<commit_message>
Add architecture-diagram slide to the presentation
</commit_message>
<xml_diff>
--- a/residency/deliverables/Deliverable 4/Group2_Project_Presentation_MSCS532.pptx
+++ b/residency/deliverables/Deliverable 4/Group2_Project_Presentation_MSCS532.pptx
@@ -24,6 +24,7 @@
     <p:sldId id="272" r:id="rId24"/>
     <p:sldId id="273" r:id="rId25"/>
     <p:sldId id="274" r:id="rId26"/>
+    <p:sldId id="275" r:id="rId27"/>
   </p:sldIdLst>
   <p:sldSz cx="12191695" cy="6858000" type="screen4x3"/>
   <p:notesSz cx="6858000" cy="9144000"/>
@@ -590,7 +591,7 @@
           <a:lstStyle/>
           <a:p>
             <a:r>
-              <a:t>The bottom row pairs cause and effect. On the left, the also-bought panel reads the co-purchase graph: the keyboard's weight of three means exactly three fulfilled orders contained mouse and keyboard together. On the right is where those weights come from — the cart enqueues orders first-in-first-out, and processing an order is a strict validate-then-commit: every line item is checked against stock before anything mutates, so a failure is atomic, and only a successful commit decrements stock, increments sales, and feeds every item pair into the graph. That causal loop — selling things makes the recommendations better — is the integration claim of the whole project, and here you can watch it happen.</a:t>
+              <a:t>The catalog table is the hash table, rendered. Every other panel on the page stores only SKU strings and resolves them through this table in constant time — that is the single-source-of-truth rule that keeps six structures consistent. The columns tell the store's story: stock falls at fulfilment and rises on returns, sold counts only fulfilled units, and the return button is enabled only while returned is less than sold — you cannot return what never sold, and you cannot return the same unit twice; the backend enforces the same cumulative cap. Click return on the keyboard and three views move at once — this table, the stock badge, and the most-returned dashboard — from one write to one record.</a:t>
             </a:r>
           </a:p>
         </p:txBody>
@@ -660,7 +661,7 @@
           <a:lstStyle/>
           <a:p>
             <a:r>
-              <a:t>All three dashboards are the same data structure asked three different questions. Each list heapifies the whole catalog bottom-up — linear time, cheaper than sorting — then pops just the top five. Low stock wants the smallest values from a max-heap, so priorities go in negated, the classic trick. And most-returned ranks the returns counters we added with the portal: a return puts the unit back in stock but never subtracts from sold, so best sellers keeps measuring demand while most-returned measures dissatisfaction — a product high on both lists is exactly what a merchandiser needs to see.</a:t>
+              <a:t>The bottom row pairs cause and effect. On the left, the also-bought panel reads the co-purchase graph: the keyboard's weight of three means exactly three fulfilled orders contained mouse and keyboard together. On the right is where those weights come from — the cart enqueues orders first-in-first-out, and processing an order is a strict validate-then-commit: every line item is checked against stock before anything mutates, so a failure is atomic, and only a successful commit decrements stock, increments sales, and feeds every item pair into the graph. That causal loop — selling things makes the recommendations better — is the integration claim of the whole project, and here you can watch it happen.</a:t>
             </a:r>
           </a:p>
         </p:txBody>
@@ -730,7 +731,7 @@
           <a:lstStyle/>
           <a:p>
             <a:r>
-              <a:t>Correctness rests on forty-two unit tests, and they aim at each structure's specific failure mode rather than the happy path. The hash table is grown through several resizes and every record re-verified. The circular buffer is drained across its wraparound boundary. The tree's range query is cross-checked against brute force on a thousand random prices, the heap against a full sort. And the integration tests verify the atomicity property: when an order fails on stock, nothing else in that order has been touched. Every module also validates inputs at the boundary, so bad data raises a typed exception before any state mutates.</a:t>
+              <a:t>All three dashboards are the same data structure asked three different questions. Each list heapifies the whole catalog bottom-up — linear time, cheaper than sorting — then pops just the top five. Low stock wants the smallest values from a max-heap, so priorities go in negated, the classic trick. And most-returned ranks the returns counters we added with the portal: a return puts the unit back in stock but never subtracts from sold, so best sellers keeps measuring demand while most-returned measures dissatisfaction — a product high on both lists is exactly what a merchandiser needs to see.</a:t>
             </a:r>
           </a:p>
         </p:txBody>
@@ -800,7 +801,7 @@
           <a:lstStyle/>
           <a:p>
             <a:r>
-              <a:t>Phase three turned to performance. The dataset generator builds catalogs from one thousand to one hundred thousand products with adjective-noun names, so the trie faces realistic shared prefixes, and an order stream with a quadratic popularity skew, so hub products emerge the way they do in real stores. Timings are best-of-five wall clock, memory is peak tracemalloc, and — this is the discipline of the whole phase — every specialized structure has to justify itself against the naive baseline a simpler system would use: a fixed-capacity table, a linear scan, a full sort.</a:t>
+              <a:t>Correctness rests on forty-two unit tests, and they aim at each structure's specific failure mode rather than the happy path. The hash table is grown through several resizes and every record re-verified. The circular buffer is drained across its wraparound boundary. The tree's range query is cross-checked against brute force on a thousand random prices, the heap against a full sort. And the integration tests verify the atomicity property: when an order fails on stock, nothing else in that order has been touched. Every module also validates inputs at the boundary, so bad data raises a typed exception before any state mutates.</a:t>
             </a:r>
           </a:p>
         </p:txBody>
@@ -870,7 +871,7 @@
           <a:lstStyle/>
           <a:p>
             <a:r>
-              <a:t>The first headline result is the catalog. With load-factor resizing — the bucket array doubles past 75 percent occupancy — lookups sit flat at about two microseconds across two orders of magnitude of catalog size. Freeze the same table at a thousand buckets and it degrades linearly to ten microseconds, with collision chains a hundred and eleven entries long. That's a five-fold penalty for skipping one optimization, and it's exactly the O of n over m arithmetic from lecture, made visible in a chart.</a:t>
+              <a:t>Phase three turned to performance. The dataset generator builds catalogs from one thousand to one hundred thousand products with adjective-noun names, so the trie faces realistic shared prefixes, and an order stream with a quadratic popularity skew, so hub products emerge the way they do in real stores. Timings are best-of-five wall clock, memory is peak tracemalloc, and — this is the discipline of the whole phase — every specialized structure has to justify itself against the naive baseline a simpler system would use: a fixed-capacity table, a linear scan, a full sort.</a:t>
             </a:r>
           </a:p>
         </p:txBody>
@@ -940,7 +941,7 @@
           <a:lstStyle/>
           <a:p>
             <a:r>
-              <a:t>Search is the largest payoff. A linear scan touches every product name on every keystroke — eighty-two milliseconds per query at full scale, which is an unusable autocomplete. The trie answers the same query in under two milliseconds, forty-five times faster, and the gap widens with catalog size because the trie's cost depends only on the prefix length and the matches, not on how big the store is. The price tree shows the same shape in milder form: the pruned in-order traversal beats scan-and-sort by nearly six times on a five-percent price band.</a:t>
+              <a:t>The first headline result is the catalog. With load-factor resizing — the bucket array doubles past 75 percent occupancy — lookups sit flat at about two microseconds across two orders of magnitude of catalog size. Freeze the same table at a thousand buckets and it degrades linearly to ten microseconds, with collision chains a hundred and eleven entries long. That's a five-fold penalty for skipping one optimization, and it's exactly the O of n over m arithmetic from lecture, made visible in a chart.</a:t>
             </a:r>
           </a:p>
         </p:txBody>
@@ -1010,7 +1011,7 @@
           <a:lstStyle/>
           <a:p>
             <a:r>
-              <a:t>And here is the result we're proudest of reporting, because it went against us. Top-ten-best-sellers from a heap is order n plus k log n — asymptotically better than fully sorting. Measured, the pure-Python heap merely ties Python's built-in sort at every size, because Timsort executes in C while every one of my sift-down comparisons executes in the interpreter. The constant factors ate the asymptotic advantage. The heap stays in the design for what the cold benchmark doesn't measure — incremental updates without re-sorting — but the lesson stands: you measure optimizations in the environment they'll run in, or the environment will measure them for you.</a:t>
+              <a:t>Search is the largest payoff. A linear scan touches every product name on every keystroke — eighty-two milliseconds per query at full scale, which is an unusable autocomplete. The trie answers the same query in under two milliseconds, forty-five times faster, and the gap widens with catalog size because the trie's cost depends only on the prefix length and the matches, not on how big the store is. The price tree shows the same shape in milder form: the pruned in-order traversal beats scan-and-sort by nearly six times on a five-percent price band.</a:t>
             </a:r>
           </a:p>
         </p:txBody>
@@ -1080,7 +1081,7 @@
           <a:lstStyle/>
           <a:p>
             <a:r>
-              <a:t>Two stress tests target the weak points the design phase wrote down. Loading the price tree with strictly increasing prices — a sorted supplier file — collapses it to a linked list: height four thousand versus twenty-five for the same prices in random order. The queries survive only because traversal is iterative; recursion would overflow Python's stack, which validates that early implementation decision. Second, replaying twenty thousand orders against a deliberately tiny catalog simulates a flash sale: nine and a half thousand orders are rejected, every rejection atomic, no line item corrupted. And end to end, the platform sustains about forty-four thousand orders per second in sixty-five megabytes.</a:t>
+              <a:t>And here is the result we're proudest of reporting, because it went against us. Top-ten-best-sellers from a heap is order n plus k log n — asymptotically better than fully sorting. Measured, the pure-Python heap merely ties Python's built-in sort at every size, because Timsort executes in C while every one of my sift-down comparisons executes in the interpreter. The constant factors ate the asymptotic advantage. The heap stays in the design for what the cold benchmark doesn't measure — incremental updates without re-sorting — but the lesson stands: you measure optimizations in the environment they'll run in, or the environment will measure them for you.</a:t>
             </a:r>
           </a:p>
         </p:txBody>
@@ -1150,7 +1151,7 @@
           <a:lstStyle/>
           <a:p>
             <a:r>
-              <a:t>Three conclusions travel beyond this project. First, composition beats generality: the speed comes from routing each workload to the right specialist behind a constant-time source of truth — the same architecture production retailers run. Second, optimizations are empirical claims: resizing repaid itself five-fold, the heap's textbook advantage did not survive the interpreter, and only measurement tells those apart. Third, worst cases documented at design time became cheap tests later — the tree collapse and the flash sale both arrived exactly as predicted. Future work is self-balancing for the price tree, edge decay for the graph, and radix compression for the trie. Everything — code, forty-two tests, benchmarks, and raw data — is in the course repository. Thank you; we're happy to take questions.</a:t>
+              <a:t>Two stress tests target the weak points the design phase wrote down. Loading the price tree with strictly increasing prices — a sorted supplier file — collapses it to a linked list: height four thousand versus twenty-five for the same prices in random order. The queries survive only because traversal is iterative; recursion would overflow Python's stack, which validates that early implementation decision. Second, replaying twenty thousand orders against a deliberately tiny catalog simulates a flash sale: nine and a half thousand orders are rejected, every rejection atomic, no line item corrupted. And end to end, the platform sustains about forty-four thousand orders per second in sixty-five megabytes.</a:t>
             </a:r>
           </a:p>
         </p:txBody>
@@ -1220,7 +1221,7 @@
           <a:lstStyle/>
           <a:p>
             <a:r>
-              <a:t>That's the project on slides — now let's show it to you running. We'll open the portal, search as we type, place and process an order, and watch a return climb the most-returned dashboard, with the metrics strip updating live. [Switch to the browser at localhost:8000; the click sequence is in the demo run sheet.]</a:t>
+              <a:t>Three conclusions travel beyond this project. First, composition beats generality: the speed comes from routing each workload to the right specialist behind a constant-time source of truth — the same architecture production retailers run. Second, optimizations are empirical claims: resizing repaid itself five-fold, the heap's textbook advantage did not survive the interpreter, and only measurement tells those apart. Third, worst cases documented at design time became cheap tests later — the tree collapse and the flash sale both arrived exactly as predicted. Future work is self-balancing for the price tree, edge decay for the graph, and radix compression for the trie. Everything — code, forty-two tests, benchmarks, and raw data — is in the course repository. Thank you; we're happy to take questions.</a:t>
             </a:r>
           </a:p>
         </p:txBody>
@@ -1315,6 +1316,76 @@
 </p:notes>
 </file>
 
+<file path=ppt/notesSlides/notesSlide20.xml><?xml version="1.0" encoding="utf-8"?>
+<p:notes xmlns:a="http://schemas.openxmlformats.org/drawingml/2006/main" xmlns:p="http://schemas.openxmlformats.org/presentationml/2006/main" xmlns:r="http://schemas.openxmlformats.org/officeDocument/2006/relationships">
+  <p:cSld>
+    <p:spTree>
+      <p:nvGrpSpPr>
+        <p:cNvPr id="1" name=""/>
+        <p:cNvGrpSpPr/>
+        <p:nvPr/>
+      </p:nvGrpSpPr>
+      <p:grpSpPr>
+        <a:xfrm>
+          <a:off x="0" y="0"/>
+          <a:ext cx="0" cy="0"/>
+          <a:chOff x="0" y="0"/>
+          <a:chExt cx="0" cy="0"/>
+        </a:xfrm>
+      </p:grpSpPr>
+      <p:sp>
+        <p:nvSpPr>
+          <p:cNvPr id="2" name="Slide Image Placeholder 1"/>
+          <p:cNvSpPr>
+            <a:spLocks noGrp="1"/>
+          </p:cNvSpPr>
+          <p:nvPr>
+            <p:ph type="sldImg" idx="2"/>
+          </p:nvPr>
+        </p:nvSpPr>
+        <p:spPr/>
+      </p:sp>
+      <p:sp>
+        <p:nvSpPr>
+          <p:cNvPr id="3" name="Notes Placeholder 2"/>
+          <p:cNvSpPr>
+            <a:spLocks noGrp="1"/>
+          </p:cNvSpPr>
+          <p:nvPr>
+            <p:ph type="body" idx="3" sz="quarter"/>
+          </p:nvPr>
+        </p:nvSpPr>
+        <p:spPr/>
+        <p:txBody>
+          <a:bodyPr/>
+          <a:lstStyle/>
+          <a:p>
+            <a:r>
+              <a:t>That's the project on slides — now let's show it to you running. We'll open the portal, search as we type, place and process an order, and watch a return climb the most-returned dashboard, with the metrics strip updating live. [Switch to the browser at localhost:8000; the click sequence is in the demo run sheet.]</a:t>
+            </a:r>
+          </a:p>
+        </p:txBody>
+      </p:sp>
+      <p:sp>
+        <p:nvSpPr>
+          <p:cNvPr id="4" name="Slide Number Placeholder 3"/>
+          <p:cNvSpPr>
+            <a:spLocks noGrp="1"/>
+          </p:cNvSpPr>
+          <p:nvPr>
+            <p:ph type="sldNum" idx="5" sz="quarter"/>
+          </p:nvPr>
+        </p:nvSpPr>
+        <p:spPr/>
+      </p:sp>
+    </p:spTree>
+  </p:cSld>
+  <p:clrMapOvr>
+    <a:masterClrMapping/>
+  </p:clrMapOvr>
+</p:notes>
+</file>
+
 <file path=ppt/notesSlides/notesSlide3.xml><?xml version="1.0" encoding="utf-8"?>
 <p:notes xmlns:a="http://schemas.openxmlformats.org/drawingml/2006/main" xmlns:p="http://schemas.openxmlformats.org/presentationml/2006/main" xmlns:r="http://schemas.openxmlformats.org/officeDocument/2006/relationships">
   <p:cSld>
@@ -1500,7 +1571,7 @@
           <a:lstStyle/>
           <a:p>
             <a:r>
-              <a:t>Phase two implemented all six structures from scratch — no dict or heapq shortcuts for the mechanics under study — and proved they cooperate with a scripted end-to-end session. What you see here is the second half of that demo. Eight orders flow through the queue, and immediately afterward the also-bought panel for the wireless mouse ranks the wireless keyboard first with weight three — because exactly three of the eight orders contained both. The dashboards reflect the decremented stock, and the last step deliberately triggers the error paths: an unknown SKU is rejected at checkout, and an order for an exhausted product fails cleanly at fulfilment.</a:t>
+              <a:t>Here is the whole system on one page. At the top, the browser — one HTML page whose JavaScript talks JSON to a single Python process over localhost. Inside that process, portal dot py is just an HTTP server; every request becomes one call on the facade, and the facade drives the six structure modules — each in its own file, each color-matched to the panel it serves in the portal you'll see shortly. All data lives in this process's memory: stop it and the state is gone, start it and it re-seeds identically. And note the bottom row — the demo script, the forty-two tests, and the benchmark suite are separate processes driving the same facade and the same classes, which is why proving correctness and measuring performance never interferes with the running store.</a:t>
             </a:r>
           </a:p>
         </p:txBody>
@@ -1570,7 +1641,7 @@
           <a:lstStyle/>
           <a:p>
             <a:r>
-              <a:t>The proof of concept also runs live in the browser. A single-file portal — standard-library HTTP server, still zero dependencies — serves this storefront, and every panel is answered by exactly one structure and painted in its color: the search box walks the trie on every keystroke, the price filter is a pruned tree traversal, the catalog table is the hash table itself, the also-bought panel reads the co-purchase graph, the cart drains through the FIFO queue, and the three dashboards at the bottom — best sellers, low stock, and most returned — are one max-heap asked three different questions. The portal also adds a returns workflow: an accepted return restocks the catalog, cumulative returns are capped at units sold, and the most-returned dashboard keeps dissatisfaction visible next to demand. In the live demo we will place an order, watch the pending counter drain, and watch a return climb that dashboard.</a:t>
+              <a:t>Phase two implemented all six structures from scratch — no dict or heapq shortcuts for the mechanics under study — and proved they cooperate with a scripted end-to-end session. What you see here is the second half of that demo. Eight orders flow through the queue, and immediately afterward the also-bought panel for the wireless mouse ranks the wireless keyboard first with weight three — because exactly three of the eight orders contained both. The dashboards reflect the decremented stock, and the last step deliberately triggers the error paths: an unknown SKU is rejected at checkout, and an order for an exhausted product fails cleanly at fulfilment.</a:t>
             </a:r>
           </a:p>
         </p:txBody>
@@ -1640,7 +1711,7 @@
           <a:lstStyle/>
           <a:p>
             <a:r>
-              <a:t>The strip across the top of the portal is the structures' vital signs, read live at every refresh. The load factor is fifteen records over sixty-four buckets — point two three — and the table doubles its buckets past point seven five, which is exactly what keeps lookups constant-time. Max chain one means every SKU sits alone in its bucket; freeze the resizing at benchmark scale and that number climbs to a hundred and eleven. The tree height of five is near the balanced ideal of four for fifteen prices — had prices arrived sorted it would be fifteen, a linked list. These three numbers decide whether our complexity claims actually hold, so the portal keeps them visible while you shop.</a:t>
+              <a:t>The proof of concept also runs live in the browser. A single-file portal — standard-library HTTP server, still zero dependencies — serves this storefront, and every panel is answered by exactly one structure and painted in its color: the search box walks the trie on every keystroke, the price filter is a pruned tree traversal, the catalog table is the hash table itself, the also-bought panel reads the co-purchase graph, the cart drains through the FIFO queue, and the three dashboards at the bottom — best sellers, low stock, and most returned — are one max-heap asked three different questions. The portal also adds a returns workflow: an accepted return restocks the catalog, cumulative returns are capped at units sold, and the most-returned dashboard keeps dissatisfaction visible next to demand. In the live demo we will place an order, watch the pending counter drain, and watch a return climb that dashboard.</a:t>
             </a:r>
           </a:p>
         </p:txBody>
@@ -1710,7 +1781,7 @@
           <a:lstStyle/>
           <a:p>
             <a:r>
-              <a:t>Here are the two query panels doing real work. The search box fires on every keystroke, and each query is one walk down the prefix tree, so its cost depends on the length of what you typed, never on how big the store is. The screenshot shows the interesting case: wireless-space-k-e-y is two walks whose results are intersected, so only the Wireless Keyboard survives both word filters. Next to it, the price filter answers fifteen-to-fifty dollars with a pruned in-order traversal — subtrees that cannot intersect the band are never visited — and because in-order visits prices in ascending order, the results come back sorted for free.</a:t>
+              <a:t>The strip across the top of the portal is the structures' vital signs, read live at every refresh. The load factor is fifteen records over sixty-four buckets — point two three — and the table doubles its buckets past point seven five, which is exactly what keeps lookups constant-time. Max chain one means every SKU sits alone in its bucket; freeze the resizing at benchmark scale and that number climbs to a hundred and eleven. The tree height of five is near the balanced ideal of four for fifteen prices — had prices arrived sorted it would be fifteen, a linked list. These three numbers decide whether our complexity claims actually hold, so the portal keeps them visible while you shop.</a:t>
             </a:r>
           </a:p>
         </p:txBody>
@@ -1780,7 +1851,7 @@
           <a:lstStyle/>
           <a:p>
             <a:r>
-              <a:t>The catalog table is the hash table, rendered. Every other panel on the page stores only SKU strings and resolves them through this table in constant time — that is the single-source-of-truth rule that keeps six structures consistent. The columns tell the store's story: stock falls at fulfilment and rises on returns, sold counts only fulfilled units, and the return button is enabled only while returned is less than sold — you cannot return what never sold, and you cannot return the same unit twice; the backend enforces the same cumulative cap. Click return on the keyboard and three views move at once — this table, the stock badge, and the most-returned dashboard — from one write to one record.</a:t>
+              <a:t>Here are the two query panels doing real work. The search box fires on every keystroke, and each query is one walk down the prefix tree, so its cost depends on the length of what you typed, never on how big the store is. The screenshot shows the interesting case: wireless-space-k-e-y is two walks whose results are intersected, so only the Wireless Keyboard survives both word filters. Next to it, the price filter answers fifteen-to-fifty dollars with a pruned in-order traversal — subtrees that cannot intersect the band are never visited — and because in-order visits prices in ascending order, the results come back sorted for free.</a:t>
             </a:r>
           </a:p>
         </p:txBody>
@@ -5487,7 +5558,7 @@
           <a:lstStyle/>
           <a:p>
             <a:pPr algn="l">
-              <a:defRPr sz="2600" b="1">
+              <a:defRPr sz="2900" b="1">
                 <a:solidFill>
                   <a:srgbClr val="1F2A44"/>
                 </a:solidFill>
@@ -5495,7 +5566,7 @@
               </a:defRPr>
             </a:pPr>
             <a:r>
-              <a:t>Recommendations Read the Graph; the Cart Drains the Queue</a:t>
+              <a:t>The Catalog Panel Is the Hash Table</a:t>
             </a:r>
           </a:p>
         </p:txBody>
@@ -5808,45 +5879,16 @@
           </a:p>
         </p:txBody>
       </p:sp>
-      <p:pic>
-        <p:nvPicPr>
-          <p:cNvPr id="11" name="Picture 10" descr="panel_graph_cart.png"/>
-          <p:cNvPicPr>
-            <a:picLocks noChangeAspect="1"/>
-          </p:cNvPicPr>
-          <p:nvPr/>
-        </p:nvPicPr>
-        <p:blipFill>
-          <a:blip r:embed="rId2"/>
-          <a:stretch>
-            <a:fillRect/>
-          </a:stretch>
-        </p:blipFill>
-        <p:spPr>
-          <a:xfrm>
-            <a:off x="563727" y="1417320"/>
-            <a:ext cx="11064240" cy="1764556"/>
-          </a:xfrm>
-          <a:prstGeom prst="rect">
-            <a:avLst/>
-          </a:prstGeom>
-          <a:ln w="12700">
-            <a:solidFill>
-              <a:srgbClr val="DCE0E8"/>
-            </a:solidFill>
-          </a:ln>
-        </p:spPr>
-      </p:pic>
-      <p:sp>
-        <p:nvSpPr>
-          <p:cNvPr id="12" name="TextBox 11"/>
+      <p:sp>
+        <p:nvSpPr>
+          <p:cNvPr id="11" name="TextBox 10"/>
           <p:cNvSpPr txBox="1"/>
           <p:nvPr/>
         </p:nvSpPr>
         <p:spPr>
           <a:xfrm>
-            <a:off x="822960" y="3364756"/>
-            <a:ext cx="10515600" cy="2990324"/>
+            <a:off x="548640" y="1463040"/>
+            <a:ext cx="5577840" cy="4846320"/>
           </a:xfrm>
           <a:prstGeom prst="rect">
             <a:avLst/>
@@ -5854,7 +5896,7 @@
           <a:noFill/>
         </p:spPr>
         <p:txBody>
-          <a:bodyPr wrap="square">
+          <a:bodyPr wrap="square" anchor="ctr">
             <a:spAutoFit/>
           </a:bodyPr>
           <a:lstStyle/>
@@ -5864,7 +5906,7 @@
                 <a:spcPct val="104000"/>
               </a:lnSpc>
               <a:spcAft>
-                <a:spcPts val="700"/>
+                <a:spcPts val="1200"/>
               </a:spcAft>
               <a:buClr>
                 <a:srgbClr val="2C7BB6"/>
@@ -5874,13 +5916,13 @@
               <a:buChar char="▪"/>
             </a:pPr>
             <a:r>
-              <a:rPr sz="1800">
+              <a:rPr sz="2000">
                 <a:solidFill>
                   <a:srgbClr val="3A3F4A"/>
                 </a:solidFill>
                 <a:latin typeface="Calibri"/>
               </a:rPr>
-              <a:t>×3 = mouse + keyboard appeared together in three fulfilled orders — weights are order counts</a:t>
+              <a:t>Single source of truth — every other panel resolves SKUs here in O(1)</a:t>
             </a:r>
           </a:p>
           <a:p>
@@ -5889,7 +5931,7 @@
                 <a:spcPct val="104000"/>
               </a:lnSpc>
               <a:spcAft>
-                <a:spcPts val="700"/>
+                <a:spcPts val="1200"/>
               </a:spcAft>
               <a:buClr>
                 <a:srgbClr val="2C7BB6"/>
@@ -5899,13 +5941,13 @@
               <a:buChar char="▪"/>
             </a:pPr>
             <a:r>
-              <a:rPr sz="1800">
+              <a:rPr sz="2000">
                 <a:solidFill>
                   <a:srgbClr val="3A3F4A"/>
                 </a:solidFill>
                 <a:latin typeface="Calibri"/>
               </a:rPr>
-              <a:t>Fulfilment adds or strengthens edges → commerce improves the recommendations, immediately</a:t>
+              <a:t>FNV-1a hash → bucket → short chain scan</a:t>
             </a:r>
           </a:p>
           <a:p>
@@ -5914,7 +5956,7 @@
                 <a:spcPct val="104000"/>
               </a:lnSpc>
               <a:spcAft>
-                <a:spcPts val="700"/>
+                <a:spcPts val="1200"/>
               </a:spcAft>
               <a:buClr>
                 <a:srgbClr val="2C7BB6"/>
@@ -5924,13 +5966,13 @@
               <a:buChar char="▪"/>
             </a:pPr>
             <a:r>
-              <a:rPr sz="1800">
+              <a:rPr sz="2000">
                 <a:solidFill>
                   <a:srgbClr val="3A3F4A"/>
                 </a:solidFill>
                 <a:latin typeface="Calibri"/>
               </a:rPr>
-              <a:t>Checkout validates and enqueues (FIFO) — stock is untouched until fulfilment</a:t>
+              <a:t>⚠ low badge at ≤ 5 units — the same signal the low-stock dashboard ranks</a:t>
             </a:r>
           </a:p>
           <a:p>
@@ -5939,7 +5981,7 @@
                 <a:spcPct val="104000"/>
               </a:lnSpc>
               <a:spcAft>
-                <a:spcPts val="700"/>
+                <a:spcPts val="1200"/>
               </a:spcAft>
               <a:buClr>
                 <a:srgbClr val="2C7BB6"/>
@@ -5949,17 +5991,71 @@
               <a:buChar char="▪"/>
             </a:pPr>
             <a:r>
-              <a:rPr sz="1800">
+              <a:rPr sz="2000">
                 <a:solidFill>
                   <a:srgbClr val="3A3F4A"/>
                 </a:solidFill>
                 <a:latin typeface="Calibri"/>
               </a:rPr>
-              <a:t>Fulfilment validates every line item, then commits atomically — a failed order changes nothing</a:t>
-            </a:r>
-          </a:p>
-        </p:txBody>
-      </p:sp>
+              <a:t>Return enabled only while Returned &lt; Sold — the cumulative cap</a:t>
+            </a:r>
+          </a:p>
+          <a:p>
+            <a:pPr algn="l" marL="256032" indent="-256032">
+              <a:lnSpc>
+                <a:spcPct val="104000"/>
+              </a:lnSpc>
+              <a:spcAft>
+                <a:spcPts val="1200"/>
+              </a:spcAft>
+              <a:buClr>
+                <a:srgbClr val="2C7BB6"/>
+              </a:buClr>
+              <a:buSzPct val="82000"/>
+              <a:buFont typeface="Arial"/>
+              <a:buChar char="▪"/>
+            </a:pPr>
+            <a:r>
+              <a:rPr sz="2000">
+                <a:solidFill>
+                  <a:srgbClr val="3A3F4A"/>
+                </a:solidFill>
+                <a:latin typeface="Calibri"/>
+              </a:rPr>
+              <a:t>One write updates every view — indexes can never disagree</a:t>
+            </a:r>
+          </a:p>
+        </p:txBody>
+      </p:sp>
+      <p:pic>
+        <p:nvPicPr>
+          <p:cNvPr id="12" name="Picture 11" descr="panel_catalog.png"/>
+          <p:cNvPicPr>
+            <a:picLocks noChangeAspect="1"/>
+          </p:cNvPicPr>
+          <p:nvPr/>
+        </p:nvPicPr>
+        <p:blipFill>
+          <a:blip r:embed="rId2"/>
+          <a:stretch>
+            <a:fillRect/>
+          </a:stretch>
+        </p:blipFill>
+        <p:spPr>
+          <a:xfrm>
+            <a:off x="6309360" y="2291715"/>
+            <a:ext cx="5669280" cy="3188970"/>
+          </a:xfrm>
+          <a:prstGeom prst="rect">
+            <a:avLst/>
+          </a:prstGeom>
+          <a:ln w="12700">
+            <a:solidFill>
+              <a:srgbClr val="DCE0E8"/>
+            </a:solidFill>
+          </a:ln>
+        </p:spPr>
+      </p:pic>
       <p:sp>
         <p:nvSpPr>
           <p:cNvPr id="13" name="Rectangle 12"/>
@@ -6160,7 +6256,7 @@
           <a:lstStyle/>
           <a:p>
             <a:pPr algn="l">
-              <a:defRPr sz="2900" b="1">
+              <a:defRPr sz="2600" b="1">
                 <a:solidFill>
                   <a:srgbClr val="1F2A44"/>
                 </a:solidFill>
@@ -6168,7 +6264,7 @@
               </a:defRPr>
             </a:pPr>
             <a:r>
-              <a:t>Three Dashboards, One Max-Heap</a:t>
+              <a:t>Recommendations Read the Graph; the Cart Drains the Queue</a:t>
             </a:r>
           </a:p>
         </p:txBody>
@@ -6483,7 +6579,7 @@
       </p:sp>
       <p:pic>
         <p:nvPicPr>
-          <p:cNvPr id="11" name="Picture 10" descr="panel_dashboards.png"/>
+          <p:cNvPr id="11" name="Picture 10" descr="panel_graph_cart.png"/>
           <p:cNvPicPr>
             <a:picLocks noChangeAspect="1"/>
           </p:cNvPicPr>
@@ -6497,8 +6593,8 @@
         </p:blipFill>
         <p:spPr>
           <a:xfrm>
-            <a:off x="1432407" y="1417320"/>
-            <a:ext cx="9326880" cy="2733741"/>
+            <a:off x="563727" y="1417320"/>
+            <a:ext cx="11064240" cy="1764556"/>
           </a:xfrm>
           <a:prstGeom prst="rect">
             <a:avLst/>
@@ -6518,8 +6614,8 @@
         </p:nvSpPr>
         <p:spPr>
           <a:xfrm>
-            <a:off x="822960" y="4333941"/>
-            <a:ext cx="10515600" cy="2021139"/>
+            <a:off x="822960" y="3364756"/>
+            <a:ext cx="10515600" cy="2990324"/>
           </a:xfrm>
           <a:prstGeom prst="rect">
             <a:avLst/>
@@ -6553,7 +6649,7 @@
                 </a:solidFill>
                 <a:latin typeface="Calibri"/>
               </a:rPr>
-              <a:t>O(n) bottom-up heapify over the catalog, then k pops — O(n + k log n) per dashboard</a:t>
+              <a:t>×3 = mouse + keyboard appeared together in three fulfilled orders — weights are order counts</a:t>
             </a:r>
           </a:p>
           <a:p>
@@ -6578,7 +6674,7 @@
                 </a:solidFill>
                 <a:latin typeface="Calibri"/>
               </a:rPr>
-              <a:t>Low stock: priorities pushed negated — the classic min-heap trick</a:t>
+              <a:t>Fulfilment adds or strengthens edges → commerce improves the recommendations, immediately</a:t>
             </a:r>
           </a:p>
           <a:p>
@@ -6603,7 +6699,32 @@
                 </a:solidFill>
                 <a:latin typeface="Calibri"/>
               </a:rPr>
-              <a:t>Most returned tracks dissatisfaction, Sold tracks demand — kept as separate signals</a:t>
+              <a:t>Checkout validates and enqueues (FIFO) — stock is untouched until fulfilment</a:t>
+            </a:r>
+          </a:p>
+          <a:p>
+            <a:pPr algn="l" marL="256032" indent="-256032">
+              <a:lnSpc>
+                <a:spcPct val="104000"/>
+              </a:lnSpc>
+              <a:spcAft>
+                <a:spcPts val="700"/>
+              </a:spcAft>
+              <a:buClr>
+                <a:srgbClr val="2C7BB6"/>
+              </a:buClr>
+              <a:buSzPct val="82000"/>
+              <a:buFont typeface="Arial"/>
+              <a:buChar char="▪"/>
+            </a:pPr>
+            <a:r>
+              <a:rPr sz="1800">
+                <a:solidFill>
+                  <a:srgbClr val="3A3F4A"/>
+                </a:solidFill>
+                <a:latin typeface="Calibri"/>
+              </a:rPr>
+              <a:t>Fulfilment validates every line item, then commits atomically — a failed order changes nothing</a:t>
             </a:r>
           </a:p>
         </p:txBody>
@@ -6780,7 +6901,7 @@
                 </a:solidFill>
                 <a:latin typeface="Calibri"/>
               </a:rPr>
-              <a:t>05 · TESTING</a:t>
+              <a:t>04 · LIVE PORTAL</a:t>
             </a:r>
           </a:p>
         </p:txBody>
@@ -6816,7 +6937,7 @@
               </a:defRPr>
             </a:pPr>
             <a:r>
-              <a:t>Correctness: 42 Tests Aimed at the Failure Modes</a:t>
+              <a:t>Three Dashboards, One Max-Heap</a:t>
             </a:r>
           </a:p>
         </p:txBody>
@@ -7129,16 +7250,45 @@
           </a:p>
         </p:txBody>
       </p:sp>
-      <p:sp>
-        <p:nvSpPr>
-          <p:cNvPr id="11" name="TextBox 10"/>
+      <p:pic>
+        <p:nvPicPr>
+          <p:cNvPr id="11" name="Picture 10" descr="panel_dashboards.png"/>
+          <p:cNvPicPr>
+            <a:picLocks noChangeAspect="1"/>
+          </p:cNvPicPr>
+          <p:nvPr/>
+        </p:nvPicPr>
+        <p:blipFill>
+          <a:blip r:embed="rId2"/>
+          <a:stretch>
+            <a:fillRect/>
+          </a:stretch>
+        </p:blipFill>
+        <p:spPr>
+          <a:xfrm>
+            <a:off x="1432407" y="1417320"/>
+            <a:ext cx="9326880" cy="2733741"/>
+          </a:xfrm>
+          <a:prstGeom prst="rect">
+            <a:avLst/>
+          </a:prstGeom>
+          <a:ln w="12700">
+            <a:solidFill>
+              <a:srgbClr val="DCE0E8"/>
+            </a:solidFill>
+          </a:ln>
+        </p:spPr>
+      </p:pic>
+      <p:sp>
+        <p:nvSpPr>
+          <p:cNvPr id="12" name="TextBox 11"/>
           <p:cNvSpPr txBox="1"/>
           <p:nvPr/>
         </p:nvSpPr>
         <p:spPr>
           <a:xfrm>
-            <a:off x="548640" y="1463040"/>
-            <a:ext cx="5577840" cy="4846320"/>
+            <a:off x="822960" y="4333941"/>
+            <a:ext cx="10515600" cy="2021139"/>
           </a:xfrm>
           <a:prstGeom prst="rect">
             <a:avLst/>
@@ -7146,7 +7296,7 @@
           <a:noFill/>
         </p:spPr>
         <p:txBody>
-          <a:bodyPr wrap="square" anchor="ctr">
+          <a:bodyPr wrap="square">
             <a:spAutoFit/>
           </a:bodyPr>
           <a:lstStyle/>
@@ -7156,7 +7306,7 @@
                 <a:spcPct val="104000"/>
               </a:lnSpc>
               <a:spcAft>
-                <a:spcPts val="800"/>
+                <a:spcPts val="700"/>
               </a:spcAft>
               <a:buClr>
                 <a:srgbClr val="2C7BB6"/>
@@ -7166,13 +7316,13 @@
               <a:buChar char="▪"/>
             </a:pPr>
             <a:r>
-              <a:rPr sz="1700">
+              <a:rPr sz="1800">
                 <a:solidFill>
                   <a:srgbClr val="3A3F4A"/>
                 </a:solidFill>
                 <a:latin typeface="Calibri"/>
               </a:rPr>
-              <a:t>Hash table filled through multiple resizes, re-verified</a:t>
+              <a:t>O(n) bottom-up heapify over the catalog, then k pops — O(n + k log n) per dashboard</a:t>
             </a:r>
           </a:p>
           <a:p>
@@ -7181,7 +7331,7 @@
                 <a:spcPct val="104000"/>
               </a:lnSpc>
               <a:spcAft>
-                <a:spcPts val="800"/>
+                <a:spcPts val="700"/>
               </a:spcAft>
               <a:buClr>
                 <a:srgbClr val="2C7BB6"/>
@@ -7191,13 +7341,13 @@
               <a:buChar char="▪"/>
             </a:pPr>
             <a:r>
-              <a:rPr sz="1700">
+              <a:rPr sz="1800">
                 <a:solidFill>
                   <a:srgbClr val="3A3F4A"/>
                 </a:solidFill>
                 <a:latin typeface="Calibri"/>
               </a:rPr>
-              <a:t>Queue drained across the circular wraparound boundary</a:t>
+              <a:t>Low stock: priorities pushed negated — the classic min-heap trick</a:t>
             </a:r>
           </a:p>
           <a:p>
@@ -7206,7 +7356,7 @@
                 <a:spcPct val="104000"/>
               </a:lnSpc>
               <a:spcAft>
-                <a:spcPts val="800"/>
+                <a:spcPts val="700"/>
               </a:spcAft>
               <a:buClr>
                 <a:srgbClr val="2C7BB6"/>
@@ -7216,146 +7366,17 @@
               <a:buChar char="▪"/>
             </a:pPr>
             <a:r>
-              <a:rPr sz="1700">
+              <a:rPr sz="1800">
                 <a:solidFill>
                   <a:srgbClr val="3A3F4A"/>
                 </a:solidFill>
                 <a:latin typeface="Calibri"/>
               </a:rPr>
-              <a:t>BST range query cross-checked vs brute force (1,000 prices)</a:t>
-            </a:r>
-          </a:p>
-          <a:p>
-            <a:pPr algn="l" marL="256032" indent="-256032">
-              <a:lnSpc>
-                <a:spcPct val="104000"/>
-              </a:lnSpc>
-              <a:spcAft>
-                <a:spcPts val="800"/>
-              </a:spcAft>
-              <a:buClr>
-                <a:srgbClr val="2C7BB6"/>
-              </a:buClr>
-              <a:buSzPct val="82000"/>
-              <a:buFont typeface="Arial"/>
-              <a:buChar char="▪"/>
-            </a:pPr>
-            <a:r>
-              <a:rPr sz="1700">
-                <a:solidFill>
-                  <a:srgbClr val="3A3F4A"/>
-                </a:solidFill>
-                <a:latin typeface="Calibri"/>
-              </a:rPr>
-              <a:t>Heap top-25 vs full sort (2,000 random entries)</a:t>
-            </a:r>
-          </a:p>
-          <a:p>
-            <a:pPr algn="l" marL="256032" indent="-256032">
-              <a:lnSpc>
-                <a:spcPct val="104000"/>
-              </a:lnSpc>
-              <a:spcAft>
-                <a:spcPts val="800"/>
-              </a:spcAft>
-              <a:buClr>
-                <a:srgbClr val="2C7BB6"/>
-              </a:buClr>
-              <a:buSzPct val="82000"/>
-              <a:buFont typeface="Arial"/>
-              <a:buChar char="▪"/>
-            </a:pPr>
-            <a:r>
-              <a:rPr sz="1700">
-                <a:solidFill>
-                  <a:srgbClr val="3A3F4A"/>
-                </a:solidFill>
-                <a:latin typeface="Calibri"/>
-              </a:rPr>
-              <a:t>Failed order commits nothing — atomicity test</a:t>
-            </a:r>
-          </a:p>
-          <a:p>
-            <a:pPr algn="l" marL="256032" indent="-256032">
-              <a:lnSpc>
-                <a:spcPct val="104000"/>
-              </a:lnSpc>
-              <a:spcAft>
-                <a:spcPts val="800"/>
-              </a:spcAft>
-              <a:buClr>
-                <a:srgbClr val="2C7BB6"/>
-              </a:buClr>
-              <a:buSzPct val="82000"/>
-              <a:buFont typeface="Arial"/>
-              <a:buChar char="▪"/>
-            </a:pPr>
-            <a:r>
-              <a:rPr sz="1700">
-                <a:solidFill>
-                  <a:srgbClr val="3A3F4A"/>
-                </a:solidFill>
-                <a:latin typeface="Calibri"/>
-              </a:rPr>
-              <a:t>Returns capped cumulatively — never exceed units sold</a:t>
-            </a:r>
-          </a:p>
-          <a:p>
-            <a:pPr algn="l" marL="256032" indent="-256032">
-              <a:lnSpc>
-                <a:spcPct val="104000"/>
-              </a:lnSpc>
-              <a:spcAft>
-                <a:spcPts val="800"/>
-              </a:spcAft>
-              <a:buClr>
-                <a:srgbClr val="2C7BB6"/>
-              </a:buClr>
-              <a:buSzPct val="82000"/>
-              <a:buFont typeface="Arial"/>
-              <a:buChar char="▪"/>
-            </a:pPr>
-            <a:r>
-              <a:rPr sz="1700">
-                <a:solidFill>
-                  <a:srgbClr val="3A3F4A"/>
-                </a:solidFill>
-                <a:latin typeface="Calibri"/>
-              </a:rPr>
-              <a:t>Input validation at every boundary (typed exceptions)</a:t>
-            </a:r>
-          </a:p>
-        </p:txBody>
-      </p:sp>
-      <p:pic>
-        <p:nvPicPr>
-          <p:cNvPr id="12" name="Picture 11" descr="screenshot_tests.png"/>
-          <p:cNvPicPr>
-            <a:picLocks noChangeAspect="1"/>
-          </p:cNvPicPr>
-          <p:nvPr/>
-        </p:nvPicPr>
-        <p:blipFill>
-          <a:blip r:embed="rId2"/>
-          <a:stretch>
-            <a:fillRect/>
-          </a:stretch>
-        </p:blipFill>
-        <p:spPr>
-          <a:xfrm>
-            <a:off x="6309360" y="3167651"/>
-            <a:ext cx="5669280" cy="1437097"/>
-          </a:xfrm>
-          <a:prstGeom prst="rect">
-            <a:avLst/>
-          </a:prstGeom>
-          <a:ln w="12700">
-            <a:solidFill>
-              <a:srgbClr val="DCE0E8"/>
-            </a:solidFill>
-          </a:ln>
-        </p:spPr>
-      </p:pic>
+              <a:t>Most returned tracks dissatisfaction, Sold tracks demand — kept as separate signals</a:t>
+            </a:r>
+          </a:p>
+        </p:txBody>
+      </p:sp>
       <p:sp>
         <p:nvSpPr>
           <p:cNvPr id="13" name="Rectangle 12"/>
@@ -7528,7 +7549,7 @@
                 </a:solidFill>
                 <a:latin typeface="Calibri"/>
               </a:rPr>
-              <a:t>06 · BENCHMARKS</a:t>
+              <a:t>05 · TESTING</a:t>
             </a:r>
           </a:p>
         </p:txBody>
@@ -7564,7 +7585,7 @@
               </a:defRPr>
             </a:pPr>
             <a:r>
-              <a:t>Phase 3: Scaling Method</a:t>
+              <a:t>Correctness: 42 Tests Aimed at the Failure Modes</a:t>
             </a:r>
           </a:p>
         </p:txBody>
@@ -7886,7 +7907,7 @@
         <p:spPr>
           <a:xfrm>
             <a:off x="548640" y="1463040"/>
-            <a:ext cx="11064240" cy="4846320"/>
+            <a:ext cx="5577840" cy="4846320"/>
           </a:xfrm>
           <a:prstGeom prst="rect">
             <a:avLst/>
@@ -7904,7 +7925,7 @@
                 <a:spcPct val="104000"/>
               </a:lnSpc>
               <a:spcAft>
-                <a:spcPts val="1200"/>
+                <a:spcPts val="800"/>
               </a:spcAft>
               <a:buClr>
                 <a:srgbClr val="2C7BB6"/>
@@ -7914,72 +7935,22 @@
               <a:buChar char="▪"/>
             </a:pPr>
             <a:r>
-              <a:rPr sz="2000">
+              <a:rPr sz="1700">
                 <a:solidFill>
                   <a:srgbClr val="3A3F4A"/>
                 </a:solidFill>
                 <a:latin typeface="Calibri"/>
               </a:rPr>
-              <a:t>Catalogs of 1k → 100k products, 20k-order streams</a:t>
-            </a:r>
-          </a:p>
-          <a:p>
-            <a:pPr algn="l" marL="530352" indent="-182880">
+              <a:t>Hash table filled through multiple resizes, re-verified</a:t>
+            </a:r>
+          </a:p>
+          <a:p>
+            <a:pPr algn="l" marL="256032" indent="-256032">
               <a:lnSpc>
                 <a:spcPct val="104000"/>
               </a:lnSpc>
               <a:spcAft>
                 <a:spcPts val="800"/>
-              </a:spcAft>
-              <a:buClr>
-                <a:srgbClr val="8A8984"/>
-              </a:buClr>
-              <a:buSzPct val="82000"/>
-              <a:buFont typeface="Calibri"/>
-              <a:buChar char="–"/>
-            </a:pPr>
-            <a:r>
-              <a:rPr sz="1700">
-                <a:solidFill>
-                  <a:srgbClr val="3A3F4A"/>
-                </a:solidFill>
-                <a:latin typeface="Calibri"/>
-              </a:rPr>
-              <a:t>Realistic names (shared prefixes) — the trie earns nothing from random strings</a:t>
-            </a:r>
-          </a:p>
-          <a:p>
-            <a:pPr algn="l" marL="530352" indent="-182880">
-              <a:lnSpc>
-                <a:spcPct val="104000"/>
-              </a:lnSpc>
-              <a:spcAft>
-                <a:spcPts val="800"/>
-              </a:spcAft>
-              <a:buClr>
-                <a:srgbClr val="8A8984"/>
-              </a:buClr>
-              <a:buSzPct val="82000"/>
-              <a:buFont typeface="Calibri"/>
-              <a:buChar char="–"/>
-            </a:pPr>
-            <a:r>
-              <a:rPr sz="1700">
-                <a:solidFill>
-                  <a:srgbClr val="3A3F4A"/>
-                </a:solidFill>
-                <a:latin typeface="Calibri"/>
-              </a:rPr>
-              <a:t>Quadratic popularity skew — hub products emerge, like real stores</a:t>
-            </a:r>
-          </a:p>
-          <a:p>
-            <a:pPr algn="l" marL="256032" indent="-256032">
-              <a:lnSpc>
-                <a:spcPct val="104000"/>
-              </a:lnSpc>
-              <a:spcAft>
-                <a:spcPts val="1200"/>
               </a:spcAft>
               <a:buClr>
                 <a:srgbClr val="2C7BB6"/>
@@ -7989,13 +7960,13 @@
               <a:buChar char="▪"/>
             </a:pPr>
             <a:r>
-              <a:rPr sz="2000">
+              <a:rPr sz="1700">
                 <a:solidFill>
                   <a:srgbClr val="3A3F4A"/>
                 </a:solidFill>
                 <a:latin typeface="Calibri"/>
               </a:rPr>
-              <a:t>Best-of-5 timings (perf_counter), peak memory (tracemalloc)</a:t>
+              <a:t>Queue drained across the circular wraparound boundary</a:t>
             </a:r>
           </a:p>
           <a:p>
@@ -8004,7 +7975,7 @@
                 <a:spcPct val="104000"/>
               </a:lnSpc>
               <a:spcAft>
-                <a:spcPts val="1200"/>
+                <a:spcPts val="800"/>
               </a:spcAft>
               <a:buClr>
                 <a:srgbClr val="2C7BB6"/>
@@ -8014,17 +7985,17 @@
               <a:buChar char="▪"/>
             </a:pPr>
             <a:r>
-              <a:rPr sz="2000">
+              <a:rPr sz="1700">
                 <a:solidFill>
                   <a:srgbClr val="3A3F4A"/>
                 </a:solidFill>
                 <a:latin typeface="Calibri"/>
               </a:rPr>
-              <a:t>Every structure measured against a naive baseline</a:t>
-            </a:r>
-          </a:p>
-          <a:p>
-            <a:pPr algn="l" marL="530352" indent="-182880">
+              <a:t>BST range query cross-checked vs brute force (1,000 prices)</a:t>
+            </a:r>
+          </a:p>
+          <a:p>
+            <a:pPr algn="l" marL="256032" indent="-256032">
               <a:lnSpc>
                 <a:spcPct val="104000"/>
               </a:lnSpc>
@@ -8032,11 +8003,11 @@
                 <a:spcPts val="800"/>
               </a:spcAft>
               <a:buClr>
-                <a:srgbClr val="8A8984"/>
+                <a:srgbClr val="2C7BB6"/>
               </a:buClr>
               <a:buSzPct val="82000"/>
-              <a:buFont typeface="Calibri"/>
-              <a:buChar char="–"/>
+              <a:buFont typeface="Arial"/>
+              <a:buChar char="▪"/>
             </a:pPr>
             <a:r>
               <a:rPr sz="1700">
@@ -8045,14 +8016,118 @@
                 </a:solidFill>
                 <a:latin typeface="Calibri"/>
               </a:rPr>
-              <a:t>fixed-capacity hashing, linear scans, full sorts</a:t>
-            </a:r>
-          </a:p>
-        </p:txBody>
-      </p:sp>
-      <p:sp>
-        <p:nvSpPr>
-          <p:cNvPr id="12" name="Rectangle 11"/>
+              <a:t>Heap top-25 vs full sort (2,000 random entries)</a:t>
+            </a:r>
+          </a:p>
+          <a:p>
+            <a:pPr algn="l" marL="256032" indent="-256032">
+              <a:lnSpc>
+                <a:spcPct val="104000"/>
+              </a:lnSpc>
+              <a:spcAft>
+                <a:spcPts val="800"/>
+              </a:spcAft>
+              <a:buClr>
+                <a:srgbClr val="2C7BB6"/>
+              </a:buClr>
+              <a:buSzPct val="82000"/>
+              <a:buFont typeface="Arial"/>
+              <a:buChar char="▪"/>
+            </a:pPr>
+            <a:r>
+              <a:rPr sz="1700">
+                <a:solidFill>
+                  <a:srgbClr val="3A3F4A"/>
+                </a:solidFill>
+                <a:latin typeface="Calibri"/>
+              </a:rPr>
+              <a:t>Failed order commits nothing — atomicity test</a:t>
+            </a:r>
+          </a:p>
+          <a:p>
+            <a:pPr algn="l" marL="256032" indent="-256032">
+              <a:lnSpc>
+                <a:spcPct val="104000"/>
+              </a:lnSpc>
+              <a:spcAft>
+                <a:spcPts val="800"/>
+              </a:spcAft>
+              <a:buClr>
+                <a:srgbClr val="2C7BB6"/>
+              </a:buClr>
+              <a:buSzPct val="82000"/>
+              <a:buFont typeface="Arial"/>
+              <a:buChar char="▪"/>
+            </a:pPr>
+            <a:r>
+              <a:rPr sz="1700">
+                <a:solidFill>
+                  <a:srgbClr val="3A3F4A"/>
+                </a:solidFill>
+                <a:latin typeface="Calibri"/>
+              </a:rPr>
+              <a:t>Returns capped cumulatively — never exceed units sold</a:t>
+            </a:r>
+          </a:p>
+          <a:p>
+            <a:pPr algn="l" marL="256032" indent="-256032">
+              <a:lnSpc>
+                <a:spcPct val="104000"/>
+              </a:lnSpc>
+              <a:spcAft>
+                <a:spcPts val="800"/>
+              </a:spcAft>
+              <a:buClr>
+                <a:srgbClr val="2C7BB6"/>
+              </a:buClr>
+              <a:buSzPct val="82000"/>
+              <a:buFont typeface="Arial"/>
+              <a:buChar char="▪"/>
+            </a:pPr>
+            <a:r>
+              <a:rPr sz="1700">
+                <a:solidFill>
+                  <a:srgbClr val="3A3F4A"/>
+                </a:solidFill>
+                <a:latin typeface="Calibri"/>
+              </a:rPr>
+              <a:t>Input validation at every boundary (typed exceptions)</a:t>
+            </a:r>
+          </a:p>
+        </p:txBody>
+      </p:sp>
+      <p:pic>
+        <p:nvPicPr>
+          <p:cNvPr id="12" name="Picture 11" descr="screenshot_tests.png"/>
+          <p:cNvPicPr>
+            <a:picLocks noChangeAspect="1"/>
+          </p:cNvPicPr>
+          <p:nvPr/>
+        </p:nvPicPr>
+        <p:blipFill>
+          <a:blip r:embed="rId2"/>
+          <a:stretch>
+            <a:fillRect/>
+          </a:stretch>
+        </p:blipFill>
+        <p:spPr>
+          <a:xfrm>
+            <a:off x="6309360" y="3167651"/>
+            <a:ext cx="5669280" cy="1437097"/>
+          </a:xfrm>
+          <a:prstGeom prst="rect">
+            <a:avLst/>
+          </a:prstGeom>
+          <a:ln w="12700">
+            <a:solidFill>
+              <a:srgbClr val="DCE0E8"/>
+            </a:solidFill>
+          </a:ln>
+        </p:spPr>
+      </p:pic>
+      <p:sp>
+        <p:nvSpPr>
+          <p:cNvPr id="13" name="Rectangle 12"/>
           <p:cNvSpPr/>
           <p:nvPr/>
         </p:nvSpPr>
@@ -8096,7 +8171,7 @@
       </p:sp>
       <p:sp>
         <p:nvSpPr>
-          <p:cNvPr id="13" name="TextBox 12"/>
+          <p:cNvPr id="14" name="TextBox 13"/>
           <p:cNvSpPr txBox="1"/>
           <p:nvPr/>
         </p:nvSpPr>
@@ -8132,7 +8207,7 @@
       </p:sp>
       <p:sp>
         <p:nvSpPr>
-          <p:cNvPr id="14" name="TextBox 13"/>
+          <p:cNvPr id="15" name="TextBox 14"/>
           <p:cNvSpPr txBox="1"/>
           <p:nvPr/>
         </p:nvSpPr>
@@ -8258,7 +8333,7 @@
               </a:defRPr>
             </a:pPr>
             <a:r>
-              <a:t>Result: Resizing Keeps Lookups Flat</a:t>
+              <a:t>Phase 3: Scaling Method</a:t>
             </a:r>
           </a:p>
         </p:txBody>
@@ -8579,8 +8654,8 @@
         </p:nvSpPr>
         <p:spPr>
           <a:xfrm>
-            <a:off x="548640" y="1572768"/>
-            <a:ext cx="5577840" cy="1463040"/>
+            <a:off x="548640" y="1463040"/>
+            <a:ext cx="11064240" cy="4846320"/>
           </a:xfrm>
           <a:prstGeom prst="rect">
             <a:avLst/>
@@ -8588,56 +8663,7 @@
           <a:noFill/>
         </p:spPr>
         <p:txBody>
-          <a:bodyPr wrap="square">
-            <a:spAutoFit/>
-          </a:bodyPr>
-          <a:lstStyle/>
-          <a:p>
-            <a:pPr algn="l">
-              <a:defRPr sz="5200" b="1">
-                <a:solidFill>
-                  <a:srgbClr val="2C7BB6"/>
-                </a:solidFill>
-                <a:latin typeface="Calibri"/>
-              </a:defRPr>
-            </a:pPr>
-            <a:r>
-              <a:t>4.6×</a:t>
-            </a:r>
-          </a:p>
-          <a:p>
-            <a:pPr algn="l">
-              <a:defRPr sz="1400">
-                <a:solidFill>
-                  <a:srgbClr val="8A8984"/>
-                </a:solidFill>
-                <a:latin typeface="Calibri"/>
-              </a:defRPr>
-            </a:pPr>
-            <a:r>
-              <a:t>faster lookups with load-factor resizing than a fixed-capacity table at 100k products</a:t>
-            </a:r>
-          </a:p>
-        </p:txBody>
-      </p:sp>
-      <p:sp>
-        <p:nvSpPr>
-          <p:cNvPr id="12" name="TextBox 11"/>
-          <p:cNvSpPr txBox="1"/>
-          <p:nvPr/>
-        </p:nvSpPr>
-        <p:spPr>
-          <a:xfrm>
-            <a:off x="548640" y="3108960"/>
-            <a:ext cx="5577840" cy="3200400"/>
-          </a:xfrm>
-          <a:prstGeom prst="rect">
-            <a:avLst/>
-          </a:prstGeom>
-          <a:noFill/>
-        </p:spPr>
-        <p:txBody>
-          <a:bodyPr wrap="square">
+          <a:bodyPr wrap="square" anchor="ctr">
             <a:spAutoFit/>
           </a:bodyPr>
           <a:lstStyle/>
@@ -8663,7 +8689,57 @@
                 </a:solidFill>
                 <a:latin typeface="Calibri"/>
               </a:rPr>
-              <a:t>Resizing: ~2.2 µs per lookup — flat, 1k → 100k</a:t>
+              <a:t>Catalogs of 1k → 100k products, 20k-order streams</a:t>
+            </a:r>
+          </a:p>
+          <a:p>
+            <a:pPr algn="l" marL="530352" indent="-182880">
+              <a:lnSpc>
+                <a:spcPct val="104000"/>
+              </a:lnSpc>
+              <a:spcAft>
+                <a:spcPts val="800"/>
+              </a:spcAft>
+              <a:buClr>
+                <a:srgbClr val="8A8984"/>
+              </a:buClr>
+              <a:buSzPct val="82000"/>
+              <a:buFont typeface="Calibri"/>
+              <a:buChar char="–"/>
+            </a:pPr>
+            <a:r>
+              <a:rPr sz="1700">
+                <a:solidFill>
+                  <a:srgbClr val="3A3F4A"/>
+                </a:solidFill>
+                <a:latin typeface="Calibri"/>
+              </a:rPr>
+              <a:t>Realistic names (shared prefixes) — the trie earns nothing from random strings</a:t>
+            </a:r>
+          </a:p>
+          <a:p>
+            <a:pPr algn="l" marL="530352" indent="-182880">
+              <a:lnSpc>
+                <a:spcPct val="104000"/>
+              </a:lnSpc>
+              <a:spcAft>
+                <a:spcPts val="800"/>
+              </a:spcAft>
+              <a:buClr>
+                <a:srgbClr val="8A8984"/>
+              </a:buClr>
+              <a:buSzPct val="82000"/>
+              <a:buFont typeface="Calibri"/>
+              <a:buChar char="–"/>
+            </a:pPr>
+            <a:r>
+              <a:rPr sz="1700">
+                <a:solidFill>
+                  <a:srgbClr val="3A3F4A"/>
+                </a:solidFill>
+                <a:latin typeface="Calibri"/>
+              </a:rPr>
+              <a:t>Quadratic popularity skew — hub products emerge, like real stores</a:t>
             </a:r>
           </a:p>
           <a:p>
@@ -8688,7 +8764,32 @@
                 </a:solidFill>
                 <a:latin typeface="Calibri"/>
               </a:rPr>
-              <a:t>Fixed 1,024 buckets: degrades to 10.1 µs</a:t>
+              <a:t>Best-of-5 timings (perf_counter), peak memory (tracemalloc)</a:t>
+            </a:r>
+          </a:p>
+          <a:p>
+            <a:pPr algn="l" marL="256032" indent="-256032">
+              <a:lnSpc>
+                <a:spcPct val="104000"/>
+              </a:lnSpc>
+              <a:spcAft>
+                <a:spcPts val="1200"/>
+              </a:spcAft>
+              <a:buClr>
+                <a:srgbClr val="2C7BB6"/>
+              </a:buClr>
+              <a:buSzPct val="82000"/>
+              <a:buFont typeface="Arial"/>
+              <a:buChar char="▪"/>
+            </a:pPr>
+            <a:r>
+              <a:rPr sz="2000">
+                <a:solidFill>
+                  <a:srgbClr val="3A3F4A"/>
+                </a:solidFill>
+                <a:latin typeface="Calibri"/>
+              </a:rPr>
+              <a:t>Every structure measured against a naive baseline</a:t>
             </a:r>
           </a:p>
           <a:p>
@@ -8713,68 +8814,14 @@
                 </a:solidFill>
                 <a:latin typeface="Calibri"/>
               </a:rPr>
-              <a:t>max collision chain reaches 111 entries</a:t>
-            </a:r>
-          </a:p>
-          <a:p>
-            <a:pPr algn="l" marL="256032" indent="-256032">
-              <a:lnSpc>
-                <a:spcPct val="104000"/>
-              </a:lnSpc>
-              <a:spcAft>
-                <a:spcPts val="1200"/>
-              </a:spcAft>
-              <a:buClr>
-                <a:srgbClr val="2C7BB6"/>
-              </a:buClr>
-              <a:buSzPct val="82000"/>
-              <a:buFont typeface="Arial"/>
-              <a:buChar char="▪"/>
-            </a:pPr>
-            <a:r>
-              <a:rPr sz="2000">
-                <a:solidFill>
-                  <a:srgbClr val="3A3F4A"/>
-                </a:solidFill>
-                <a:latin typeface="Calibri"/>
-              </a:rPr>
-              <a:t>The O(n/m) arithmetic of chained hashing, made visible</a:t>
-            </a:r>
-          </a:p>
-        </p:txBody>
-      </p:sp>
-      <p:pic>
-        <p:nvPicPr>
-          <p:cNvPr id="13" name="Picture 12" descr="chart_catalog_lookup.png"/>
-          <p:cNvPicPr>
-            <a:picLocks noChangeAspect="1"/>
-          </p:cNvPicPr>
-          <p:nvPr/>
-        </p:nvPicPr>
-        <p:blipFill>
-          <a:blip r:embed="rId2"/>
-          <a:stretch>
-            <a:fillRect/>
-          </a:stretch>
-        </p:blipFill>
-        <p:spPr>
-          <a:xfrm>
-            <a:off x="6309360" y="2063931"/>
-            <a:ext cx="5669280" cy="3644537"/>
-          </a:xfrm>
-          <a:prstGeom prst="rect">
-            <a:avLst/>
-          </a:prstGeom>
-          <a:ln w="12700">
-            <a:solidFill>
-              <a:srgbClr val="DCE0E8"/>
-            </a:solidFill>
-          </a:ln>
-        </p:spPr>
-      </p:pic>
-      <p:sp>
-        <p:nvSpPr>
-          <p:cNvPr id="14" name="Rectangle 13"/>
+              <a:t>fixed-capacity hashing, linear scans, full sorts</a:t>
+            </a:r>
+          </a:p>
+        </p:txBody>
+      </p:sp>
+      <p:sp>
+        <p:nvSpPr>
+          <p:cNvPr id="12" name="Rectangle 11"/>
           <p:cNvSpPr/>
           <p:nvPr/>
         </p:nvSpPr>
@@ -8818,7 +8865,7 @@
       </p:sp>
       <p:sp>
         <p:nvSpPr>
-          <p:cNvPr id="15" name="TextBox 14"/>
+          <p:cNvPr id="13" name="TextBox 12"/>
           <p:cNvSpPr txBox="1"/>
           <p:nvPr/>
         </p:nvSpPr>
@@ -8854,7 +8901,7 @@
       </p:sp>
       <p:sp>
         <p:nvSpPr>
-          <p:cNvPr id="16" name="TextBox 15"/>
+          <p:cNvPr id="14" name="TextBox 13"/>
           <p:cNvSpPr txBox="1"/>
           <p:nvPr/>
         </p:nvSpPr>
@@ -8980,7 +9027,7 @@
               </a:defRPr>
             </a:pPr>
             <a:r>
-              <a:t>Result: The Trie Wins by 45×</a:t>
+              <a:t>Result: Resizing Keeps Lookups Flat</a:t>
             </a:r>
           </a:p>
         </p:txBody>
@@ -9324,7 +9371,7 @@
               </a:defRPr>
             </a:pPr>
             <a:r>
-              <a:t>45×</a:t>
+              <a:t>4.6×</a:t>
             </a:r>
           </a:p>
           <a:p>
@@ -9337,7 +9384,7 @@
               </a:defRPr>
             </a:pPr>
             <a:r>
-              <a:t>faster prefix search than a linear scan at 100k products</a:t>
+              <a:t>faster lookups with load-factor resizing than a fixed-capacity table at 100k products</a:t>
             </a:r>
           </a:p>
         </p:txBody>
@@ -9385,7 +9432,7 @@
                 </a:solidFill>
                 <a:latin typeface="Calibri"/>
               </a:rPr>
-              <a:t>Linear name scan: 82 ms per query at 100k products</a:t>
+              <a:t>Resizing: ~2.2 µs per lookup — flat, 1k → 100k</a:t>
             </a:r>
           </a:p>
           <a:p>
@@ -9410,7 +9457,7 @@
                 </a:solidFill>
                 <a:latin typeface="Calibri"/>
               </a:rPr>
-              <a:t>Trie prefix walk: 1.83 ms — 45× faster</a:t>
+              <a:t>Fixed 1,024 buckets: degrades to 10.1 µs</a:t>
             </a:r>
           </a:p>
           <a:p>
@@ -9435,7 +9482,7 @@
                 </a:solidFill>
                 <a:latin typeface="Calibri"/>
               </a:rPr>
-              <a:t>Cost depends on prefix + matches, not catalog size</a:t>
+              <a:t>max collision chain reaches 111 entries</a:t>
             </a:r>
           </a:p>
           <a:p>
@@ -9460,39 +9507,14 @@
                 </a:solidFill>
                 <a:latin typeface="Calibri"/>
               </a:rPr>
-              <a:t>Price-band query: pruned BST beats scan 5.7×</a:t>
-            </a:r>
-          </a:p>
-          <a:p>
-            <a:pPr algn="l" marL="256032" indent="-256032">
-              <a:lnSpc>
-                <a:spcPct val="104000"/>
-              </a:lnSpc>
-              <a:spcAft>
-                <a:spcPts val="1200"/>
-              </a:spcAft>
-              <a:buClr>
-                <a:srgbClr val="2C7BB6"/>
-              </a:buClr>
-              <a:buSzPct val="82000"/>
-              <a:buFont typeface="Arial"/>
-              <a:buChar char="▪"/>
-            </a:pPr>
-            <a:r>
-              <a:rPr sz="2000">
-                <a:solidFill>
-                  <a:srgbClr val="3A3F4A"/>
-                </a:solidFill>
-                <a:latin typeface="Calibri"/>
-              </a:rPr>
-              <a:t>Both gaps widen as the catalog grows</a:t>
+              <a:t>The O(n/m) arithmetic of chained hashing, made visible</a:t>
             </a:r>
           </a:p>
         </p:txBody>
       </p:sp>
       <p:pic>
         <p:nvPicPr>
-          <p:cNvPr id="13" name="Picture 12" descr="chart_search_prefix.png"/>
+          <p:cNvPr id="13" name="Picture 12" descr="chart_catalog_lookup.png"/>
           <p:cNvPicPr>
             <a:picLocks noChangeAspect="1"/>
           </p:cNvPicPr>
@@ -9727,7 +9749,7 @@
               </a:defRPr>
             </a:pPr>
             <a:r>
-              <a:t>The Honest Result: Asymptotics vs the Interpreter</a:t>
+              <a:t>Result: The Trie Wins by 45×</a:t>
             </a:r>
           </a:p>
         </p:txBody>
@@ -10048,8 +10070,8 @@
         </p:nvSpPr>
         <p:spPr>
           <a:xfrm>
-            <a:off x="548640" y="1463040"/>
-            <a:ext cx="5577840" cy="4846320"/>
+            <a:off x="548640" y="1572768"/>
+            <a:ext cx="5577840" cy="1463040"/>
           </a:xfrm>
           <a:prstGeom prst="rect">
             <a:avLst/>
@@ -10057,7 +10079,56 @@
           <a:noFill/>
         </p:spPr>
         <p:txBody>
-          <a:bodyPr wrap="square" anchor="ctr">
+          <a:bodyPr wrap="square">
+            <a:spAutoFit/>
+          </a:bodyPr>
+          <a:lstStyle/>
+          <a:p>
+            <a:pPr algn="l">
+              <a:defRPr sz="5200" b="1">
+                <a:solidFill>
+                  <a:srgbClr val="2C7BB6"/>
+                </a:solidFill>
+                <a:latin typeface="Calibri"/>
+              </a:defRPr>
+            </a:pPr>
+            <a:r>
+              <a:t>45×</a:t>
+            </a:r>
+          </a:p>
+          <a:p>
+            <a:pPr algn="l">
+              <a:defRPr sz="1400">
+                <a:solidFill>
+                  <a:srgbClr val="8A8984"/>
+                </a:solidFill>
+                <a:latin typeface="Calibri"/>
+              </a:defRPr>
+            </a:pPr>
+            <a:r>
+              <a:t>faster prefix search than a linear scan at 100k products</a:t>
+            </a:r>
+          </a:p>
+        </p:txBody>
+      </p:sp>
+      <p:sp>
+        <p:nvSpPr>
+          <p:cNvPr id="12" name="TextBox 11"/>
+          <p:cNvSpPr txBox="1"/>
+          <p:nvPr/>
+        </p:nvSpPr>
+        <p:spPr>
+          <a:xfrm>
+            <a:off x="548640" y="3108960"/>
+            <a:ext cx="5577840" cy="3200400"/>
+          </a:xfrm>
+          <a:prstGeom prst="rect">
+            <a:avLst/>
+          </a:prstGeom>
+          <a:noFill/>
+        </p:spPr>
+        <p:txBody>
+          <a:bodyPr wrap="square">
             <a:spAutoFit/>
           </a:bodyPr>
           <a:lstStyle/>
@@ -10083,7 +10154,7 @@
                 </a:solidFill>
                 <a:latin typeface="Calibri"/>
               </a:rPr>
-              <a:t>Heap top-10: O(n + k log n) — should beat O(n log n) sort</a:t>
+              <a:t>Linear name scan: 82 ms per query at 100k products</a:t>
             </a:r>
           </a:p>
           <a:p>
@@ -10108,7 +10179,7 @@
                 </a:solidFill>
                 <a:latin typeface="Calibri"/>
               </a:rPr>
-              <a:t>Measured: pure-Python heap ≈ ties C-implemented Timsort</a:t>
+              <a:t>Trie prefix walk: 1.83 ms — 45× faster</a:t>
             </a:r>
           </a:p>
           <a:p>
@@ -10133,7 +10204,7 @@
                 </a:solidFill>
                 <a:latin typeface="Calibri"/>
               </a:rPr>
-              <a:t>every sift-down comparison runs in the interpreter</a:t>
+              <a:t>Cost depends on prefix + matches, not catalog size</a:t>
             </a:r>
           </a:p>
           <a:p>
@@ -10158,7 +10229,7 @@
                 </a:solidFill>
                 <a:latin typeface="Calibri"/>
               </a:rPr>
-              <a:t>Constant factors consumed the asymptotic advantage</a:t>
+              <a:t>Price-band query: pruned BST beats scan 5.7×</a:t>
             </a:r>
           </a:p>
           <a:p>
@@ -10183,39 +10254,14 @@
                 </a:solidFill>
                 <a:latin typeface="Calibri"/>
               </a:rPr>
-              <a:t>Heap kept for incremental updates, not cold rankings</a:t>
-            </a:r>
-          </a:p>
-          <a:p>
-            <a:pPr algn="l" marL="256032" indent="-256032">
-              <a:lnSpc>
-                <a:spcPct val="104000"/>
-              </a:lnSpc>
-              <a:spcAft>
-                <a:spcPts val="1200"/>
-              </a:spcAft>
-              <a:buClr>
-                <a:srgbClr val="2C7BB6"/>
-              </a:buClr>
-              <a:buSzPct val="82000"/>
-              <a:buFont typeface="Arial"/>
-              <a:buChar char="▪"/>
-            </a:pPr>
-            <a:r>
-              <a:rPr sz="2000">
-                <a:solidFill>
-                  <a:srgbClr val="3A3F4A"/>
-                </a:solidFill>
-                <a:latin typeface="Calibri"/>
-              </a:rPr>
-              <a:t>Lesson: measure optimizations in their environment</a:t>
+              <a:t>Both gaps widen as the catalog grows</a:t>
             </a:r>
           </a:p>
         </p:txBody>
       </p:sp>
       <p:pic>
         <p:nvPicPr>
-          <p:cNvPr id="12" name="Picture 11" descr="chart_top_k.png"/>
+          <p:cNvPr id="13" name="Picture 12" descr="chart_search_prefix.png"/>
           <p:cNvPicPr>
             <a:picLocks noChangeAspect="1"/>
           </p:cNvPicPr>
@@ -10244,7 +10290,7 @@
       </p:pic>
       <p:sp>
         <p:nvSpPr>
-          <p:cNvPr id="13" name="Rectangle 12"/>
+          <p:cNvPr id="14" name="Rectangle 13"/>
           <p:cNvSpPr/>
           <p:nvPr/>
         </p:nvSpPr>
@@ -10288,7 +10334,7 @@
       </p:sp>
       <p:sp>
         <p:nvSpPr>
-          <p:cNvPr id="14" name="TextBox 13"/>
+          <p:cNvPr id="15" name="TextBox 14"/>
           <p:cNvSpPr txBox="1"/>
           <p:nvPr/>
         </p:nvSpPr>
@@ -10324,7 +10370,7 @@
       </p:sp>
       <p:sp>
         <p:nvSpPr>
-          <p:cNvPr id="15" name="TextBox 14"/>
+          <p:cNvPr id="16" name="TextBox 15"/>
           <p:cNvSpPr txBox="1"/>
           <p:nvPr/>
         </p:nvSpPr>
@@ -10450,7 +10496,7 @@
               </a:defRPr>
             </a:pPr>
             <a:r>
-              <a:t>Stress Tests: Predicted Failures, Observed on Cue</a:t>
+              <a:t>The Honest Result: Asymptotics vs the Interpreter</a:t>
             </a:r>
           </a:p>
         </p:txBody>
@@ -10806,7 +10852,32 @@
                 </a:solidFill>
                 <a:latin typeface="Calibri"/>
               </a:rPr>
-              <a:t>Monotone price load: BST height 4,000 vs 25 (random)</a:t>
+              <a:t>Heap top-10: O(n + k log n) — should beat O(n log n) sort</a:t>
+            </a:r>
+          </a:p>
+          <a:p>
+            <a:pPr algn="l" marL="256032" indent="-256032">
+              <a:lnSpc>
+                <a:spcPct val="104000"/>
+              </a:lnSpc>
+              <a:spcAft>
+                <a:spcPts val="1200"/>
+              </a:spcAft>
+              <a:buClr>
+                <a:srgbClr val="2C7BB6"/>
+              </a:buClr>
+              <a:buSzPct val="82000"/>
+              <a:buFont typeface="Arial"/>
+              <a:buChar char="▪"/>
+            </a:pPr>
+            <a:r>
+              <a:rPr sz="2000">
+                <a:solidFill>
+                  <a:srgbClr val="3A3F4A"/>
+                </a:solidFill>
+                <a:latin typeface="Calibri"/>
+              </a:rPr>
+              <a:t>Measured: pure-Python heap ≈ ties C-implemented Timsort</a:t>
             </a:r>
           </a:p>
           <a:p>
@@ -10831,32 +10902,7 @@
                 </a:solidFill>
                 <a:latin typeface="Calibri"/>
               </a:rPr>
-              <a:t>the documented worst case, built deliberately</a:t>
-            </a:r>
-          </a:p>
-          <a:p>
-            <a:pPr algn="l" marL="530352" indent="-182880">
-              <a:lnSpc>
-                <a:spcPct val="104000"/>
-              </a:lnSpc>
-              <a:spcAft>
-                <a:spcPts val="800"/>
-              </a:spcAft>
-              <a:buClr>
-                <a:srgbClr val="8A8984"/>
-              </a:buClr>
-              <a:buSzPct val="82000"/>
-              <a:buFont typeface="Calibri"/>
-              <a:buChar char="–"/>
-            </a:pPr>
-            <a:r>
-              <a:rPr sz="1700">
-                <a:solidFill>
-                  <a:srgbClr val="3A3F4A"/>
-                </a:solidFill>
-                <a:latin typeface="Calibri"/>
-              </a:rPr>
-              <a:t>iterative traversal survives where recursion would overflow</a:t>
+              <a:t>every sift-down comparison runs in the interpreter</a:t>
             </a:r>
           </a:p>
           <a:p>
@@ -10881,32 +10927,7 @@
                 </a:solidFill>
                 <a:latin typeface="Calibri"/>
               </a:rPr>
-              <a:t>Flash-sale load: 20k orders vs 1k-product catalog</a:t>
-            </a:r>
-          </a:p>
-          <a:p>
-            <a:pPr algn="l" marL="530352" indent="-182880">
-              <a:lnSpc>
-                <a:spcPct val="104000"/>
-              </a:lnSpc>
-              <a:spcAft>
-                <a:spcPts val="800"/>
-              </a:spcAft>
-              <a:buClr>
-                <a:srgbClr val="8A8984"/>
-              </a:buClr>
-              <a:buSzPct val="82000"/>
-              <a:buFont typeface="Calibri"/>
-              <a:buChar char="–"/>
-            </a:pPr>
-            <a:r>
-              <a:rPr sz="1700">
-                <a:solidFill>
-                  <a:srgbClr val="3A3F4A"/>
-                </a:solidFill>
-                <a:latin typeface="Calibri"/>
-              </a:rPr>
-              <a:t>9,413 atomic rejections, zero corrupted line items</a:t>
+              <a:t>Constant factors consumed the asymptotic advantage</a:t>
             </a:r>
           </a:p>
           <a:p>
@@ -10931,14 +10952,39 @@
                 </a:solidFill>
                 <a:latin typeface="Calibri"/>
               </a:rPr>
-              <a:t>End to end: ~44k orders/s, ~65 MB at 100k products</a:t>
+              <a:t>Heap kept for incremental updates, not cold rankings</a:t>
+            </a:r>
+          </a:p>
+          <a:p>
+            <a:pPr algn="l" marL="256032" indent="-256032">
+              <a:lnSpc>
+                <a:spcPct val="104000"/>
+              </a:lnSpc>
+              <a:spcAft>
+                <a:spcPts val="1200"/>
+              </a:spcAft>
+              <a:buClr>
+                <a:srgbClr val="2C7BB6"/>
+              </a:buClr>
+              <a:buSzPct val="82000"/>
+              <a:buFont typeface="Arial"/>
+              <a:buChar char="▪"/>
+            </a:pPr>
+            <a:r>
+              <a:rPr sz="2000">
+                <a:solidFill>
+                  <a:srgbClr val="3A3F4A"/>
+                </a:solidFill>
+                <a:latin typeface="Calibri"/>
+              </a:rPr>
+              <a:t>Lesson: measure optimizations in their environment</a:t>
             </a:r>
           </a:p>
         </p:txBody>
       </p:sp>
       <p:pic>
         <p:nvPicPr>
-          <p:cNvPr id="12" name="Picture 11" descr="chart_bst_height.png"/>
+          <p:cNvPr id="12" name="Picture 11" descr="chart_top_k.png"/>
           <p:cNvPicPr>
             <a:picLocks noChangeAspect="1"/>
           </p:cNvPicPr>
@@ -11137,7 +11183,7 @@
                 </a:solidFill>
                 <a:latin typeface="Calibri"/>
               </a:rPr>
-              <a:t>07 · CONCLUSIONS</a:t>
+              <a:t>06 · BENCHMARKS</a:t>
             </a:r>
           </a:p>
         </p:txBody>
@@ -11173,7 +11219,7 @@
               </a:defRPr>
             </a:pPr>
             <a:r>
-              <a:t>Conclusions</a:t>
+              <a:t>Stress Tests: Predicted Failures, Observed on Cue</a:t>
             </a:r>
           </a:p>
         </p:txBody>
@@ -11495,7 +11541,7 @@
         <p:spPr>
           <a:xfrm>
             <a:off x="548640" y="1463040"/>
-            <a:ext cx="11064240" cy="4846320"/>
+            <a:ext cx="5577840" cy="4846320"/>
           </a:xfrm>
           <a:prstGeom prst="rect">
             <a:avLst/>
@@ -11529,7 +11575,57 @@
                 </a:solidFill>
                 <a:latin typeface="Calibri"/>
               </a:rPr>
-              <a:t>Composition beats generality — six specialists, one O(1) source of truth</a:t>
+              <a:t>Monotone price load: BST height 4,000 vs 25 (random)</a:t>
+            </a:r>
+          </a:p>
+          <a:p>
+            <a:pPr algn="l" marL="530352" indent="-182880">
+              <a:lnSpc>
+                <a:spcPct val="104000"/>
+              </a:lnSpc>
+              <a:spcAft>
+                <a:spcPts val="800"/>
+              </a:spcAft>
+              <a:buClr>
+                <a:srgbClr val="8A8984"/>
+              </a:buClr>
+              <a:buSzPct val="82000"/>
+              <a:buFont typeface="Calibri"/>
+              <a:buChar char="–"/>
+            </a:pPr>
+            <a:r>
+              <a:rPr sz="1700">
+                <a:solidFill>
+                  <a:srgbClr val="3A3F4A"/>
+                </a:solidFill>
+                <a:latin typeface="Calibri"/>
+              </a:rPr>
+              <a:t>the documented worst case, built deliberately</a:t>
+            </a:r>
+          </a:p>
+          <a:p>
+            <a:pPr algn="l" marL="530352" indent="-182880">
+              <a:lnSpc>
+                <a:spcPct val="104000"/>
+              </a:lnSpc>
+              <a:spcAft>
+                <a:spcPts val="800"/>
+              </a:spcAft>
+              <a:buClr>
+                <a:srgbClr val="8A8984"/>
+              </a:buClr>
+              <a:buSzPct val="82000"/>
+              <a:buFont typeface="Calibri"/>
+              <a:buChar char="–"/>
+            </a:pPr>
+            <a:r>
+              <a:rPr sz="1700">
+                <a:solidFill>
+                  <a:srgbClr val="3A3F4A"/>
+                </a:solidFill>
+                <a:latin typeface="Calibri"/>
+              </a:rPr>
+              <a:t>iterative traversal survives where recursion would overflow</a:t>
             </a:r>
           </a:p>
           <a:p>
@@ -11554,7 +11650,32 @@
                 </a:solidFill>
                 <a:latin typeface="Calibri"/>
               </a:rPr>
-              <a:t>Optimizations must be measured: resizing repaid 5×, the heap's textbook win didn't survive C vs interpreter</a:t>
+              <a:t>Flash-sale load: 20k orders vs 1k-product catalog</a:t>
+            </a:r>
+          </a:p>
+          <a:p>
+            <a:pPr algn="l" marL="530352" indent="-182880">
+              <a:lnSpc>
+                <a:spcPct val="104000"/>
+              </a:lnSpc>
+              <a:spcAft>
+                <a:spcPts val="800"/>
+              </a:spcAft>
+              <a:buClr>
+                <a:srgbClr val="8A8984"/>
+              </a:buClr>
+              <a:buSzPct val="82000"/>
+              <a:buFont typeface="Calibri"/>
+              <a:buChar char="–"/>
+            </a:pPr>
+            <a:r>
+              <a:rPr sz="1700">
+                <a:solidFill>
+                  <a:srgbClr val="3A3F4A"/>
+                </a:solidFill>
+                <a:latin typeface="Calibri"/>
+              </a:rPr>
+              <a:t>9,413 atomic rejections, zero corrupted line items</a:t>
             </a:r>
           </a:p>
           <a:p>
@@ -11579,9 +11700,582 @@
                 </a:solidFill>
                 <a:latin typeface="Calibri"/>
               </a:rPr>
-              <a:t>Worst cases written down at design time became cheap tests</a:t>
-            </a:r>
-          </a:p>
+              <a:t>End to end: ~44k orders/s, ~65 MB at 100k products</a:t>
+            </a:r>
+          </a:p>
+        </p:txBody>
+      </p:sp>
+      <p:pic>
+        <p:nvPicPr>
+          <p:cNvPr id="12" name="Picture 11" descr="chart_bst_height.png"/>
+          <p:cNvPicPr>
+            <a:picLocks noChangeAspect="1"/>
+          </p:cNvPicPr>
+          <p:nvPr/>
+        </p:nvPicPr>
+        <p:blipFill>
+          <a:blip r:embed="rId2"/>
+          <a:stretch>
+            <a:fillRect/>
+          </a:stretch>
+        </p:blipFill>
+        <p:spPr>
+          <a:xfrm>
+            <a:off x="6309360" y="2063931"/>
+            <a:ext cx="5669280" cy="3644537"/>
+          </a:xfrm>
+          <a:prstGeom prst="rect">
+            <a:avLst/>
+          </a:prstGeom>
+          <a:ln w="12700">
+            <a:solidFill>
+              <a:srgbClr val="DCE0E8"/>
+            </a:solidFill>
+          </a:ln>
+        </p:spPr>
+      </p:pic>
+      <p:sp>
+        <p:nvSpPr>
+          <p:cNvPr id="13" name="Rectangle 12"/>
+          <p:cNvSpPr/>
+          <p:nvPr/>
+        </p:nvSpPr>
+        <p:spPr>
+          <a:xfrm>
+            <a:off x="548640" y="6455664"/>
+            <a:ext cx="11091672" cy="10972"/>
+          </a:xfrm>
+          <a:prstGeom prst="rect">
+            <a:avLst/>
+          </a:prstGeom>
+          <a:solidFill>
+            <a:srgbClr val="DCE0E8"/>
+          </a:solidFill>
+          <a:ln>
+            <a:noFill/>
+          </a:ln>
+          <a:effectLst/>
+        </p:spPr>
+        <p:style>
+          <a:lnRef idx="1">
+            <a:schemeClr val="accent1"/>
+          </a:lnRef>
+          <a:fillRef idx="3">
+            <a:schemeClr val="accent1"/>
+          </a:fillRef>
+          <a:effectRef idx="2">
+            <a:schemeClr val="accent1"/>
+          </a:effectRef>
+          <a:fontRef idx="minor">
+            <a:schemeClr val="lt1"/>
+          </a:fontRef>
+        </p:style>
+        <p:txBody>
+          <a:bodyPr rtlCol="0" anchor="ctr"/>
+          <a:lstStyle/>
+          <a:p>
+            <a:pPr algn="ctr"/>
+          </a:p>
+        </p:txBody>
+      </p:sp>
+      <p:sp>
+        <p:nvSpPr>
+          <p:cNvPr id="14" name="TextBox 13"/>
+          <p:cNvSpPr txBox="1"/>
+          <p:nvPr/>
+        </p:nvSpPr>
+        <p:spPr>
+          <a:xfrm>
+            <a:off x="548640" y="6510528"/>
+            <a:ext cx="8229600" cy="274320"/>
+          </a:xfrm>
+          <a:prstGeom prst="rect">
+            <a:avLst/>
+          </a:prstGeom>
+          <a:noFill/>
+        </p:spPr>
+        <p:txBody>
+          <a:bodyPr wrap="square">
+            <a:spAutoFit/>
+          </a:bodyPr>
+          <a:lstStyle/>
+          <a:p>
+            <a:pPr algn="l">
+              <a:defRPr sz="950">
+                <a:solidFill>
+                  <a:srgbClr val="8A8984"/>
+                </a:solidFill>
+                <a:latin typeface="Calibri"/>
+              </a:defRPr>
+            </a:pPr>
+            <a:r>
+              <a:t>MSCS-532 · Group 2 — E-Commerce Order Platform</a:t>
+            </a:r>
+          </a:p>
+        </p:txBody>
+      </p:sp>
+      <p:sp>
+        <p:nvSpPr>
+          <p:cNvPr id="15" name="TextBox 14"/>
+          <p:cNvSpPr txBox="1"/>
+          <p:nvPr/>
+        </p:nvSpPr>
+        <p:spPr>
+          <a:xfrm>
+            <a:off x="10972800" y="6510528"/>
+            <a:ext cx="667512" cy="274320"/>
+          </a:xfrm>
+          <a:prstGeom prst="rect">
+            <a:avLst/>
+          </a:prstGeom>
+          <a:noFill/>
+        </p:spPr>
+        <p:txBody>
+          <a:bodyPr wrap="square">
+            <a:spAutoFit/>
+          </a:bodyPr>
+          <a:lstStyle/>
+          <a:p>
+            <a:pPr algn="r">
+              <a:defRPr sz="950">
+                <a:solidFill>
+                  <a:srgbClr val="8A8984"/>
+                </a:solidFill>
+                <a:latin typeface="Calibri"/>
+              </a:defRPr>
+            </a:pPr>
+            <a:r>
+              <a:t>18</a:t>
+            </a:r>
+          </a:p>
+        </p:txBody>
+      </p:sp>
+    </p:spTree>
+  </p:cSld>
+  <p:clrMapOvr>
+    <a:masterClrMapping/>
+  </p:clrMapOvr>
+</p:sld>
+</file>
+
+<file path=ppt/slides/slide19.xml><?xml version="1.0" encoding="utf-8"?>
+<p:sld xmlns:a="http://schemas.openxmlformats.org/drawingml/2006/main" xmlns:p="http://schemas.openxmlformats.org/presentationml/2006/main" xmlns:r="http://schemas.openxmlformats.org/officeDocument/2006/relationships">
+  <p:cSld>
+    <p:bg>
+      <p:bgPr>
+        <a:solidFill>
+          <a:srgbClr val="FCFCFB"/>
+        </a:solidFill>
+        <a:effectLst/>
+      </p:bgPr>
+    </p:bg>
+    <p:spTree>
+      <p:nvGrpSpPr>
+        <p:cNvPr id="1" name=""/>
+        <p:cNvGrpSpPr/>
+        <p:nvPr/>
+      </p:nvGrpSpPr>
+      <p:grpSpPr/>
+      <p:sp>
+        <p:nvSpPr>
+          <p:cNvPr id="2" name="TextBox 1"/>
+          <p:cNvSpPr txBox="1"/>
+          <p:nvPr/>
+        </p:nvSpPr>
+        <p:spPr>
+          <a:xfrm>
+            <a:off x="566928" y="310896"/>
+            <a:ext cx="8046720" cy="274320"/>
+          </a:xfrm>
+          <a:prstGeom prst="rect">
+            <a:avLst/>
+          </a:prstGeom>
+          <a:noFill/>
+        </p:spPr>
+        <p:txBody>
+          <a:bodyPr wrap="square">
+            <a:spAutoFit/>
+          </a:bodyPr>
+          <a:lstStyle/>
+          <a:p>
+            <a:pPr algn="l"/>
+            <a:r>
+              <a:rPr sz="1150" b="1" spc="160">
+                <a:solidFill>
+                  <a:srgbClr val="6B7A99"/>
+                </a:solidFill>
+                <a:latin typeface="Calibri"/>
+              </a:rPr>
+              <a:t>07 · CONCLUSIONS</a:t>
+            </a:r>
+          </a:p>
+        </p:txBody>
+      </p:sp>
+      <p:sp>
+        <p:nvSpPr>
+          <p:cNvPr id="3" name="TextBox 2"/>
+          <p:cNvSpPr txBox="1"/>
+          <p:nvPr/>
+        </p:nvSpPr>
+        <p:spPr>
+          <a:xfrm>
+            <a:off x="548640" y="530352"/>
+            <a:ext cx="11064240" cy="685800"/>
+          </a:xfrm>
+          <a:prstGeom prst="rect">
+            <a:avLst/>
+          </a:prstGeom>
+          <a:noFill/>
+        </p:spPr>
+        <p:txBody>
+          <a:bodyPr wrap="square">
+            <a:spAutoFit/>
+          </a:bodyPr>
+          <a:lstStyle/>
+          <a:p>
+            <a:pPr algn="l">
+              <a:defRPr sz="2900" b="1">
+                <a:solidFill>
+                  <a:srgbClr val="1F2A44"/>
+                </a:solidFill>
+                <a:latin typeface="Calibri"/>
+              </a:defRPr>
+            </a:pPr>
+            <a:r>
+              <a:t>Conclusions</a:t>
+            </a:r>
+          </a:p>
+        </p:txBody>
+      </p:sp>
+      <p:sp>
+        <p:nvSpPr>
+          <p:cNvPr id="4" name="Rectangle 3"/>
+          <p:cNvSpPr/>
+          <p:nvPr/>
+        </p:nvSpPr>
+        <p:spPr>
+          <a:xfrm>
+            <a:off x="548640" y="1243584"/>
+            <a:ext cx="11064240" cy="12801"/>
+          </a:xfrm>
+          <a:prstGeom prst="rect">
+            <a:avLst/>
+          </a:prstGeom>
+          <a:solidFill>
+            <a:srgbClr val="DCE0E8"/>
+          </a:solidFill>
+          <a:ln>
+            <a:noFill/>
+          </a:ln>
+          <a:effectLst/>
+        </p:spPr>
+        <p:style>
+          <a:lnRef idx="1">
+            <a:schemeClr val="accent1"/>
+          </a:lnRef>
+          <a:fillRef idx="3">
+            <a:schemeClr val="accent1"/>
+          </a:fillRef>
+          <a:effectRef idx="2">
+            <a:schemeClr val="accent1"/>
+          </a:effectRef>
+          <a:fontRef idx="minor">
+            <a:schemeClr val="lt1"/>
+          </a:fontRef>
+        </p:style>
+        <p:txBody>
+          <a:bodyPr rtlCol="0" anchor="ctr"/>
+          <a:lstStyle/>
+          <a:p>
+            <a:pPr algn="ctr"/>
+          </a:p>
+        </p:txBody>
+      </p:sp>
+      <p:sp>
+        <p:nvSpPr>
+          <p:cNvPr id="5" name="Rectangle 4"/>
+          <p:cNvSpPr/>
+          <p:nvPr/>
+        </p:nvSpPr>
+        <p:spPr>
+          <a:xfrm>
+            <a:off x="548640" y="1216152"/>
+            <a:ext cx="329184" cy="50292"/>
+          </a:xfrm>
+          <a:prstGeom prst="rect">
+            <a:avLst/>
+          </a:prstGeom>
+          <a:solidFill>
+            <a:srgbClr val="2A78D6"/>
+          </a:solidFill>
+          <a:ln>
+            <a:noFill/>
+          </a:ln>
+          <a:effectLst/>
+        </p:spPr>
+        <p:style>
+          <a:lnRef idx="1">
+            <a:schemeClr val="accent1"/>
+          </a:lnRef>
+          <a:fillRef idx="3">
+            <a:schemeClr val="accent1"/>
+          </a:fillRef>
+          <a:effectRef idx="2">
+            <a:schemeClr val="accent1"/>
+          </a:effectRef>
+          <a:fontRef idx="minor">
+            <a:schemeClr val="lt1"/>
+          </a:fontRef>
+        </p:style>
+        <p:txBody>
+          <a:bodyPr rtlCol="0" anchor="ctr"/>
+          <a:lstStyle/>
+          <a:p>
+            <a:pPr algn="ctr"/>
+          </a:p>
+        </p:txBody>
+      </p:sp>
+      <p:sp>
+        <p:nvSpPr>
+          <p:cNvPr id="6" name="Rectangle 5"/>
+          <p:cNvSpPr/>
+          <p:nvPr/>
+        </p:nvSpPr>
+        <p:spPr>
+          <a:xfrm>
+            <a:off x="877824" y="1216152"/>
+            <a:ext cx="329184" cy="50292"/>
+          </a:xfrm>
+          <a:prstGeom prst="rect">
+            <a:avLst/>
+          </a:prstGeom>
+          <a:solidFill>
+            <a:srgbClr val="008300"/>
+          </a:solidFill>
+          <a:ln>
+            <a:noFill/>
+          </a:ln>
+          <a:effectLst/>
+        </p:spPr>
+        <p:style>
+          <a:lnRef idx="1">
+            <a:schemeClr val="accent1"/>
+          </a:lnRef>
+          <a:fillRef idx="3">
+            <a:schemeClr val="accent1"/>
+          </a:fillRef>
+          <a:effectRef idx="2">
+            <a:schemeClr val="accent1"/>
+          </a:effectRef>
+          <a:fontRef idx="minor">
+            <a:schemeClr val="lt1"/>
+          </a:fontRef>
+        </p:style>
+        <p:txBody>
+          <a:bodyPr rtlCol="0" anchor="ctr"/>
+          <a:lstStyle/>
+          <a:p>
+            <a:pPr algn="ctr"/>
+          </a:p>
+        </p:txBody>
+      </p:sp>
+      <p:sp>
+        <p:nvSpPr>
+          <p:cNvPr id="7" name="Rectangle 6"/>
+          <p:cNvSpPr/>
+          <p:nvPr/>
+        </p:nvSpPr>
+        <p:spPr>
+          <a:xfrm>
+            <a:off x="1207008" y="1216152"/>
+            <a:ext cx="329184" cy="50292"/>
+          </a:xfrm>
+          <a:prstGeom prst="rect">
+            <a:avLst/>
+          </a:prstGeom>
+          <a:solidFill>
+            <a:srgbClr val="EB6834"/>
+          </a:solidFill>
+          <a:ln>
+            <a:noFill/>
+          </a:ln>
+          <a:effectLst/>
+        </p:spPr>
+        <p:style>
+          <a:lnRef idx="1">
+            <a:schemeClr val="accent1"/>
+          </a:lnRef>
+          <a:fillRef idx="3">
+            <a:schemeClr val="accent1"/>
+          </a:fillRef>
+          <a:effectRef idx="2">
+            <a:schemeClr val="accent1"/>
+          </a:effectRef>
+          <a:fontRef idx="minor">
+            <a:schemeClr val="lt1"/>
+          </a:fontRef>
+        </p:style>
+        <p:txBody>
+          <a:bodyPr rtlCol="0" anchor="ctr"/>
+          <a:lstStyle/>
+          <a:p>
+            <a:pPr algn="ctr"/>
+          </a:p>
+        </p:txBody>
+      </p:sp>
+      <p:sp>
+        <p:nvSpPr>
+          <p:cNvPr id="8" name="Rectangle 7"/>
+          <p:cNvSpPr/>
+          <p:nvPr/>
+        </p:nvSpPr>
+        <p:spPr>
+          <a:xfrm>
+            <a:off x="1536192" y="1216152"/>
+            <a:ext cx="329184" cy="50292"/>
+          </a:xfrm>
+          <a:prstGeom prst="rect">
+            <a:avLst/>
+          </a:prstGeom>
+          <a:solidFill>
+            <a:srgbClr val="E87BA4"/>
+          </a:solidFill>
+          <a:ln>
+            <a:noFill/>
+          </a:ln>
+          <a:effectLst/>
+        </p:spPr>
+        <p:style>
+          <a:lnRef idx="1">
+            <a:schemeClr val="accent1"/>
+          </a:lnRef>
+          <a:fillRef idx="3">
+            <a:schemeClr val="accent1"/>
+          </a:fillRef>
+          <a:effectRef idx="2">
+            <a:schemeClr val="accent1"/>
+          </a:effectRef>
+          <a:fontRef idx="minor">
+            <a:schemeClr val="lt1"/>
+          </a:fontRef>
+        </p:style>
+        <p:txBody>
+          <a:bodyPr rtlCol="0" anchor="ctr"/>
+          <a:lstStyle/>
+          <a:p>
+            <a:pPr algn="ctr"/>
+          </a:p>
+        </p:txBody>
+      </p:sp>
+      <p:sp>
+        <p:nvSpPr>
+          <p:cNvPr id="9" name="Rectangle 8"/>
+          <p:cNvSpPr/>
+          <p:nvPr/>
+        </p:nvSpPr>
+        <p:spPr>
+          <a:xfrm>
+            <a:off x="1865376" y="1216152"/>
+            <a:ext cx="329184" cy="50292"/>
+          </a:xfrm>
+          <a:prstGeom prst="rect">
+            <a:avLst/>
+          </a:prstGeom>
+          <a:solidFill>
+            <a:srgbClr val="1BAF7A"/>
+          </a:solidFill>
+          <a:ln>
+            <a:noFill/>
+          </a:ln>
+          <a:effectLst/>
+        </p:spPr>
+        <p:style>
+          <a:lnRef idx="1">
+            <a:schemeClr val="accent1"/>
+          </a:lnRef>
+          <a:fillRef idx="3">
+            <a:schemeClr val="accent1"/>
+          </a:fillRef>
+          <a:effectRef idx="2">
+            <a:schemeClr val="accent1"/>
+          </a:effectRef>
+          <a:fontRef idx="minor">
+            <a:schemeClr val="lt1"/>
+          </a:fontRef>
+        </p:style>
+        <p:txBody>
+          <a:bodyPr rtlCol="0" anchor="ctr"/>
+          <a:lstStyle/>
+          <a:p>
+            <a:pPr algn="ctr"/>
+          </a:p>
+        </p:txBody>
+      </p:sp>
+      <p:sp>
+        <p:nvSpPr>
+          <p:cNvPr id="10" name="Rectangle 9"/>
+          <p:cNvSpPr/>
+          <p:nvPr/>
+        </p:nvSpPr>
+        <p:spPr>
+          <a:xfrm>
+            <a:off x="2194560" y="1216152"/>
+            <a:ext cx="329184" cy="50292"/>
+          </a:xfrm>
+          <a:prstGeom prst="rect">
+            <a:avLst/>
+          </a:prstGeom>
+          <a:solidFill>
+            <a:srgbClr val="4A3AA7"/>
+          </a:solidFill>
+          <a:ln>
+            <a:noFill/>
+          </a:ln>
+          <a:effectLst/>
+        </p:spPr>
+        <p:style>
+          <a:lnRef idx="1">
+            <a:schemeClr val="accent1"/>
+          </a:lnRef>
+          <a:fillRef idx="3">
+            <a:schemeClr val="accent1"/>
+          </a:fillRef>
+          <a:effectRef idx="2">
+            <a:schemeClr val="accent1"/>
+          </a:effectRef>
+          <a:fontRef idx="minor">
+            <a:schemeClr val="lt1"/>
+          </a:fontRef>
+        </p:style>
+        <p:txBody>
+          <a:bodyPr rtlCol="0" anchor="ctr"/>
+          <a:lstStyle/>
+          <a:p>
+            <a:pPr algn="ctr"/>
+          </a:p>
+        </p:txBody>
+      </p:sp>
+      <p:sp>
+        <p:nvSpPr>
+          <p:cNvPr id="11" name="TextBox 10"/>
+          <p:cNvSpPr txBox="1"/>
+          <p:nvPr/>
+        </p:nvSpPr>
+        <p:spPr>
+          <a:xfrm>
+            <a:off x="548640" y="1463040"/>
+            <a:ext cx="11064240" cy="4846320"/>
+          </a:xfrm>
+          <a:prstGeom prst="rect">
+            <a:avLst/>
+          </a:prstGeom>
+          <a:noFill/>
+        </p:spPr>
+        <p:txBody>
+          <a:bodyPr wrap="square" anchor="ctr">
+            <a:spAutoFit/>
+          </a:bodyPr>
+          <a:lstStyle/>
           <a:p>
             <a:pPr algn="l" marL="256032" indent="-256032">
               <a:lnSpc>
@@ -11604,7 +12298,7 @@
                 </a:solidFill>
                 <a:latin typeface="Calibri"/>
               </a:rPr>
-              <a:t>Future: self-balancing price tree, edge decay in the graph, radix-compressed trie</a:t>
+              <a:t>Composition beats generality — six specialists, one O(1) source of truth</a:t>
             </a:r>
           </a:p>
           <a:p>
@@ -11629,7 +12323,7 @@
                 </a:solidFill>
                 <a:latin typeface="Calibri"/>
               </a:rPr>
-              <a:t>Code, tests, benchmarks, data: github.com/xhon-pelushi/2026-Summer-Algorithms-and-Data-Structures-MSCS-532-M20</a:t>
+              <a:t>Optimizations must be measured: resizing repaid 5×, the heap's textbook win didn't survive C vs interpreter</a:t>
             </a:r>
           </a:p>
           <a:p>
@@ -11648,6 +12342,81 @@
               <a:buChar char="▪"/>
             </a:pPr>
             <a:r>
+              <a:rPr sz="2000">
+                <a:solidFill>
+                  <a:srgbClr val="3A3F4A"/>
+                </a:solidFill>
+                <a:latin typeface="Calibri"/>
+              </a:rPr>
+              <a:t>Worst cases written down at design time became cheap tests</a:t>
+            </a:r>
+          </a:p>
+          <a:p>
+            <a:pPr algn="l" marL="256032" indent="-256032">
+              <a:lnSpc>
+                <a:spcPct val="104000"/>
+              </a:lnSpc>
+              <a:spcAft>
+                <a:spcPts val="1200"/>
+              </a:spcAft>
+              <a:buClr>
+                <a:srgbClr val="2C7BB6"/>
+              </a:buClr>
+              <a:buSzPct val="82000"/>
+              <a:buFont typeface="Arial"/>
+              <a:buChar char="▪"/>
+            </a:pPr>
+            <a:r>
+              <a:rPr sz="2000">
+                <a:solidFill>
+                  <a:srgbClr val="3A3F4A"/>
+                </a:solidFill>
+                <a:latin typeface="Calibri"/>
+              </a:rPr>
+              <a:t>Future: self-balancing price tree, edge decay in the graph, radix-compressed trie</a:t>
+            </a:r>
+          </a:p>
+          <a:p>
+            <a:pPr algn="l" marL="256032" indent="-256032">
+              <a:lnSpc>
+                <a:spcPct val="104000"/>
+              </a:lnSpc>
+              <a:spcAft>
+                <a:spcPts val="1200"/>
+              </a:spcAft>
+              <a:buClr>
+                <a:srgbClr val="2C7BB6"/>
+              </a:buClr>
+              <a:buSzPct val="82000"/>
+              <a:buFont typeface="Arial"/>
+              <a:buChar char="▪"/>
+            </a:pPr>
+            <a:r>
+              <a:rPr sz="2000">
+                <a:solidFill>
+                  <a:srgbClr val="3A3F4A"/>
+                </a:solidFill>
+                <a:latin typeface="Calibri"/>
+              </a:rPr>
+              <a:t>Code, tests, benchmarks, data: github.com/xhon-pelushi/2026-Summer-Algorithms-and-Data-Structures-MSCS-532-M20</a:t>
+            </a:r>
+          </a:p>
+          <a:p>
+            <a:pPr algn="l" marL="256032" indent="-256032">
+              <a:lnSpc>
+                <a:spcPct val="104000"/>
+              </a:lnSpc>
+              <a:spcAft>
+                <a:spcPts val="1200"/>
+              </a:spcAft>
+              <a:buClr>
+                <a:srgbClr val="2C7BB6"/>
+              </a:buClr>
+              <a:buSzPct val="82000"/>
+              <a:buFont typeface="Arial"/>
+              <a:buChar char="▪"/>
+            </a:pPr>
+            <a:r>
               <a:rPr sz="2000" b="1">
                 <a:solidFill>
                   <a:srgbClr val="2C7BB6"/>
@@ -11765,484 +12534,6 @@
               <a:defRPr sz="950">
                 <a:solidFill>
                   <a:srgbClr val="8A8984"/>
-                </a:solidFill>
-                <a:latin typeface="Calibri"/>
-              </a:defRPr>
-            </a:pPr>
-            <a:r>
-              <a:t>18</a:t>
-            </a:r>
-          </a:p>
-        </p:txBody>
-      </p:sp>
-    </p:spTree>
-  </p:cSld>
-  <p:clrMapOvr>
-    <a:masterClrMapping/>
-  </p:clrMapOvr>
-</p:sld>
-</file>
-
-<file path=ppt/slides/slide19.xml><?xml version="1.0" encoding="utf-8"?>
-<p:sld xmlns:a="http://schemas.openxmlformats.org/drawingml/2006/main" xmlns:p="http://schemas.openxmlformats.org/presentationml/2006/main" xmlns:r="http://schemas.openxmlformats.org/officeDocument/2006/relationships">
-  <p:cSld>
-    <p:bg>
-      <p:bgPr>
-        <a:solidFill>
-          <a:srgbClr val="1F2A44"/>
-        </a:solidFill>
-        <a:effectLst/>
-      </p:bgPr>
-    </p:bg>
-    <p:spTree>
-      <p:nvGrpSpPr>
-        <p:cNvPr id="1" name=""/>
-        <p:cNvGrpSpPr/>
-        <p:nvPr/>
-      </p:nvGrpSpPr>
-      <p:grpSpPr/>
-      <p:sp>
-        <p:nvSpPr>
-          <p:cNvPr id="2" name="TextBox 1"/>
-          <p:cNvSpPr txBox="1"/>
-          <p:nvPr/>
-        </p:nvSpPr>
-        <p:spPr>
-          <a:xfrm>
-            <a:off x="914400" y="2331720"/>
-            <a:ext cx="10360152" cy="1280160"/>
-          </a:xfrm>
-          <a:prstGeom prst="rect">
-            <a:avLst/>
-          </a:prstGeom>
-          <a:noFill/>
-        </p:spPr>
-        <p:txBody>
-          <a:bodyPr wrap="square">
-            <a:spAutoFit/>
-          </a:bodyPr>
-          <a:lstStyle/>
-          <a:p>
-            <a:pPr algn="ctr">
-              <a:defRPr sz="6600" b="1">
-                <a:solidFill>
-                  <a:srgbClr val="FFFFFF"/>
-                </a:solidFill>
-                <a:latin typeface="Calibri"/>
-              </a:defRPr>
-            </a:pPr>
-            <a:r>
-              <a:t>Demo time!</a:t>
-            </a:r>
-          </a:p>
-        </p:txBody>
-      </p:sp>
-      <p:sp>
-        <p:nvSpPr>
-          <p:cNvPr id="3" name="Rectangle 2"/>
-          <p:cNvSpPr/>
-          <p:nvPr/>
-        </p:nvSpPr>
-        <p:spPr>
-          <a:xfrm>
-            <a:off x="4724247" y="3794760"/>
-            <a:ext cx="457200" cy="64008"/>
-          </a:xfrm>
-          <a:prstGeom prst="rect">
-            <a:avLst/>
-          </a:prstGeom>
-          <a:solidFill>
-            <a:srgbClr val="2A78D6"/>
-          </a:solidFill>
-          <a:ln>
-            <a:noFill/>
-          </a:ln>
-          <a:effectLst/>
-        </p:spPr>
-        <p:style>
-          <a:lnRef idx="1">
-            <a:schemeClr val="accent1"/>
-          </a:lnRef>
-          <a:fillRef idx="3">
-            <a:schemeClr val="accent1"/>
-          </a:fillRef>
-          <a:effectRef idx="2">
-            <a:schemeClr val="accent1"/>
-          </a:effectRef>
-          <a:fontRef idx="minor">
-            <a:schemeClr val="lt1"/>
-          </a:fontRef>
-        </p:style>
-        <p:txBody>
-          <a:bodyPr rtlCol="0" anchor="ctr"/>
-          <a:lstStyle/>
-          <a:p>
-            <a:pPr algn="ctr"/>
-          </a:p>
-        </p:txBody>
-      </p:sp>
-      <p:sp>
-        <p:nvSpPr>
-          <p:cNvPr id="4" name="Rectangle 3"/>
-          <p:cNvSpPr/>
-          <p:nvPr/>
-        </p:nvSpPr>
-        <p:spPr>
-          <a:xfrm>
-            <a:off x="5181447" y="3794760"/>
-            <a:ext cx="457200" cy="64008"/>
-          </a:xfrm>
-          <a:prstGeom prst="rect">
-            <a:avLst/>
-          </a:prstGeom>
-          <a:solidFill>
-            <a:srgbClr val="008300"/>
-          </a:solidFill>
-          <a:ln>
-            <a:noFill/>
-          </a:ln>
-          <a:effectLst/>
-        </p:spPr>
-        <p:style>
-          <a:lnRef idx="1">
-            <a:schemeClr val="accent1"/>
-          </a:lnRef>
-          <a:fillRef idx="3">
-            <a:schemeClr val="accent1"/>
-          </a:fillRef>
-          <a:effectRef idx="2">
-            <a:schemeClr val="accent1"/>
-          </a:effectRef>
-          <a:fontRef idx="minor">
-            <a:schemeClr val="lt1"/>
-          </a:fontRef>
-        </p:style>
-        <p:txBody>
-          <a:bodyPr rtlCol="0" anchor="ctr"/>
-          <a:lstStyle/>
-          <a:p>
-            <a:pPr algn="ctr"/>
-          </a:p>
-        </p:txBody>
-      </p:sp>
-      <p:sp>
-        <p:nvSpPr>
-          <p:cNvPr id="5" name="Rectangle 4"/>
-          <p:cNvSpPr/>
-          <p:nvPr/>
-        </p:nvSpPr>
-        <p:spPr>
-          <a:xfrm>
-            <a:off x="5638647" y="3794760"/>
-            <a:ext cx="457200" cy="64008"/>
-          </a:xfrm>
-          <a:prstGeom prst="rect">
-            <a:avLst/>
-          </a:prstGeom>
-          <a:solidFill>
-            <a:srgbClr val="EB6834"/>
-          </a:solidFill>
-          <a:ln>
-            <a:noFill/>
-          </a:ln>
-          <a:effectLst/>
-        </p:spPr>
-        <p:style>
-          <a:lnRef idx="1">
-            <a:schemeClr val="accent1"/>
-          </a:lnRef>
-          <a:fillRef idx="3">
-            <a:schemeClr val="accent1"/>
-          </a:fillRef>
-          <a:effectRef idx="2">
-            <a:schemeClr val="accent1"/>
-          </a:effectRef>
-          <a:fontRef idx="minor">
-            <a:schemeClr val="lt1"/>
-          </a:fontRef>
-        </p:style>
-        <p:txBody>
-          <a:bodyPr rtlCol="0" anchor="ctr"/>
-          <a:lstStyle/>
-          <a:p>
-            <a:pPr algn="ctr"/>
-          </a:p>
-        </p:txBody>
-      </p:sp>
-      <p:sp>
-        <p:nvSpPr>
-          <p:cNvPr id="6" name="Rectangle 5"/>
-          <p:cNvSpPr/>
-          <p:nvPr/>
-        </p:nvSpPr>
-        <p:spPr>
-          <a:xfrm>
-            <a:off x="6095847" y="3794760"/>
-            <a:ext cx="457200" cy="64008"/>
-          </a:xfrm>
-          <a:prstGeom prst="rect">
-            <a:avLst/>
-          </a:prstGeom>
-          <a:solidFill>
-            <a:srgbClr val="E87BA4"/>
-          </a:solidFill>
-          <a:ln>
-            <a:noFill/>
-          </a:ln>
-          <a:effectLst/>
-        </p:spPr>
-        <p:style>
-          <a:lnRef idx="1">
-            <a:schemeClr val="accent1"/>
-          </a:lnRef>
-          <a:fillRef idx="3">
-            <a:schemeClr val="accent1"/>
-          </a:fillRef>
-          <a:effectRef idx="2">
-            <a:schemeClr val="accent1"/>
-          </a:effectRef>
-          <a:fontRef idx="minor">
-            <a:schemeClr val="lt1"/>
-          </a:fontRef>
-        </p:style>
-        <p:txBody>
-          <a:bodyPr rtlCol="0" anchor="ctr"/>
-          <a:lstStyle/>
-          <a:p>
-            <a:pPr algn="ctr"/>
-          </a:p>
-        </p:txBody>
-      </p:sp>
-      <p:sp>
-        <p:nvSpPr>
-          <p:cNvPr id="7" name="Rectangle 6"/>
-          <p:cNvSpPr/>
-          <p:nvPr/>
-        </p:nvSpPr>
-        <p:spPr>
-          <a:xfrm>
-            <a:off x="6553047" y="3794760"/>
-            <a:ext cx="457200" cy="64008"/>
-          </a:xfrm>
-          <a:prstGeom prst="rect">
-            <a:avLst/>
-          </a:prstGeom>
-          <a:solidFill>
-            <a:srgbClr val="1BAF7A"/>
-          </a:solidFill>
-          <a:ln>
-            <a:noFill/>
-          </a:ln>
-          <a:effectLst/>
-        </p:spPr>
-        <p:style>
-          <a:lnRef idx="1">
-            <a:schemeClr val="accent1"/>
-          </a:lnRef>
-          <a:fillRef idx="3">
-            <a:schemeClr val="accent1"/>
-          </a:fillRef>
-          <a:effectRef idx="2">
-            <a:schemeClr val="accent1"/>
-          </a:effectRef>
-          <a:fontRef idx="minor">
-            <a:schemeClr val="lt1"/>
-          </a:fontRef>
-        </p:style>
-        <p:txBody>
-          <a:bodyPr rtlCol="0" anchor="ctr"/>
-          <a:lstStyle/>
-          <a:p>
-            <a:pPr algn="ctr"/>
-          </a:p>
-        </p:txBody>
-      </p:sp>
-      <p:sp>
-        <p:nvSpPr>
-          <p:cNvPr id="8" name="Rectangle 7"/>
-          <p:cNvSpPr/>
-          <p:nvPr/>
-        </p:nvSpPr>
-        <p:spPr>
-          <a:xfrm>
-            <a:off x="7010247" y="3794760"/>
-            <a:ext cx="457200" cy="64008"/>
-          </a:xfrm>
-          <a:prstGeom prst="rect">
-            <a:avLst/>
-          </a:prstGeom>
-          <a:solidFill>
-            <a:srgbClr val="4A3AA7"/>
-          </a:solidFill>
-          <a:ln>
-            <a:noFill/>
-          </a:ln>
-          <a:effectLst/>
-        </p:spPr>
-        <p:style>
-          <a:lnRef idx="1">
-            <a:schemeClr val="accent1"/>
-          </a:lnRef>
-          <a:fillRef idx="3">
-            <a:schemeClr val="accent1"/>
-          </a:fillRef>
-          <a:effectRef idx="2">
-            <a:schemeClr val="accent1"/>
-          </a:effectRef>
-          <a:fontRef idx="minor">
-            <a:schemeClr val="lt1"/>
-          </a:fontRef>
-        </p:style>
-        <p:txBody>
-          <a:bodyPr rtlCol="0" anchor="ctr"/>
-          <a:lstStyle/>
-          <a:p>
-            <a:pPr algn="ctr"/>
-          </a:p>
-        </p:txBody>
-      </p:sp>
-      <p:sp>
-        <p:nvSpPr>
-          <p:cNvPr id="9" name="TextBox 8"/>
-          <p:cNvSpPr txBox="1"/>
-          <p:nvPr/>
-        </p:nvSpPr>
-        <p:spPr>
-          <a:xfrm>
-            <a:off x="914400" y="4069080"/>
-            <a:ext cx="10360152" cy="457200"/>
-          </a:xfrm>
-          <a:prstGeom prst="rect">
-            <a:avLst/>
-          </a:prstGeom>
-          <a:noFill/>
-        </p:spPr>
-        <p:txBody>
-          <a:bodyPr wrap="square">
-            <a:spAutoFit/>
-          </a:bodyPr>
-          <a:lstStyle/>
-          <a:p>
-            <a:pPr algn="ctr">
-              <a:defRPr sz="1800">
-                <a:solidFill>
-                  <a:srgbClr val="9FB3D1"/>
-                </a:solidFill>
-                <a:latin typeface="Calibri"/>
-              </a:defRPr>
-            </a:pPr>
-            <a:r>
-              <a:t>the portal, live — http://localhost:8000</a:t>
-            </a:r>
-          </a:p>
-        </p:txBody>
-      </p:sp>
-      <p:sp>
-        <p:nvSpPr>
-          <p:cNvPr id="10" name="Rectangle 9"/>
-          <p:cNvSpPr/>
-          <p:nvPr/>
-        </p:nvSpPr>
-        <p:spPr>
-          <a:xfrm>
-            <a:off x="548640" y="6455664"/>
-            <a:ext cx="11091672" cy="10972"/>
-          </a:xfrm>
-          <a:prstGeom prst="rect">
-            <a:avLst/>
-          </a:prstGeom>
-          <a:solidFill>
-            <a:srgbClr val="3A4A6E"/>
-          </a:solidFill>
-          <a:ln>
-            <a:noFill/>
-          </a:ln>
-          <a:effectLst/>
-        </p:spPr>
-        <p:style>
-          <a:lnRef idx="1">
-            <a:schemeClr val="accent1"/>
-          </a:lnRef>
-          <a:fillRef idx="3">
-            <a:schemeClr val="accent1"/>
-          </a:fillRef>
-          <a:effectRef idx="2">
-            <a:schemeClr val="accent1"/>
-          </a:effectRef>
-          <a:fontRef idx="minor">
-            <a:schemeClr val="lt1"/>
-          </a:fontRef>
-        </p:style>
-        <p:txBody>
-          <a:bodyPr rtlCol="0" anchor="ctr"/>
-          <a:lstStyle/>
-          <a:p>
-            <a:pPr algn="ctr"/>
-          </a:p>
-        </p:txBody>
-      </p:sp>
-      <p:sp>
-        <p:nvSpPr>
-          <p:cNvPr id="11" name="TextBox 10"/>
-          <p:cNvSpPr txBox="1"/>
-          <p:nvPr/>
-        </p:nvSpPr>
-        <p:spPr>
-          <a:xfrm>
-            <a:off x="548640" y="6510528"/>
-            <a:ext cx="8229600" cy="274320"/>
-          </a:xfrm>
-          <a:prstGeom prst="rect">
-            <a:avLst/>
-          </a:prstGeom>
-          <a:noFill/>
-        </p:spPr>
-        <p:txBody>
-          <a:bodyPr wrap="square">
-            <a:spAutoFit/>
-          </a:bodyPr>
-          <a:lstStyle/>
-          <a:p>
-            <a:pPr algn="l">
-              <a:defRPr sz="950">
-                <a:solidFill>
-                  <a:srgbClr val="9FB3D1"/>
-                </a:solidFill>
-                <a:latin typeface="Calibri"/>
-              </a:defRPr>
-            </a:pPr>
-            <a:r>
-              <a:t>MSCS-532 · Group 2 — E-Commerce Order Platform</a:t>
-            </a:r>
-          </a:p>
-        </p:txBody>
-      </p:sp>
-      <p:sp>
-        <p:nvSpPr>
-          <p:cNvPr id="12" name="TextBox 11"/>
-          <p:cNvSpPr txBox="1"/>
-          <p:nvPr/>
-        </p:nvSpPr>
-        <p:spPr>
-          <a:xfrm>
-            <a:off x="10972800" y="6510528"/>
-            <a:ext cx="667512" cy="274320"/>
-          </a:xfrm>
-          <a:prstGeom prst="rect">
-            <a:avLst/>
-          </a:prstGeom>
-          <a:noFill/>
-        </p:spPr>
-        <p:txBody>
-          <a:bodyPr wrap="square">
-            <a:spAutoFit/>
-          </a:bodyPr>
-          <a:lstStyle/>
-          <a:p>
-            <a:pPr algn="r">
-              <a:defRPr sz="950">
-                <a:solidFill>
-                  <a:srgbClr val="9FB3D1"/>
                 </a:solidFill>
                 <a:latin typeface="Calibri"/>
               </a:defRPr>
@@ -13005,6 +13296,484 @@
 </p:sld>
 </file>
 
+<file path=ppt/slides/slide20.xml><?xml version="1.0" encoding="utf-8"?>
+<p:sld xmlns:a="http://schemas.openxmlformats.org/drawingml/2006/main" xmlns:p="http://schemas.openxmlformats.org/presentationml/2006/main" xmlns:r="http://schemas.openxmlformats.org/officeDocument/2006/relationships">
+  <p:cSld>
+    <p:bg>
+      <p:bgPr>
+        <a:solidFill>
+          <a:srgbClr val="1F2A44"/>
+        </a:solidFill>
+        <a:effectLst/>
+      </p:bgPr>
+    </p:bg>
+    <p:spTree>
+      <p:nvGrpSpPr>
+        <p:cNvPr id="1" name=""/>
+        <p:cNvGrpSpPr/>
+        <p:nvPr/>
+      </p:nvGrpSpPr>
+      <p:grpSpPr/>
+      <p:sp>
+        <p:nvSpPr>
+          <p:cNvPr id="2" name="TextBox 1"/>
+          <p:cNvSpPr txBox="1"/>
+          <p:nvPr/>
+        </p:nvSpPr>
+        <p:spPr>
+          <a:xfrm>
+            <a:off x="914400" y="2331720"/>
+            <a:ext cx="10360152" cy="1280160"/>
+          </a:xfrm>
+          <a:prstGeom prst="rect">
+            <a:avLst/>
+          </a:prstGeom>
+          <a:noFill/>
+        </p:spPr>
+        <p:txBody>
+          <a:bodyPr wrap="square">
+            <a:spAutoFit/>
+          </a:bodyPr>
+          <a:lstStyle/>
+          <a:p>
+            <a:pPr algn="ctr">
+              <a:defRPr sz="6600" b="1">
+                <a:solidFill>
+                  <a:srgbClr val="FFFFFF"/>
+                </a:solidFill>
+                <a:latin typeface="Calibri"/>
+              </a:defRPr>
+            </a:pPr>
+            <a:r>
+              <a:t>Demo time!</a:t>
+            </a:r>
+          </a:p>
+        </p:txBody>
+      </p:sp>
+      <p:sp>
+        <p:nvSpPr>
+          <p:cNvPr id="3" name="Rectangle 2"/>
+          <p:cNvSpPr/>
+          <p:nvPr/>
+        </p:nvSpPr>
+        <p:spPr>
+          <a:xfrm>
+            <a:off x="4724247" y="3794760"/>
+            <a:ext cx="457200" cy="64008"/>
+          </a:xfrm>
+          <a:prstGeom prst="rect">
+            <a:avLst/>
+          </a:prstGeom>
+          <a:solidFill>
+            <a:srgbClr val="2A78D6"/>
+          </a:solidFill>
+          <a:ln>
+            <a:noFill/>
+          </a:ln>
+          <a:effectLst/>
+        </p:spPr>
+        <p:style>
+          <a:lnRef idx="1">
+            <a:schemeClr val="accent1"/>
+          </a:lnRef>
+          <a:fillRef idx="3">
+            <a:schemeClr val="accent1"/>
+          </a:fillRef>
+          <a:effectRef idx="2">
+            <a:schemeClr val="accent1"/>
+          </a:effectRef>
+          <a:fontRef idx="minor">
+            <a:schemeClr val="lt1"/>
+          </a:fontRef>
+        </p:style>
+        <p:txBody>
+          <a:bodyPr rtlCol="0" anchor="ctr"/>
+          <a:lstStyle/>
+          <a:p>
+            <a:pPr algn="ctr"/>
+          </a:p>
+        </p:txBody>
+      </p:sp>
+      <p:sp>
+        <p:nvSpPr>
+          <p:cNvPr id="4" name="Rectangle 3"/>
+          <p:cNvSpPr/>
+          <p:nvPr/>
+        </p:nvSpPr>
+        <p:spPr>
+          <a:xfrm>
+            <a:off x="5181447" y="3794760"/>
+            <a:ext cx="457200" cy="64008"/>
+          </a:xfrm>
+          <a:prstGeom prst="rect">
+            <a:avLst/>
+          </a:prstGeom>
+          <a:solidFill>
+            <a:srgbClr val="008300"/>
+          </a:solidFill>
+          <a:ln>
+            <a:noFill/>
+          </a:ln>
+          <a:effectLst/>
+        </p:spPr>
+        <p:style>
+          <a:lnRef idx="1">
+            <a:schemeClr val="accent1"/>
+          </a:lnRef>
+          <a:fillRef idx="3">
+            <a:schemeClr val="accent1"/>
+          </a:fillRef>
+          <a:effectRef idx="2">
+            <a:schemeClr val="accent1"/>
+          </a:effectRef>
+          <a:fontRef idx="minor">
+            <a:schemeClr val="lt1"/>
+          </a:fontRef>
+        </p:style>
+        <p:txBody>
+          <a:bodyPr rtlCol="0" anchor="ctr"/>
+          <a:lstStyle/>
+          <a:p>
+            <a:pPr algn="ctr"/>
+          </a:p>
+        </p:txBody>
+      </p:sp>
+      <p:sp>
+        <p:nvSpPr>
+          <p:cNvPr id="5" name="Rectangle 4"/>
+          <p:cNvSpPr/>
+          <p:nvPr/>
+        </p:nvSpPr>
+        <p:spPr>
+          <a:xfrm>
+            <a:off x="5638647" y="3794760"/>
+            <a:ext cx="457200" cy="64008"/>
+          </a:xfrm>
+          <a:prstGeom prst="rect">
+            <a:avLst/>
+          </a:prstGeom>
+          <a:solidFill>
+            <a:srgbClr val="EB6834"/>
+          </a:solidFill>
+          <a:ln>
+            <a:noFill/>
+          </a:ln>
+          <a:effectLst/>
+        </p:spPr>
+        <p:style>
+          <a:lnRef idx="1">
+            <a:schemeClr val="accent1"/>
+          </a:lnRef>
+          <a:fillRef idx="3">
+            <a:schemeClr val="accent1"/>
+          </a:fillRef>
+          <a:effectRef idx="2">
+            <a:schemeClr val="accent1"/>
+          </a:effectRef>
+          <a:fontRef idx="minor">
+            <a:schemeClr val="lt1"/>
+          </a:fontRef>
+        </p:style>
+        <p:txBody>
+          <a:bodyPr rtlCol="0" anchor="ctr"/>
+          <a:lstStyle/>
+          <a:p>
+            <a:pPr algn="ctr"/>
+          </a:p>
+        </p:txBody>
+      </p:sp>
+      <p:sp>
+        <p:nvSpPr>
+          <p:cNvPr id="6" name="Rectangle 5"/>
+          <p:cNvSpPr/>
+          <p:nvPr/>
+        </p:nvSpPr>
+        <p:spPr>
+          <a:xfrm>
+            <a:off x="6095847" y="3794760"/>
+            <a:ext cx="457200" cy="64008"/>
+          </a:xfrm>
+          <a:prstGeom prst="rect">
+            <a:avLst/>
+          </a:prstGeom>
+          <a:solidFill>
+            <a:srgbClr val="E87BA4"/>
+          </a:solidFill>
+          <a:ln>
+            <a:noFill/>
+          </a:ln>
+          <a:effectLst/>
+        </p:spPr>
+        <p:style>
+          <a:lnRef idx="1">
+            <a:schemeClr val="accent1"/>
+          </a:lnRef>
+          <a:fillRef idx="3">
+            <a:schemeClr val="accent1"/>
+          </a:fillRef>
+          <a:effectRef idx="2">
+            <a:schemeClr val="accent1"/>
+          </a:effectRef>
+          <a:fontRef idx="minor">
+            <a:schemeClr val="lt1"/>
+          </a:fontRef>
+        </p:style>
+        <p:txBody>
+          <a:bodyPr rtlCol="0" anchor="ctr"/>
+          <a:lstStyle/>
+          <a:p>
+            <a:pPr algn="ctr"/>
+          </a:p>
+        </p:txBody>
+      </p:sp>
+      <p:sp>
+        <p:nvSpPr>
+          <p:cNvPr id="7" name="Rectangle 6"/>
+          <p:cNvSpPr/>
+          <p:nvPr/>
+        </p:nvSpPr>
+        <p:spPr>
+          <a:xfrm>
+            <a:off x="6553047" y="3794760"/>
+            <a:ext cx="457200" cy="64008"/>
+          </a:xfrm>
+          <a:prstGeom prst="rect">
+            <a:avLst/>
+          </a:prstGeom>
+          <a:solidFill>
+            <a:srgbClr val="1BAF7A"/>
+          </a:solidFill>
+          <a:ln>
+            <a:noFill/>
+          </a:ln>
+          <a:effectLst/>
+        </p:spPr>
+        <p:style>
+          <a:lnRef idx="1">
+            <a:schemeClr val="accent1"/>
+          </a:lnRef>
+          <a:fillRef idx="3">
+            <a:schemeClr val="accent1"/>
+          </a:fillRef>
+          <a:effectRef idx="2">
+            <a:schemeClr val="accent1"/>
+          </a:effectRef>
+          <a:fontRef idx="minor">
+            <a:schemeClr val="lt1"/>
+          </a:fontRef>
+        </p:style>
+        <p:txBody>
+          <a:bodyPr rtlCol="0" anchor="ctr"/>
+          <a:lstStyle/>
+          <a:p>
+            <a:pPr algn="ctr"/>
+          </a:p>
+        </p:txBody>
+      </p:sp>
+      <p:sp>
+        <p:nvSpPr>
+          <p:cNvPr id="8" name="Rectangle 7"/>
+          <p:cNvSpPr/>
+          <p:nvPr/>
+        </p:nvSpPr>
+        <p:spPr>
+          <a:xfrm>
+            <a:off x="7010247" y="3794760"/>
+            <a:ext cx="457200" cy="64008"/>
+          </a:xfrm>
+          <a:prstGeom prst="rect">
+            <a:avLst/>
+          </a:prstGeom>
+          <a:solidFill>
+            <a:srgbClr val="4A3AA7"/>
+          </a:solidFill>
+          <a:ln>
+            <a:noFill/>
+          </a:ln>
+          <a:effectLst/>
+        </p:spPr>
+        <p:style>
+          <a:lnRef idx="1">
+            <a:schemeClr val="accent1"/>
+          </a:lnRef>
+          <a:fillRef idx="3">
+            <a:schemeClr val="accent1"/>
+          </a:fillRef>
+          <a:effectRef idx="2">
+            <a:schemeClr val="accent1"/>
+          </a:effectRef>
+          <a:fontRef idx="minor">
+            <a:schemeClr val="lt1"/>
+          </a:fontRef>
+        </p:style>
+        <p:txBody>
+          <a:bodyPr rtlCol="0" anchor="ctr"/>
+          <a:lstStyle/>
+          <a:p>
+            <a:pPr algn="ctr"/>
+          </a:p>
+        </p:txBody>
+      </p:sp>
+      <p:sp>
+        <p:nvSpPr>
+          <p:cNvPr id="9" name="TextBox 8"/>
+          <p:cNvSpPr txBox="1"/>
+          <p:nvPr/>
+        </p:nvSpPr>
+        <p:spPr>
+          <a:xfrm>
+            <a:off x="914400" y="4069080"/>
+            <a:ext cx="10360152" cy="457200"/>
+          </a:xfrm>
+          <a:prstGeom prst="rect">
+            <a:avLst/>
+          </a:prstGeom>
+          <a:noFill/>
+        </p:spPr>
+        <p:txBody>
+          <a:bodyPr wrap="square">
+            <a:spAutoFit/>
+          </a:bodyPr>
+          <a:lstStyle/>
+          <a:p>
+            <a:pPr algn="ctr">
+              <a:defRPr sz="1800">
+                <a:solidFill>
+                  <a:srgbClr val="9FB3D1"/>
+                </a:solidFill>
+                <a:latin typeface="Calibri"/>
+              </a:defRPr>
+            </a:pPr>
+            <a:r>
+              <a:t>the portal, live — http://localhost:8000</a:t>
+            </a:r>
+          </a:p>
+        </p:txBody>
+      </p:sp>
+      <p:sp>
+        <p:nvSpPr>
+          <p:cNvPr id="10" name="Rectangle 9"/>
+          <p:cNvSpPr/>
+          <p:nvPr/>
+        </p:nvSpPr>
+        <p:spPr>
+          <a:xfrm>
+            <a:off x="548640" y="6455664"/>
+            <a:ext cx="11091672" cy="10972"/>
+          </a:xfrm>
+          <a:prstGeom prst="rect">
+            <a:avLst/>
+          </a:prstGeom>
+          <a:solidFill>
+            <a:srgbClr val="3A4A6E"/>
+          </a:solidFill>
+          <a:ln>
+            <a:noFill/>
+          </a:ln>
+          <a:effectLst/>
+        </p:spPr>
+        <p:style>
+          <a:lnRef idx="1">
+            <a:schemeClr val="accent1"/>
+          </a:lnRef>
+          <a:fillRef idx="3">
+            <a:schemeClr val="accent1"/>
+          </a:fillRef>
+          <a:effectRef idx="2">
+            <a:schemeClr val="accent1"/>
+          </a:effectRef>
+          <a:fontRef idx="minor">
+            <a:schemeClr val="lt1"/>
+          </a:fontRef>
+        </p:style>
+        <p:txBody>
+          <a:bodyPr rtlCol="0" anchor="ctr"/>
+          <a:lstStyle/>
+          <a:p>
+            <a:pPr algn="ctr"/>
+          </a:p>
+        </p:txBody>
+      </p:sp>
+      <p:sp>
+        <p:nvSpPr>
+          <p:cNvPr id="11" name="TextBox 10"/>
+          <p:cNvSpPr txBox="1"/>
+          <p:nvPr/>
+        </p:nvSpPr>
+        <p:spPr>
+          <a:xfrm>
+            <a:off x="548640" y="6510528"/>
+            <a:ext cx="8229600" cy="274320"/>
+          </a:xfrm>
+          <a:prstGeom prst="rect">
+            <a:avLst/>
+          </a:prstGeom>
+          <a:noFill/>
+        </p:spPr>
+        <p:txBody>
+          <a:bodyPr wrap="square">
+            <a:spAutoFit/>
+          </a:bodyPr>
+          <a:lstStyle/>
+          <a:p>
+            <a:pPr algn="l">
+              <a:defRPr sz="950">
+                <a:solidFill>
+                  <a:srgbClr val="9FB3D1"/>
+                </a:solidFill>
+                <a:latin typeface="Calibri"/>
+              </a:defRPr>
+            </a:pPr>
+            <a:r>
+              <a:t>MSCS-532 · Group 2 — E-Commerce Order Platform</a:t>
+            </a:r>
+          </a:p>
+        </p:txBody>
+      </p:sp>
+      <p:sp>
+        <p:nvSpPr>
+          <p:cNvPr id="12" name="TextBox 11"/>
+          <p:cNvSpPr txBox="1"/>
+          <p:nvPr/>
+        </p:nvSpPr>
+        <p:spPr>
+          <a:xfrm>
+            <a:off x="10972800" y="6510528"/>
+            <a:ext cx="667512" cy="274320"/>
+          </a:xfrm>
+          <a:prstGeom prst="rect">
+            <a:avLst/>
+          </a:prstGeom>
+          <a:noFill/>
+        </p:spPr>
+        <p:txBody>
+          <a:bodyPr wrap="square">
+            <a:spAutoFit/>
+          </a:bodyPr>
+          <a:lstStyle/>
+          <a:p>
+            <a:pPr algn="r">
+              <a:defRPr sz="950">
+                <a:solidFill>
+                  <a:srgbClr val="9FB3D1"/>
+                </a:solidFill>
+                <a:latin typeface="Calibri"/>
+              </a:defRPr>
+            </a:pPr>
+            <a:r>
+              <a:t>20</a:t>
+            </a:r>
+          </a:p>
+        </p:txBody>
+      </p:sp>
+    </p:spTree>
+  </p:cSld>
+  <p:clrMapOvr>
+    <a:masterClrMapping/>
+  </p:clrMapOvr>
+</p:sld>
+</file>
+
 <file path=ppt/slides/slide3.xml><?xml version="1.0" encoding="utf-8"?>
 <p:sld xmlns:a="http://schemas.openxmlformats.org/drawingml/2006/main" xmlns:p="http://schemas.openxmlformats.org/presentationml/2006/main" xmlns:r="http://schemas.openxmlformats.org/officeDocument/2006/relationships">
   <p:cSld>
@@ -14595,7 +15364,7 @@
                 </a:solidFill>
                 <a:latin typeface="Calibri"/>
               </a:rPr>
-              <a:t>03 · PROOF OF CONCEPT</a:t>
+              <a:t>02 · DESIGN</a:t>
             </a:r>
           </a:p>
         </p:txBody>
@@ -14631,7 +15400,7 @@
               </a:defRPr>
             </a:pPr>
             <a:r>
-              <a:t>Proof of Concept: One Scripted Session, End to End</a:t>
+              <a:t>The Whole System on One Page</a:t>
             </a:r>
           </a:p>
         </p:txBody>
@@ -14946,7 +15715,7 @@
       </p:sp>
       <p:pic>
         <p:nvPicPr>
-          <p:cNvPr id="11" name="Picture 10" descr="screenshot_demo_part2.png"/>
+          <p:cNvPr id="11" name="Picture 10" descr="diagram_architecture.png"/>
           <p:cNvPicPr>
             <a:picLocks noChangeAspect="1"/>
           </p:cNvPicPr>
@@ -14960,8 +15729,8 @@
         </p:blipFill>
         <p:spPr>
           <a:xfrm>
-            <a:off x="2072487" y="1805548"/>
-            <a:ext cx="8046720" cy="4161304"/>
+            <a:off x="2758287" y="1502228"/>
+            <a:ext cx="6675120" cy="4767943"/>
           </a:xfrm>
           <a:prstGeom prst="rect">
             <a:avLst/>
@@ -15145,7 +15914,7 @@
                 </a:solidFill>
                 <a:latin typeface="Calibri"/>
               </a:rPr>
-              <a:t>04 · LIVE PORTAL</a:t>
+              <a:t>03 · PROOF OF CONCEPT</a:t>
             </a:r>
           </a:p>
         </p:txBody>
@@ -15181,7 +15950,7 @@
               </a:defRPr>
             </a:pPr>
             <a:r>
-              <a:t>Proof of Concept, Live: The Browser Portal</a:t>
+              <a:t>Proof of Concept: One Scripted Session, End to End</a:t>
             </a:r>
           </a:p>
         </p:txBody>
@@ -15496,7 +16265,7 @@
       </p:sp>
       <p:pic>
         <p:nvPicPr>
-          <p:cNvPr id="11" name="Picture 10" descr="screenshot_portal_slide.png"/>
+          <p:cNvPr id="11" name="Picture 10" descr="screenshot_demo_part2.png"/>
           <p:cNvPicPr>
             <a:picLocks noChangeAspect="1"/>
           </p:cNvPicPr>
@@ -15510,8 +16279,8 @@
         </p:blipFill>
         <p:spPr>
           <a:xfrm>
-            <a:off x="1386873" y="1463040"/>
-            <a:ext cx="9417948" cy="4846320"/>
+            <a:off x="2072487" y="1805548"/>
+            <a:ext cx="8046720" cy="4161304"/>
           </a:xfrm>
           <a:prstGeom prst="rect">
             <a:avLst/>
@@ -15731,7 +16500,7 @@
               </a:defRPr>
             </a:pPr>
             <a:r>
-              <a:t>Portal Metrics: The Structures' Vital Signs</a:t>
+              <a:t>Proof of Concept, Live: The Browser Portal</a:t>
             </a:r>
           </a:p>
         </p:txBody>
@@ -16046,7 +16815,7 @@
       </p:sp>
       <p:pic>
         <p:nvPicPr>
-          <p:cNvPr id="11" name="Picture 10" descr="panel_stats.png"/>
+          <p:cNvPr id="11" name="Picture 10" descr="screenshot_portal_slide.png"/>
           <p:cNvPicPr>
             <a:picLocks noChangeAspect="1"/>
           </p:cNvPicPr>
@@ -16060,8 +16829,8 @@
         </p:blipFill>
         <p:spPr>
           <a:xfrm>
-            <a:off x="1066647" y="1417320"/>
-            <a:ext cx="10058400" cy="857513"/>
+            <a:off x="1386873" y="1463040"/>
+            <a:ext cx="9417948" cy="4846320"/>
           </a:xfrm>
           <a:prstGeom prst="rect">
             <a:avLst/>
@@ -16075,155 +16844,7 @@
       </p:pic>
       <p:sp>
         <p:nvSpPr>
-          <p:cNvPr id="12" name="TextBox 11"/>
-          <p:cNvSpPr txBox="1"/>
-          <p:nvPr/>
-        </p:nvSpPr>
-        <p:spPr>
-          <a:xfrm>
-            <a:off x="822960" y="2457713"/>
-            <a:ext cx="10515600" cy="3897367"/>
-          </a:xfrm>
-          <a:prstGeom prst="rect">
-            <a:avLst/>
-          </a:prstGeom>
-          <a:noFill/>
-        </p:spPr>
-        <p:txBody>
-          <a:bodyPr wrap="square">
-            <a:spAutoFit/>
-          </a:bodyPr>
-          <a:lstStyle/>
-          <a:p>
-            <a:pPr algn="l" marL="256032" indent="-256032">
-              <a:lnSpc>
-                <a:spcPct val="104000"/>
-              </a:lnSpc>
-              <a:spcAft>
-                <a:spcPts val="700"/>
-              </a:spcAft>
-              <a:buClr>
-                <a:srgbClr val="2C7BB6"/>
-              </a:buClr>
-              <a:buSzPct val="82000"/>
-              <a:buFont typeface="Arial"/>
-              <a:buChar char="▪"/>
-            </a:pPr>
-            <a:r>
-              <a:rPr sz="1800">
-                <a:solidFill>
-                  <a:srgbClr val="3A3F4A"/>
-                </a:solidFill>
-                <a:latin typeface="Calibri"/>
-              </a:rPr>
-              <a:t>Live diagnostics, one tile per structure — color-coded to its panel</a:t>
-            </a:r>
-          </a:p>
-          <a:p>
-            <a:pPr algn="l" marL="256032" indent="-256032">
-              <a:lnSpc>
-                <a:spcPct val="104000"/>
-              </a:lnSpc>
-              <a:spcAft>
-                <a:spcPts val="700"/>
-              </a:spcAft>
-              <a:buClr>
-                <a:srgbClr val="2C7BB6"/>
-              </a:buClr>
-              <a:buSzPct val="82000"/>
-              <a:buFont typeface="Arial"/>
-              <a:buChar char="▪"/>
-            </a:pPr>
-            <a:r>
-              <a:rPr sz="1800">
-                <a:solidFill>
-                  <a:srgbClr val="3A3F4A"/>
-                </a:solidFill>
-                <a:latin typeface="Calibri"/>
-              </a:rPr>
-              <a:t>Load factor 0.23 = 15 records / 64 buckets — doubling past 0.75 is what keeps lookups O(1)</a:t>
-            </a:r>
-          </a:p>
-          <a:p>
-            <a:pPr algn="l" marL="256032" indent="-256032">
-              <a:lnSpc>
-                <a:spcPct val="104000"/>
-              </a:lnSpc>
-              <a:spcAft>
-                <a:spcPts val="700"/>
-              </a:spcAft>
-              <a:buClr>
-                <a:srgbClr val="2C7BB6"/>
-              </a:buClr>
-              <a:buSzPct val="82000"/>
-              <a:buFont typeface="Arial"/>
-              <a:buChar char="▪"/>
-            </a:pPr>
-            <a:r>
-              <a:rPr sz="1800">
-                <a:solidFill>
-                  <a:srgbClr val="3A3F4A"/>
-                </a:solidFill>
-                <a:latin typeface="Calibri"/>
-              </a:rPr>
-              <a:t>Max chain 1 — FNV-1a spreads keys well (111 when resizing is disabled at 100k products)</a:t>
-            </a:r>
-          </a:p>
-          <a:p>
-            <a:pPr algn="l" marL="256032" indent="-256032">
-              <a:lnSpc>
-                <a:spcPct val="104000"/>
-              </a:lnSpc>
-              <a:spcAft>
-                <a:spcPts val="700"/>
-              </a:spcAft>
-              <a:buClr>
-                <a:srgbClr val="2C7BB6"/>
-              </a:buClr>
-              <a:buSzPct val="82000"/>
-              <a:buFont typeface="Arial"/>
-              <a:buChar char="▪"/>
-            </a:pPr>
-            <a:r>
-              <a:rPr sz="1800">
-                <a:solidFill>
-                  <a:srgbClr val="3A3F4A"/>
-                </a:solidFill>
-                <a:latin typeface="Calibri"/>
-              </a:rPr>
-              <a:t>BST height 5 vs ~4 ideal — near-balanced; sorted inserts would make it 15</a:t>
-            </a:r>
-          </a:p>
-          <a:p>
-            <a:pPr algn="l" marL="256032" indent="-256032">
-              <a:lnSpc>
-                <a:spcPct val="104000"/>
-              </a:lnSpc>
-              <a:spcAft>
-                <a:spcPts val="700"/>
-              </a:spcAft>
-              <a:buClr>
-                <a:srgbClr val="2C7BB6"/>
-              </a:buClr>
-              <a:buSzPct val="82000"/>
-              <a:buFont typeface="Arial"/>
-              <a:buChar char="▪"/>
-            </a:pPr>
-            <a:r>
-              <a:rPr sz="1800">
-                <a:solidFill>
-                  <a:srgbClr val="3A3F4A"/>
-                </a:solidFill>
-                <a:latin typeface="Calibri"/>
-              </a:rPr>
-              <a:t>148 trie nodes — shared prefixes stored once; 7 graph edges grow with every fulfilled order</a:t>
-            </a:r>
-          </a:p>
-        </p:txBody>
-      </p:sp>
-      <p:sp>
-        <p:nvSpPr>
-          <p:cNvPr id="13" name="Rectangle 12"/>
+          <p:cNvPr id="12" name="Rectangle 11"/>
           <p:cNvSpPr/>
           <p:nvPr/>
         </p:nvSpPr>
@@ -16267,7 +16888,7 @@
       </p:sp>
       <p:sp>
         <p:nvSpPr>
-          <p:cNvPr id="14" name="TextBox 13"/>
+          <p:cNvPr id="13" name="TextBox 12"/>
           <p:cNvSpPr txBox="1"/>
           <p:nvPr/>
         </p:nvSpPr>
@@ -16303,7 +16924,7 @@
       </p:sp>
       <p:sp>
         <p:nvSpPr>
-          <p:cNvPr id="15" name="TextBox 14"/>
+          <p:cNvPr id="14" name="TextBox 13"/>
           <p:cNvSpPr txBox="1"/>
           <p:nvPr/>
         </p:nvSpPr>
@@ -16421,7 +17042,7 @@
           <a:lstStyle/>
           <a:p>
             <a:pPr algn="l">
-              <a:defRPr sz="2600" b="1">
+              <a:defRPr sz="2900" b="1">
                 <a:solidFill>
                   <a:srgbClr val="1F2A44"/>
                 </a:solidFill>
@@ -16429,7 +17050,7 @@
               </a:defRPr>
             </a:pPr>
             <a:r>
-              <a:t>Live Search Is a Trie Walk; the Filter Is a Pruned BST</a:t>
+              <a:t>Portal Metrics: The Structures' Vital Signs</a:t>
             </a:r>
           </a:p>
         </p:txBody>
@@ -16744,7 +17365,7 @@
       </p:sp>
       <p:pic>
         <p:nvPicPr>
-          <p:cNvPr id="11" name="Picture 10" descr="panel_search_price.png"/>
+          <p:cNvPr id="11" name="Picture 10" descr="panel_stats.png"/>
           <p:cNvPicPr>
             <a:picLocks noChangeAspect="1"/>
           </p:cNvPicPr>
@@ -16758,8 +17379,8 @@
         </p:blipFill>
         <p:spPr>
           <a:xfrm>
-            <a:off x="563727" y="1417320"/>
-            <a:ext cx="11064240" cy="1208164"/>
+            <a:off x="1066647" y="1417320"/>
+            <a:ext cx="10058400" cy="857513"/>
           </a:xfrm>
           <a:prstGeom prst="rect">
             <a:avLst/>
@@ -16779,8 +17400,8 @@
         </p:nvSpPr>
         <p:spPr>
           <a:xfrm>
-            <a:off x="822960" y="2808364"/>
-            <a:ext cx="10515600" cy="3546716"/>
+            <a:off x="822960" y="2457713"/>
+            <a:ext cx="10515600" cy="3897367"/>
           </a:xfrm>
           <a:prstGeom prst="rect">
             <a:avLst/>
@@ -16814,7 +17435,7 @@
                 </a:solidFill>
                 <a:latin typeface="Calibri"/>
               </a:rPr>
-              <a:t>Every keystroke = one prefix walk — cost grows with the prefix, never with the catalog</a:t>
+              <a:t>Live diagnostics, one tile per structure — color-coded to its panel</a:t>
             </a:r>
           </a:p>
           <a:p>
@@ -16839,7 +17460,7 @@
                 </a:solidFill>
                 <a:latin typeface="Calibri"/>
               </a:rPr>
-              <a:t>“wireless key” = two walks intersected → only the Wireless Keyboard survives both</a:t>
+              <a:t>Load factor 0.23 = 15 records / 64 buckets — doubling past 0.75 is what keeps lookups O(1)</a:t>
             </a:r>
           </a:p>
           <a:p>
@@ -16864,7 +17485,7 @@
                 </a:solidFill>
                 <a:latin typeface="Calibri"/>
               </a:rPr>
-              <a:t>$15–$50 = pruned in-order traversal — whole subtrees outside the band are never visited</a:t>
+              <a:t>Max chain 1 — FNV-1a spreads keys well (111 when resizing is disabled at 100k products)</a:t>
             </a:r>
           </a:p>
           <a:p>
@@ -16889,7 +17510,32 @@
                 </a:solidFill>
                 <a:latin typeface="Calibri"/>
               </a:rPr>
-              <a:t>Results arrive already sorted by price — no sorting step exists anywhere in the system</a:t>
+              <a:t>BST height 5 vs ~4 ideal — near-balanced; sorted inserts would make it 15</a:t>
+            </a:r>
+          </a:p>
+          <a:p>
+            <a:pPr algn="l" marL="256032" indent="-256032">
+              <a:lnSpc>
+                <a:spcPct val="104000"/>
+              </a:lnSpc>
+              <a:spcAft>
+                <a:spcPts val="700"/>
+              </a:spcAft>
+              <a:buClr>
+                <a:srgbClr val="2C7BB6"/>
+              </a:buClr>
+              <a:buSzPct val="82000"/>
+              <a:buFont typeface="Arial"/>
+              <a:buChar char="▪"/>
+            </a:pPr>
+            <a:r>
+              <a:rPr sz="1800">
+                <a:solidFill>
+                  <a:srgbClr val="3A3F4A"/>
+                </a:solidFill>
+                <a:latin typeface="Calibri"/>
+              </a:rPr>
+              <a:t>148 trie nodes — shared prefixes stored once; 7 graph edges grow with every fulfilled order</a:t>
             </a:r>
           </a:p>
         </p:txBody>
@@ -17094,7 +17740,7 @@
           <a:lstStyle/>
           <a:p>
             <a:pPr algn="l">
-              <a:defRPr sz="2900" b="1">
+              <a:defRPr sz="2600" b="1">
                 <a:solidFill>
                   <a:srgbClr val="1F2A44"/>
                 </a:solidFill>
@@ -17102,7 +17748,7 @@
               </a:defRPr>
             </a:pPr>
             <a:r>
-              <a:t>The Catalog Panel Is the Hash Table</a:t>
+              <a:t>Live Search Is a Trie Walk; the Filter Is a Pruned BST</a:t>
             </a:r>
           </a:p>
         </p:txBody>
@@ -17415,16 +18061,45 @@
           </a:p>
         </p:txBody>
       </p:sp>
-      <p:sp>
-        <p:nvSpPr>
-          <p:cNvPr id="11" name="TextBox 10"/>
+      <p:pic>
+        <p:nvPicPr>
+          <p:cNvPr id="11" name="Picture 10" descr="panel_search_price.png"/>
+          <p:cNvPicPr>
+            <a:picLocks noChangeAspect="1"/>
+          </p:cNvPicPr>
+          <p:nvPr/>
+        </p:nvPicPr>
+        <p:blipFill>
+          <a:blip r:embed="rId2"/>
+          <a:stretch>
+            <a:fillRect/>
+          </a:stretch>
+        </p:blipFill>
+        <p:spPr>
+          <a:xfrm>
+            <a:off x="563727" y="1417320"/>
+            <a:ext cx="11064240" cy="1208164"/>
+          </a:xfrm>
+          <a:prstGeom prst="rect">
+            <a:avLst/>
+          </a:prstGeom>
+          <a:ln w="12700">
+            <a:solidFill>
+              <a:srgbClr val="DCE0E8"/>
+            </a:solidFill>
+          </a:ln>
+        </p:spPr>
+      </p:pic>
+      <p:sp>
+        <p:nvSpPr>
+          <p:cNvPr id="12" name="TextBox 11"/>
           <p:cNvSpPr txBox="1"/>
           <p:nvPr/>
         </p:nvSpPr>
         <p:spPr>
           <a:xfrm>
-            <a:off x="548640" y="1463040"/>
-            <a:ext cx="5577840" cy="4846320"/>
+            <a:off x="822960" y="2808364"/>
+            <a:ext cx="10515600" cy="3546716"/>
           </a:xfrm>
           <a:prstGeom prst="rect">
             <a:avLst/>
@@ -17432,7 +18107,7 @@
           <a:noFill/>
         </p:spPr>
         <p:txBody>
-          <a:bodyPr wrap="square" anchor="ctr">
+          <a:bodyPr wrap="square">
             <a:spAutoFit/>
           </a:bodyPr>
           <a:lstStyle/>
@@ -17442,7 +18117,7 @@
                 <a:spcPct val="104000"/>
               </a:lnSpc>
               <a:spcAft>
-                <a:spcPts val="1200"/>
+                <a:spcPts val="700"/>
               </a:spcAft>
               <a:buClr>
                 <a:srgbClr val="2C7BB6"/>
@@ -17452,13 +18127,13 @@
               <a:buChar char="▪"/>
             </a:pPr>
             <a:r>
-              <a:rPr sz="2000">
+              <a:rPr sz="1800">
                 <a:solidFill>
                   <a:srgbClr val="3A3F4A"/>
                 </a:solidFill>
                 <a:latin typeface="Calibri"/>
               </a:rPr>
-              <a:t>Single source of truth — every other panel resolves SKUs here in O(1)</a:t>
+              <a:t>Every keystroke = one prefix walk — cost grows with the prefix, never with the catalog</a:t>
             </a:r>
           </a:p>
           <a:p>
@@ -17467,7 +18142,7 @@
                 <a:spcPct val="104000"/>
               </a:lnSpc>
               <a:spcAft>
-                <a:spcPts val="1200"/>
+                <a:spcPts val="700"/>
               </a:spcAft>
               <a:buClr>
                 <a:srgbClr val="2C7BB6"/>
@@ -17477,13 +18152,13 @@
               <a:buChar char="▪"/>
             </a:pPr>
             <a:r>
-              <a:rPr sz="2000">
+              <a:rPr sz="1800">
                 <a:solidFill>
                   <a:srgbClr val="3A3F4A"/>
                 </a:solidFill>
                 <a:latin typeface="Calibri"/>
               </a:rPr>
-              <a:t>FNV-1a hash → bucket → short chain scan</a:t>
+              <a:t>“wireless key” = two walks intersected → only the Wireless Keyboard survives both</a:t>
             </a:r>
           </a:p>
           <a:p>
@@ -17492,7 +18167,7 @@
                 <a:spcPct val="104000"/>
               </a:lnSpc>
               <a:spcAft>
-                <a:spcPts val="1200"/>
+                <a:spcPts val="700"/>
               </a:spcAft>
               <a:buClr>
                 <a:srgbClr val="2C7BB6"/>
@@ -17502,13 +18177,13 @@
               <a:buChar char="▪"/>
             </a:pPr>
             <a:r>
-              <a:rPr sz="2000">
+              <a:rPr sz="1800">
                 <a:solidFill>
                   <a:srgbClr val="3A3F4A"/>
                 </a:solidFill>
                 <a:latin typeface="Calibri"/>
               </a:rPr>
-              <a:t>⚠ low badge at ≤ 5 units — the same signal the low-stock dashboard ranks</a:t>
+              <a:t>$15–$50 = pruned in-order traversal — whole subtrees outside the band are never visited</a:t>
             </a:r>
           </a:p>
           <a:p>
@@ -17517,7 +18192,7 @@
                 <a:spcPct val="104000"/>
               </a:lnSpc>
               <a:spcAft>
-                <a:spcPts val="1200"/>
+                <a:spcPts val="700"/>
               </a:spcAft>
               <a:buClr>
                 <a:srgbClr val="2C7BB6"/>
@@ -17527,71 +18202,17 @@
               <a:buChar char="▪"/>
             </a:pPr>
             <a:r>
-              <a:rPr sz="2000">
+              <a:rPr sz="1800">
                 <a:solidFill>
                   <a:srgbClr val="3A3F4A"/>
                 </a:solidFill>
                 <a:latin typeface="Calibri"/>
               </a:rPr>
-              <a:t>Return enabled only while Returned &lt; Sold — the cumulative cap</a:t>
-            </a:r>
-          </a:p>
-          <a:p>
-            <a:pPr algn="l" marL="256032" indent="-256032">
-              <a:lnSpc>
-                <a:spcPct val="104000"/>
-              </a:lnSpc>
-              <a:spcAft>
-                <a:spcPts val="1200"/>
-              </a:spcAft>
-              <a:buClr>
-                <a:srgbClr val="2C7BB6"/>
-              </a:buClr>
-              <a:buSzPct val="82000"/>
-              <a:buFont typeface="Arial"/>
-              <a:buChar char="▪"/>
-            </a:pPr>
-            <a:r>
-              <a:rPr sz="2000">
-                <a:solidFill>
-                  <a:srgbClr val="3A3F4A"/>
-                </a:solidFill>
-                <a:latin typeface="Calibri"/>
-              </a:rPr>
-              <a:t>One write updates every view — indexes can never disagree</a:t>
-            </a:r>
-          </a:p>
-        </p:txBody>
-      </p:sp>
-      <p:pic>
-        <p:nvPicPr>
-          <p:cNvPr id="12" name="Picture 11" descr="panel_catalog.png"/>
-          <p:cNvPicPr>
-            <a:picLocks noChangeAspect="1"/>
-          </p:cNvPicPr>
-          <p:nvPr/>
-        </p:nvPicPr>
-        <p:blipFill>
-          <a:blip r:embed="rId2"/>
-          <a:stretch>
-            <a:fillRect/>
-          </a:stretch>
-        </p:blipFill>
-        <p:spPr>
-          <a:xfrm>
-            <a:off x="6309360" y="2291715"/>
-            <a:ext cx="5669280" cy="3188970"/>
-          </a:xfrm>
-          <a:prstGeom prst="rect">
-            <a:avLst/>
-          </a:prstGeom>
-          <a:ln w="12700">
-            <a:solidFill>
-              <a:srgbClr val="DCE0E8"/>
-            </a:solidFill>
-          </a:ln>
-        </p:spPr>
-      </p:pic>
+              <a:t>Results arrive already sorted by price — no sorting step exists anywhere in the system</a:t>
+            </a:r>
+          </a:p>
+        </p:txBody>
+      </p:sp>
       <p:sp>
         <p:nvSpPr>
           <p:cNvPr id="13" name="Rectangle 12"/>

</xml_diff>

<commit_message>
Update presentation: tighten slide 2 access patterns and move demo before Phase 3
</commit_message>
<xml_diff>
--- a/residency/deliverables/Deliverable 4/Group2_Project_Presentation_MSCS532.pptx
+++ b/residency/deliverables/Deliverable 4/Group2_Project_Presentation_MSCS532.pptx
@@ -801,7 +801,7 @@
           <a:lstStyle/>
           <a:p>
             <a:r>
-              <a:t>Correctness rests on forty-two unit tests, and they aim at each structure's specific failure mode rather than the happy path. The hash table is grown through several resizes and every record re-verified. The circular buffer is drained across its wraparound boundary. The tree's range query is cross-checked against brute force on a thousand random prices, the heap against a full sort. And the integration tests verify the atomicity property: when an order fails on stock, nothing else in that order has been touched. Every module also validates inputs at the boundary, so bad data raises a typed exception before any state mutates.</a:t>
+              <a:t>That's the portal on slides — now let's show it to you running. We'll open the storefront, search as we type, place and process an order, and watch a return climb the most-returned dashboard, with the metrics strip updating live. [Switch to the browser at localhost:8000; the click sequence is in the demo run sheet.]</a:t>
             </a:r>
           </a:p>
         </p:txBody>
@@ -871,7 +871,7 @@
           <a:lstStyle/>
           <a:p>
             <a:r>
-              <a:t>Phase three turned to performance. The dataset generator builds catalogs from one thousand to one hundred thousand products with adjective-noun names, so the trie faces realistic shared prefixes, and an order stream with a quadratic popularity skew, so hub products emerge the way they do in real stores. Timings are best-of-five wall clock, memory is peak tracemalloc, and — this is the discipline of the whole phase — every specialized structure has to justify itself against the naive baseline a simpler system would use: a fixed-capacity table, a linear scan, a full sort.</a:t>
+              <a:t>Correctness rests on forty-two unit tests, and they aim at each structure's specific failure mode rather than the happy path. The hash table is grown through several resizes and every record re-verified. The circular buffer is drained across its wraparound boundary. The tree's range query is cross-checked against brute force on a thousand random prices, the heap against a full sort. And the integration tests verify the atomicity property: when an order fails on stock, nothing else in that order has been touched. Every module also validates inputs at the boundary, so bad data raises a typed exception before any state mutates.</a:t>
             </a:r>
           </a:p>
         </p:txBody>
@@ -941,7 +941,7 @@
           <a:lstStyle/>
           <a:p>
             <a:r>
-              <a:t>The first headline result is the catalog. With load-factor resizing — the bucket array doubles past 75 percent occupancy — lookups sit flat at about two microseconds across two orders of magnitude of catalog size. Freeze the same table at a thousand buckets and it degrades linearly to ten microseconds, with collision chains a hundred and eleven entries long. That's a five-fold penalty for skipping one optimization, and it's exactly the O of n over m arithmetic from lecture, made visible in a chart.</a:t>
+              <a:t>Phase three turned to performance. The dataset generator builds catalogs from one thousand to one hundred thousand products with adjective-noun names, so the trie faces realistic shared prefixes, and an order stream with a quadratic popularity skew, so hub products emerge the way they do in real stores. Timings are best-of-five wall clock, memory is peak tracemalloc, and — this is the discipline of the whole phase — every specialized structure has to justify itself against the naive baseline a simpler system would use: a fixed-capacity table, a linear scan, a full sort.</a:t>
             </a:r>
           </a:p>
         </p:txBody>
@@ -1011,7 +1011,7 @@
           <a:lstStyle/>
           <a:p>
             <a:r>
-              <a:t>Search is the largest payoff. A linear scan touches every product name on every keystroke — eighty-two milliseconds per query at full scale, which is an unusable autocomplete. The trie answers the same query in under two milliseconds, forty-five times faster, and the gap widens with catalog size because the trie's cost depends only on the prefix length and the matches, not on how big the store is. The price tree shows the same shape in milder form: the pruned in-order traversal beats scan-and-sort by nearly six times on a five-percent price band.</a:t>
+              <a:t>The first headline result is the catalog. With load-factor resizing — the bucket array doubles past 75 percent occupancy — lookups sit flat at about two microseconds across two orders of magnitude of catalog size. Freeze the same table at a thousand buckets and it degrades linearly to ten microseconds, with collision chains a hundred and eleven entries long. That's a five-fold penalty for skipping one optimization, and it's exactly the O of n over m arithmetic from lecture, made visible in a chart.</a:t>
             </a:r>
           </a:p>
         </p:txBody>
@@ -1081,7 +1081,7 @@
           <a:lstStyle/>
           <a:p>
             <a:r>
-              <a:t>And here is the result we're proudest of reporting, because it went against us. Top-ten-best-sellers from a heap is order n plus k log n — asymptotically better than fully sorting. Measured, the pure-Python heap merely ties Python's built-in sort at every size, because Timsort executes in C while every one of my sift-down comparisons executes in the interpreter. The constant factors ate the asymptotic advantage. The heap stays in the design for what the cold benchmark doesn't measure — incremental updates without re-sorting — but the lesson stands: you measure optimizations in the environment they'll run in, or the environment will measure them for you.</a:t>
+              <a:t>Search is the largest payoff. A linear scan touches every product name on every keystroke — eighty-two milliseconds per query at full scale, which is an unusable autocomplete. The trie answers the same query in under two milliseconds, forty-five times faster, and the gap widens with catalog size because the trie's cost depends only on the prefix length and the matches, not on how big the store is. The price tree shows the same shape in milder form: the pruned in-order traversal beats scan-and-sort by nearly six times on a five-percent price band.</a:t>
             </a:r>
           </a:p>
         </p:txBody>
@@ -1151,7 +1151,7 @@
           <a:lstStyle/>
           <a:p>
             <a:r>
-              <a:t>Two stress tests target the weak points the design phase wrote down. Loading the price tree with strictly increasing prices — a sorted supplier file — collapses it to a linked list: height four thousand versus twenty-five for the same prices in random order. The queries survive only because traversal is iterative; recursion would overflow Python's stack, which validates that early implementation decision. Second, replaying twenty thousand orders against a deliberately tiny catalog simulates a flash sale: nine and a half thousand orders are rejected, every rejection atomic, no line item corrupted. And end to end, the platform sustains about forty-four thousand orders per second in sixty-five megabytes.</a:t>
+              <a:t>And here is the result we're proudest of reporting, because it went against us. Top-ten-best-sellers from a heap is order n plus k log n — asymptotically better than fully sorting. Measured, the pure-Python heap merely ties Python's built-in sort at every size, because Timsort executes in C while every one of my sift-down comparisons executes in the interpreter. The constant factors ate the asymptotic advantage. The heap stays in the design for what the cold benchmark doesn't measure — incremental updates without re-sorting — but the lesson stands: you measure optimizations in the environment they'll run in, or the environment will measure them for you.</a:t>
             </a:r>
           </a:p>
         </p:txBody>
@@ -1221,7 +1221,7 @@
           <a:lstStyle/>
           <a:p>
             <a:r>
-              <a:t>Three conclusions travel beyond this project. First, composition beats generality: the speed comes from routing each workload to the right specialist behind a constant-time source of truth — the same architecture production retailers run. Second, optimizations are empirical claims: resizing repaid itself five-fold, the heap's textbook advantage did not survive the interpreter, and only measurement tells those apart. Third, worst cases documented at design time became cheap tests later — the tree collapse and the flash sale both arrived exactly as predicted. Future work is self-balancing for the price tree, edge decay for the graph, and radix compression for the trie. Everything — code, forty-two tests, benchmarks, and raw data — is in the course repository. Thank you; we're happy to take questions.</a:t>
+              <a:t>Two stress tests target the weak points the design phase wrote down. Loading the price tree with strictly increasing prices — a sorted supplier file — collapses it to a linked list: height four thousand versus twenty-five for the same prices in random order. The queries survive only because traversal is iterative; recursion would overflow Python's stack, which validates that early implementation decision. Second, replaying twenty thousand orders against a deliberately tiny catalog simulates a flash sale: nine and a half thousand orders are rejected, every rejection atomic, no line item corrupted. And end to end, the platform sustains about forty-four thousand orders per second in sixty-five megabytes.</a:t>
             </a:r>
           </a:p>
         </p:txBody>
@@ -1361,7 +1361,7 @@
           <a:lstStyle/>
           <a:p>
             <a:r>
-              <a:t>That's the project on slides — now let's show it to you running. We'll open the portal, search as we type, place and process an order, and watch a return climb the most-returned dashboard, with the metrics strip updating live. [Switch to the browser at localhost:8000; the click sequence is in the demo run sheet.]</a:t>
+              <a:t>Three conclusions travel beyond this project. First, composition beats generality: the speed comes from routing each workload to the right specialist behind a constant-time source of truth — the same architecture production retailers run. Second, optimizations are empirical claims: resizing repaid itself five-fold, the heap's textbook advantage did not survive the interpreter, and only measurement tells those apart. Third, worst cases documented at design time became cheap tests later — the tree collapse and the flash sale both arrived exactly as predicted. Future work is self-balancing for the price tree, edge decay for the graph, and radix compression for the trie. Everything — code, forty-two tests, benchmarks, and raw data — is in the course repository. Thank you; we're happy to take questions.</a:t>
             </a:r>
           </a:p>
         </p:txBody>
@@ -7507,7 +7507,7 @@
     <p:bg>
       <p:bgPr>
         <a:solidFill>
-          <a:srgbClr val="FCFCFB"/>
+          <a:srgbClr val="1F2A44"/>
         </a:solidFill>
         <a:effectLst/>
       </p:bgPr>
@@ -7527,8 +7527,8 @@
         </p:nvSpPr>
         <p:spPr>
           <a:xfrm>
-            <a:off x="566928" y="310896"/>
-            <a:ext cx="8046720" cy="274320"/>
+            <a:off x="914400" y="2331720"/>
+            <a:ext cx="10360152" cy="1280160"/>
           </a:xfrm>
           <a:prstGeom prst="rect">
             <a:avLst/>
@@ -7541,109 +7541,30 @@
           </a:bodyPr>
           <a:lstStyle/>
           <a:p>
-            <a:pPr algn="l"/>
-            <a:r>
-              <a:rPr sz="1150" b="1" spc="160">
-                <a:solidFill>
-                  <a:srgbClr val="6B7A99"/>
-                </a:solidFill>
-                <a:latin typeface="Calibri"/>
-              </a:rPr>
-              <a:t>05 · TESTING</a:t>
-            </a:r>
-          </a:p>
-        </p:txBody>
-      </p:sp>
-      <p:sp>
-        <p:nvSpPr>
-          <p:cNvPr id="3" name="TextBox 2"/>
-          <p:cNvSpPr txBox="1"/>
-          <p:nvPr/>
-        </p:nvSpPr>
-        <p:spPr>
-          <a:xfrm>
-            <a:off x="548640" y="530352"/>
-            <a:ext cx="11064240" cy="685800"/>
-          </a:xfrm>
-          <a:prstGeom prst="rect">
-            <a:avLst/>
-          </a:prstGeom>
-          <a:noFill/>
-        </p:spPr>
-        <p:txBody>
-          <a:bodyPr wrap="square">
-            <a:spAutoFit/>
-          </a:bodyPr>
-          <a:lstStyle/>
-          <a:p>
-            <a:pPr algn="l">
-              <a:defRPr sz="2900" b="1">
-                <a:solidFill>
-                  <a:srgbClr val="1F2A44"/>
+            <a:pPr algn="ctr">
+              <a:defRPr sz="6600" b="1">
+                <a:solidFill>
+                  <a:srgbClr val="FFFFFF"/>
                 </a:solidFill>
                 <a:latin typeface="Calibri"/>
               </a:defRPr>
             </a:pPr>
             <a:r>
-              <a:t>Correctness: 42 Tests Aimed at the Failure Modes</a:t>
-            </a:r>
-          </a:p>
-        </p:txBody>
-      </p:sp>
-      <p:sp>
-        <p:nvSpPr>
-          <p:cNvPr id="4" name="Rectangle 3"/>
+              <a:t>Demo time!</a:t>
+            </a:r>
+          </a:p>
+        </p:txBody>
+      </p:sp>
+      <p:sp>
+        <p:nvSpPr>
+          <p:cNvPr id="3" name="Rectangle 2"/>
           <p:cNvSpPr/>
           <p:nvPr/>
         </p:nvSpPr>
         <p:spPr>
           <a:xfrm>
-            <a:off x="548640" y="1243584"/>
-            <a:ext cx="11064240" cy="12801"/>
-          </a:xfrm>
-          <a:prstGeom prst="rect">
-            <a:avLst/>
-          </a:prstGeom>
-          <a:solidFill>
-            <a:srgbClr val="DCE0E8"/>
-          </a:solidFill>
-          <a:ln>
-            <a:noFill/>
-          </a:ln>
-          <a:effectLst/>
-        </p:spPr>
-        <p:style>
-          <a:lnRef idx="1">
-            <a:schemeClr val="accent1"/>
-          </a:lnRef>
-          <a:fillRef idx="3">
-            <a:schemeClr val="accent1"/>
-          </a:fillRef>
-          <a:effectRef idx="2">
-            <a:schemeClr val="accent1"/>
-          </a:effectRef>
-          <a:fontRef idx="minor">
-            <a:schemeClr val="lt1"/>
-          </a:fontRef>
-        </p:style>
-        <p:txBody>
-          <a:bodyPr rtlCol="0" anchor="ctr"/>
-          <a:lstStyle/>
-          <a:p>
-            <a:pPr algn="ctr"/>
-          </a:p>
-        </p:txBody>
-      </p:sp>
-      <p:sp>
-        <p:nvSpPr>
-          <p:cNvPr id="5" name="Rectangle 4"/>
-          <p:cNvSpPr/>
-          <p:nvPr/>
-        </p:nvSpPr>
-        <p:spPr>
-          <a:xfrm>
-            <a:off x="548640" y="1216152"/>
-            <a:ext cx="329184" cy="50292"/>
+            <a:off x="4724247" y="3794760"/>
+            <a:ext cx="457200" cy="64008"/>
           </a:xfrm>
           <a:prstGeom prst="rect">
             <a:avLst/>
@@ -7680,14 +7601,14 @@
       </p:sp>
       <p:sp>
         <p:nvSpPr>
-          <p:cNvPr id="6" name="Rectangle 5"/>
+          <p:cNvPr id="4" name="Rectangle 3"/>
           <p:cNvSpPr/>
           <p:nvPr/>
         </p:nvSpPr>
         <p:spPr>
           <a:xfrm>
-            <a:off x="877824" y="1216152"/>
-            <a:ext cx="329184" cy="50292"/>
+            <a:off x="5181447" y="3794760"/>
+            <a:ext cx="457200" cy="64008"/>
           </a:xfrm>
           <a:prstGeom prst="rect">
             <a:avLst/>
@@ -7724,14 +7645,14 @@
       </p:sp>
       <p:sp>
         <p:nvSpPr>
-          <p:cNvPr id="7" name="Rectangle 6"/>
+          <p:cNvPr id="5" name="Rectangle 4"/>
           <p:cNvSpPr/>
           <p:nvPr/>
         </p:nvSpPr>
         <p:spPr>
           <a:xfrm>
-            <a:off x="1207008" y="1216152"/>
-            <a:ext cx="329184" cy="50292"/>
+            <a:off x="5638647" y="3794760"/>
+            <a:ext cx="457200" cy="64008"/>
           </a:xfrm>
           <a:prstGeom prst="rect">
             <a:avLst/>
@@ -7768,14 +7689,14 @@
       </p:sp>
       <p:sp>
         <p:nvSpPr>
-          <p:cNvPr id="8" name="Rectangle 7"/>
+          <p:cNvPr id="6" name="Rectangle 5"/>
           <p:cNvSpPr/>
           <p:nvPr/>
         </p:nvSpPr>
         <p:spPr>
           <a:xfrm>
-            <a:off x="1536192" y="1216152"/>
-            <a:ext cx="329184" cy="50292"/>
+            <a:off x="6095847" y="3794760"/>
+            <a:ext cx="457200" cy="64008"/>
           </a:xfrm>
           <a:prstGeom prst="rect">
             <a:avLst/>
@@ -7812,14 +7733,14 @@
       </p:sp>
       <p:sp>
         <p:nvSpPr>
-          <p:cNvPr id="9" name="Rectangle 8"/>
+          <p:cNvPr id="7" name="Rectangle 6"/>
           <p:cNvSpPr/>
           <p:nvPr/>
         </p:nvSpPr>
         <p:spPr>
           <a:xfrm>
-            <a:off x="1865376" y="1216152"/>
-            <a:ext cx="329184" cy="50292"/>
+            <a:off x="6553047" y="3794760"/>
+            <a:ext cx="457200" cy="64008"/>
           </a:xfrm>
           <a:prstGeom prst="rect">
             <a:avLst/>
@@ -7856,14 +7777,14 @@
       </p:sp>
       <p:sp>
         <p:nvSpPr>
-          <p:cNvPr id="10" name="Rectangle 9"/>
+          <p:cNvPr id="8" name="Rectangle 7"/>
           <p:cNvSpPr/>
           <p:nvPr/>
         </p:nvSpPr>
         <p:spPr>
           <a:xfrm>
-            <a:off x="2194560" y="1216152"/>
-            <a:ext cx="329184" cy="50292"/>
+            <a:off x="7010247" y="3794760"/>
+            <a:ext cx="457200" cy="64008"/>
           </a:xfrm>
           <a:prstGeom prst="rect">
             <a:avLst/>
@@ -7900,14 +7821,14 @@
       </p:sp>
       <p:sp>
         <p:nvSpPr>
-          <p:cNvPr id="11" name="TextBox 10"/>
+          <p:cNvPr id="9" name="TextBox 8"/>
           <p:cNvSpPr txBox="1"/>
           <p:nvPr/>
         </p:nvSpPr>
         <p:spPr>
           <a:xfrm>
-            <a:off x="548640" y="1463040"/>
-            <a:ext cx="5577840" cy="4846320"/>
+            <a:off x="914400" y="4069080"/>
+            <a:ext cx="10360152" cy="457200"/>
           </a:xfrm>
           <a:prstGeom prst="rect">
             <a:avLst/>
@@ -7915,219 +7836,28 @@
           <a:noFill/>
         </p:spPr>
         <p:txBody>
-          <a:bodyPr wrap="square" anchor="ctr">
+          <a:bodyPr wrap="square">
             <a:spAutoFit/>
           </a:bodyPr>
           <a:lstStyle/>
           <a:p>
-            <a:pPr algn="l" marL="256032" indent="-256032">
-              <a:lnSpc>
-                <a:spcPct val="104000"/>
-              </a:lnSpc>
-              <a:spcAft>
-                <a:spcPts val="800"/>
-              </a:spcAft>
-              <a:buClr>
-                <a:srgbClr val="2C7BB6"/>
-              </a:buClr>
-              <a:buSzPct val="82000"/>
-              <a:buFont typeface="Arial"/>
-              <a:buChar char="▪"/>
+            <a:pPr algn="ctr">
+              <a:defRPr sz="1800">
+                <a:solidFill>
+                  <a:srgbClr val="9FB3D1"/>
+                </a:solidFill>
+                <a:latin typeface="Calibri"/>
+              </a:defRPr>
             </a:pPr>
             <a:r>
-              <a:rPr sz="1700">
-                <a:solidFill>
-                  <a:srgbClr val="3A3F4A"/>
-                </a:solidFill>
-                <a:latin typeface="Calibri"/>
-              </a:rPr>
-              <a:t>Hash table filled through multiple resizes, re-verified</a:t>
-            </a:r>
-          </a:p>
-          <a:p>
-            <a:pPr algn="l" marL="256032" indent="-256032">
-              <a:lnSpc>
-                <a:spcPct val="104000"/>
-              </a:lnSpc>
-              <a:spcAft>
-                <a:spcPts val="800"/>
-              </a:spcAft>
-              <a:buClr>
-                <a:srgbClr val="2C7BB6"/>
-              </a:buClr>
-              <a:buSzPct val="82000"/>
-              <a:buFont typeface="Arial"/>
-              <a:buChar char="▪"/>
-            </a:pPr>
-            <a:r>
-              <a:rPr sz="1700">
-                <a:solidFill>
-                  <a:srgbClr val="3A3F4A"/>
-                </a:solidFill>
-                <a:latin typeface="Calibri"/>
-              </a:rPr>
-              <a:t>Queue drained across the circular wraparound boundary</a:t>
-            </a:r>
-          </a:p>
-          <a:p>
-            <a:pPr algn="l" marL="256032" indent="-256032">
-              <a:lnSpc>
-                <a:spcPct val="104000"/>
-              </a:lnSpc>
-              <a:spcAft>
-                <a:spcPts val="800"/>
-              </a:spcAft>
-              <a:buClr>
-                <a:srgbClr val="2C7BB6"/>
-              </a:buClr>
-              <a:buSzPct val="82000"/>
-              <a:buFont typeface="Arial"/>
-              <a:buChar char="▪"/>
-            </a:pPr>
-            <a:r>
-              <a:rPr sz="1700">
-                <a:solidFill>
-                  <a:srgbClr val="3A3F4A"/>
-                </a:solidFill>
-                <a:latin typeface="Calibri"/>
-              </a:rPr>
-              <a:t>BST range query cross-checked vs brute force (1,000 prices)</a:t>
-            </a:r>
-          </a:p>
-          <a:p>
-            <a:pPr algn="l" marL="256032" indent="-256032">
-              <a:lnSpc>
-                <a:spcPct val="104000"/>
-              </a:lnSpc>
-              <a:spcAft>
-                <a:spcPts val="800"/>
-              </a:spcAft>
-              <a:buClr>
-                <a:srgbClr val="2C7BB6"/>
-              </a:buClr>
-              <a:buSzPct val="82000"/>
-              <a:buFont typeface="Arial"/>
-              <a:buChar char="▪"/>
-            </a:pPr>
-            <a:r>
-              <a:rPr sz="1700">
-                <a:solidFill>
-                  <a:srgbClr val="3A3F4A"/>
-                </a:solidFill>
-                <a:latin typeface="Calibri"/>
-              </a:rPr>
-              <a:t>Heap top-25 vs full sort (2,000 random entries)</a:t>
-            </a:r>
-          </a:p>
-          <a:p>
-            <a:pPr algn="l" marL="256032" indent="-256032">
-              <a:lnSpc>
-                <a:spcPct val="104000"/>
-              </a:lnSpc>
-              <a:spcAft>
-                <a:spcPts val="800"/>
-              </a:spcAft>
-              <a:buClr>
-                <a:srgbClr val="2C7BB6"/>
-              </a:buClr>
-              <a:buSzPct val="82000"/>
-              <a:buFont typeface="Arial"/>
-              <a:buChar char="▪"/>
-            </a:pPr>
-            <a:r>
-              <a:rPr sz="1700">
-                <a:solidFill>
-                  <a:srgbClr val="3A3F4A"/>
-                </a:solidFill>
-                <a:latin typeface="Calibri"/>
-              </a:rPr>
-              <a:t>Failed order commits nothing — atomicity test</a:t>
-            </a:r>
-          </a:p>
-          <a:p>
-            <a:pPr algn="l" marL="256032" indent="-256032">
-              <a:lnSpc>
-                <a:spcPct val="104000"/>
-              </a:lnSpc>
-              <a:spcAft>
-                <a:spcPts val="800"/>
-              </a:spcAft>
-              <a:buClr>
-                <a:srgbClr val="2C7BB6"/>
-              </a:buClr>
-              <a:buSzPct val="82000"/>
-              <a:buFont typeface="Arial"/>
-              <a:buChar char="▪"/>
-            </a:pPr>
-            <a:r>
-              <a:rPr sz="1700">
-                <a:solidFill>
-                  <a:srgbClr val="3A3F4A"/>
-                </a:solidFill>
-                <a:latin typeface="Calibri"/>
-              </a:rPr>
-              <a:t>Returns capped cumulatively — never exceed units sold</a:t>
-            </a:r>
-          </a:p>
-          <a:p>
-            <a:pPr algn="l" marL="256032" indent="-256032">
-              <a:lnSpc>
-                <a:spcPct val="104000"/>
-              </a:lnSpc>
-              <a:spcAft>
-                <a:spcPts val="800"/>
-              </a:spcAft>
-              <a:buClr>
-                <a:srgbClr val="2C7BB6"/>
-              </a:buClr>
-              <a:buSzPct val="82000"/>
-              <a:buFont typeface="Arial"/>
-              <a:buChar char="▪"/>
-            </a:pPr>
-            <a:r>
-              <a:rPr sz="1700">
-                <a:solidFill>
-                  <a:srgbClr val="3A3F4A"/>
-                </a:solidFill>
-                <a:latin typeface="Calibri"/>
-              </a:rPr>
-              <a:t>Input validation at every boundary (typed exceptions)</a:t>
-            </a:r>
-          </a:p>
-        </p:txBody>
-      </p:sp>
-      <p:pic>
-        <p:nvPicPr>
-          <p:cNvPr id="12" name="Picture 11" descr="screenshot_tests.png"/>
-          <p:cNvPicPr>
-            <a:picLocks noChangeAspect="1"/>
-          </p:cNvPicPr>
-          <p:nvPr/>
-        </p:nvPicPr>
-        <p:blipFill>
-          <a:blip r:embed="rId2"/>
-          <a:stretch>
-            <a:fillRect/>
-          </a:stretch>
-        </p:blipFill>
-        <p:spPr>
-          <a:xfrm>
-            <a:off x="6309360" y="3167651"/>
-            <a:ext cx="5669280" cy="1437097"/>
-          </a:xfrm>
-          <a:prstGeom prst="rect">
-            <a:avLst/>
-          </a:prstGeom>
-          <a:ln w="12700">
-            <a:solidFill>
-              <a:srgbClr val="DCE0E8"/>
-            </a:solidFill>
-          </a:ln>
-        </p:spPr>
-      </p:pic>
-      <p:sp>
-        <p:nvSpPr>
-          <p:cNvPr id="13" name="Rectangle 12"/>
+              <a:t>the portal, live — http://localhost:8000</a:t>
+            </a:r>
+          </a:p>
+        </p:txBody>
+      </p:sp>
+      <p:sp>
+        <p:nvSpPr>
+          <p:cNvPr id="10" name="Rectangle 9"/>
           <p:cNvSpPr/>
           <p:nvPr/>
         </p:nvSpPr>
@@ -8140,7 +7870,7 @@
             <a:avLst/>
           </a:prstGeom>
           <a:solidFill>
-            <a:srgbClr val="DCE0E8"/>
+            <a:srgbClr val="3A4A6E"/>
           </a:solidFill>
           <a:ln>
             <a:noFill/>
@@ -8171,7 +7901,7 @@
       </p:sp>
       <p:sp>
         <p:nvSpPr>
-          <p:cNvPr id="14" name="TextBox 13"/>
+          <p:cNvPr id="11" name="TextBox 10"/>
           <p:cNvSpPr txBox="1"/>
           <p:nvPr/>
         </p:nvSpPr>
@@ -8194,7 +7924,7 @@
             <a:pPr algn="l">
               <a:defRPr sz="950">
                 <a:solidFill>
-                  <a:srgbClr val="8A8984"/>
+                  <a:srgbClr val="9FB3D1"/>
                 </a:solidFill>
                 <a:latin typeface="Calibri"/>
               </a:defRPr>
@@ -8207,7 +7937,7 @@
       </p:sp>
       <p:sp>
         <p:nvSpPr>
-          <p:cNvPr id="15" name="TextBox 14"/>
+          <p:cNvPr id="12" name="TextBox 11"/>
           <p:cNvSpPr txBox="1"/>
           <p:nvPr/>
         </p:nvSpPr>
@@ -8230,7 +7960,7 @@
             <a:pPr algn="r">
               <a:defRPr sz="950">
                 <a:solidFill>
-                  <a:srgbClr val="8A8984"/>
+                  <a:srgbClr val="9FB3D1"/>
                 </a:solidFill>
                 <a:latin typeface="Calibri"/>
               </a:defRPr>
@@ -8297,7 +8027,7 @@
                 </a:solidFill>
                 <a:latin typeface="Calibri"/>
               </a:rPr>
-              <a:t>06 · BENCHMARKS</a:t>
+              <a:t>05 · TESTING</a:t>
             </a:r>
           </a:p>
         </p:txBody>
@@ -8333,7 +8063,7 @@
               </a:defRPr>
             </a:pPr>
             <a:r>
-              <a:t>Phase 3: Scaling Method</a:t>
+              <a:t>Correctness: 42 Tests Aimed at the Failure Modes</a:t>
             </a:r>
           </a:p>
         </p:txBody>
@@ -8655,7 +8385,7 @@
         <p:spPr>
           <a:xfrm>
             <a:off x="548640" y="1463040"/>
-            <a:ext cx="11064240" cy="4846320"/>
+            <a:ext cx="5577840" cy="4846320"/>
           </a:xfrm>
           <a:prstGeom prst="rect">
             <a:avLst/>
@@ -8673,7 +8403,7 @@
                 <a:spcPct val="104000"/>
               </a:lnSpc>
               <a:spcAft>
-                <a:spcPts val="1200"/>
+                <a:spcPts val="800"/>
               </a:spcAft>
               <a:buClr>
                 <a:srgbClr val="2C7BB6"/>
@@ -8683,72 +8413,22 @@
               <a:buChar char="▪"/>
             </a:pPr>
             <a:r>
-              <a:rPr sz="2000">
+              <a:rPr sz="1700">
                 <a:solidFill>
                   <a:srgbClr val="3A3F4A"/>
                 </a:solidFill>
                 <a:latin typeface="Calibri"/>
               </a:rPr>
-              <a:t>Catalogs of 1k → 100k products, 20k-order streams</a:t>
-            </a:r>
-          </a:p>
-          <a:p>
-            <a:pPr algn="l" marL="530352" indent="-182880">
+              <a:t>Hash table filled through multiple resizes, re-verified</a:t>
+            </a:r>
+          </a:p>
+          <a:p>
+            <a:pPr algn="l" marL="256032" indent="-256032">
               <a:lnSpc>
                 <a:spcPct val="104000"/>
               </a:lnSpc>
               <a:spcAft>
                 <a:spcPts val="800"/>
-              </a:spcAft>
-              <a:buClr>
-                <a:srgbClr val="8A8984"/>
-              </a:buClr>
-              <a:buSzPct val="82000"/>
-              <a:buFont typeface="Calibri"/>
-              <a:buChar char="–"/>
-            </a:pPr>
-            <a:r>
-              <a:rPr sz="1700">
-                <a:solidFill>
-                  <a:srgbClr val="3A3F4A"/>
-                </a:solidFill>
-                <a:latin typeface="Calibri"/>
-              </a:rPr>
-              <a:t>Realistic names (shared prefixes) — the trie earns nothing from random strings</a:t>
-            </a:r>
-          </a:p>
-          <a:p>
-            <a:pPr algn="l" marL="530352" indent="-182880">
-              <a:lnSpc>
-                <a:spcPct val="104000"/>
-              </a:lnSpc>
-              <a:spcAft>
-                <a:spcPts val="800"/>
-              </a:spcAft>
-              <a:buClr>
-                <a:srgbClr val="8A8984"/>
-              </a:buClr>
-              <a:buSzPct val="82000"/>
-              <a:buFont typeface="Calibri"/>
-              <a:buChar char="–"/>
-            </a:pPr>
-            <a:r>
-              <a:rPr sz="1700">
-                <a:solidFill>
-                  <a:srgbClr val="3A3F4A"/>
-                </a:solidFill>
-                <a:latin typeface="Calibri"/>
-              </a:rPr>
-              <a:t>Quadratic popularity skew — hub products emerge, like real stores</a:t>
-            </a:r>
-          </a:p>
-          <a:p>
-            <a:pPr algn="l" marL="256032" indent="-256032">
-              <a:lnSpc>
-                <a:spcPct val="104000"/>
-              </a:lnSpc>
-              <a:spcAft>
-                <a:spcPts val="1200"/>
               </a:spcAft>
               <a:buClr>
                 <a:srgbClr val="2C7BB6"/>
@@ -8758,13 +8438,13 @@
               <a:buChar char="▪"/>
             </a:pPr>
             <a:r>
-              <a:rPr sz="2000">
+              <a:rPr sz="1700">
                 <a:solidFill>
                   <a:srgbClr val="3A3F4A"/>
                 </a:solidFill>
                 <a:latin typeface="Calibri"/>
               </a:rPr>
-              <a:t>Best-of-5 timings (perf_counter), peak memory (tracemalloc)</a:t>
+              <a:t>Queue drained across the circular wraparound boundary</a:t>
             </a:r>
           </a:p>
           <a:p>
@@ -8773,7 +8453,7 @@
                 <a:spcPct val="104000"/>
               </a:lnSpc>
               <a:spcAft>
-                <a:spcPts val="1200"/>
+                <a:spcPts val="800"/>
               </a:spcAft>
               <a:buClr>
                 <a:srgbClr val="2C7BB6"/>
@@ -8783,17 +8463,17 @@
               <a:buChar char="▪"/>
             </a:pPr>
             <a:r>
-              <a:rPr sz="2000">
+              <a:rPr sz="1700">
                 <a:solidFill>
                   <a:srgbClr val="3A3F4A"/>
                 </a:solidFill>
                 <a:latin typeface="Calibri"/>
               </a:rPr>
-              <a:t>Every structure measured against a naive baseline</a:t>
-            </a:r>
-          </a:p>
-          <a:p>
-            <a:pPr algn="l" marL="530352" indent="-182880">
+              <a:t>BST range query cross-checked vs brute force (1,000 prices)</a:t>
+            </a:r>
+          </a:p>
+          <a:p>
+            <a:pPr algn="l" marL="256032" indent="-256032">
               <a:lnSpc>
                 <a:spcPct val="104000"/>
               </a:lnSpc>
@@ -8801,11 +8481,11 @@
                 <a:spcPts val="800"/>
               </a:spcAft>
               <a:buClr>
-                <a:srgbClr val="8A8984"/>
+                <a:srgbClr val="2C7BB6"/>
               </a:buClr>
               <a:buSzPct val="82000"/>
-              <a:buFont typeface="Calibri"/>
-              <a:buChar char="–"/>
+              <a:buFont typeface="Arial"/>
+              <a:buChar char="▪"/>
             </a:pPr>
             <a:r>
               <a:rPr sz="1700">
@@ -8814,14 +8494,118 @@
                 </a:solidFill>
                 <a:latin typeface="Calibri"/>
               </a:rPr>
-              <a:t>fixed-capacity hashing, linear scans, full sorts</a:t>
-            </a:r>
-          </a:p>
-        </p:txBody>
-      </p:sp>
-      <p:sp>
-        <p:nvSpPr>
-          <p:cNvPr id="12" name="Rectangle 11"/>
+              <a:t>Heap top-25 vs full sort (2,000 random entries)</a:t>
+            </a:r>
+          </a:p>
+          <a:p>
+            <a:pPr algn="l" marL="256032" indent="-256032">
+              <a:lnSpc>
+                <a:spcPct val="104000"/>
+              </a:lnSpc>
+              <a:spcAft>
+                <a:spcPts val="800"/>
+              </a:spcAft>
+              <a:buClr>
+                <a:srgbClr val="2C7BB6"/>
+              </a:buClr>
+              <a:buSzPct val="82000"/>
+              <a:buFont typeface="Arial"/>
+              <a:buChar char="▪"/>
+            </a:pPr>
+            <a:r>
+              <a:rPr sz="1700">
+                <a:solidFill>
+                  <a:srgbClr val="3A3F4A"/>
+                </a:solidFill>
+                <a:latin typeface="Calibri"/>
+              </a:rPr>
+              <a:t>Failed order commits nothing — atomicity test</a:t>
+            </a:r>
+          </a:p>
+          <a:p>
+            <a:pPr algn="l" marL="256032" indent="-256032">
+              <a:lnSpc>
+                <a:spcPct val="104000"/>
+              </a:lnSpc>
+              <a:spcAft>
+                <a:spcPts val="800"/>
+              </a:spcAft>
+              <a:buClr>
+                <a:srgbClr val="2C7BB6"/>
+              </a:buClr>
+              <a:buSzPct val="82000"/>
+              <a:buFont typeface="Arial"/>
+              <a:buChar char="▪"/>
+            </a:pPr>
+            <a:r>
+              <a:rPr sz="1700">
+                <a:solidFill>
+                  <a:srgbClr val="3A3F4A"/>
+                </a:solidFill>
+                <a:latin typeface="Calibri"/>
+              </a:rPr>
+              <a:t>Returns capped cumulatively — never exceed units sold</a:t>
+            </a:r>
+          </a:p>
+          <a:p>
+            <a:pPr algn="l" marL="256032" indent="-256032">
+              <a:lnSpc>
+                <a:spcPct val="104000"/>
+              </a:lnSpc>
+              <a:spcAft>
+                <a:spcPts val="800"/>
+              </a:spcAft>
+              <a:buClr>
+                <a:srgbClr val="2C7BB6"/>
+              </a:buClr>
+              <a:buSzPct val="82000"/>
+              <a:buFont typeface="Arial"/>
+              <a:buChar char="▪"/>
+            </a:pPr>
+            <a:r>
+              <a:rPr sz="1700">
+                <a:solidFill>
+                  <a:srgbClr val="3A3F4A"/>
+                </a:solidFill>
+                <a:latin typeface="Calibri"/>
+              </a:rPr>
+              <a:t>Input validation at every boundary (typed exceptions)</a:t>
+            </a:r>
+          </a:p>
+        </p:txBody>
+      </p:sp>
+      <p:pic>
+        <p:nvPicPr>
+          <p:cNvPr id="12" name="Picture 11" descr="screenshot_tests.png"/>
+          <p:cNvPicPr>
+            <a:picLocks noChangeAspect="1"/>
+          </p:cNvPicPr>
+          <p:nvPr/>
+        </p:nvPicPr>
+        <p:blipFill>
+          <a:blip r:embed="rId2"/>
+          <a:stretch>
+            <a:fillRect/>
+          </a:stretch>
+        </p:blipFill>
+        <p:spPr>
+          <a:xfrm>
+            <a:off x="6309360" y="3167651"/>
+            <a:ext cx="5669280" cy="1437097"/>
+          </a:xfrm>
+          <a:prstGeom prst="rect">
+            <a:avLst/>
+          </a:prstGeom>
+          <a:ln w="12700">
+            <a:solidFill>
+              <a:srgbClr val="DCE0E8"/>
+            </a:solidFill>
+          </a:ln>
+        </p:spPr>
+      </p:pic>
+      <p:sp>
+        <p:nvSpPr>
+          <p:cNvPr id="13" name="Rectangle 12"/>
           <p:cNvSpPr/>
           <p:nvPr/>
         </p:nvSpPr>
@@ -8865,7 +8649,7 @@
       </p:sp>
       <p:sp>
         <p:nvSpPr>
-          <p:cNvPr id="13" name="TextBox 12"/>
+          <p:cNvPr id="14" name="TextBox 13"/>
           <p:cNvSpPr txBox="1"/>
           <p:nvPr/>
         </p:nvSpPr>
@@ -8901,7 +8685,7 @@
       </p:sp>
       <p:sp>
         <p:nvSpPr>
-          <p:cNvPr id="14" name="TextBox 13"/>
+          <p:cNvPr id="15" name="TextBox 14"/>
           <p:cNvSpPr txBox="1"/>
           <p:nvPr/>
         </p:nvSpPr>
@@ -9027,7 +8811,7 @@
               </a:defRPr>
             </a:pPr>
             <a:r>
-              <a:t>Result: Resizing Keeps Lookups Flat</a:t>
+              <a:t>Phase 3: Scaling Method</a:t>
             </a:r>
           </a:p>
         </p:txBody>
@@ -9348,8 +9132,8 @@
         </p:nvSpPr>
         <p:spPr>
           <a:xfrm>
-            <a:off x="548640" y="1572768"/>
-            <a:ext cx="5577840" cy="1463040"/>
+            <a:off x="548640" y="1463040"/>
+            <a:ext cx="11064240" cy="4846320"/>
           </a:xfrm>
           <a:prstGeom prst="rect">
             <a:avLst/>
@@ -9357,56 +9141,7 @@
           <a:noFill/>
         </p:spPr>
         <p:txBody>
-          <a:bodyPr wrap="square">
-            <a:spAutoFit/>
-          </a:bodyPr>
-          <a:lstStyle/>
-          <a:p>
-            <a:pPr algn="l">
-              <a:defRPr sz="5200" b="1">
-                <a:solidFill>
-                  <a:srgbClr val="2C7BB6"/>
-                </a:solidFill>
-                <a:latin typeface="Calibri"/>
-              </a:defRPr>
-            </a:pPr>
-            <a:r>
-              <a:t>4.6×</a:t>
-            </a:r>
-          </a:p>
-          <a:p>
-            <a:pPr algn="l">
-              <a:defRPr sz="1400">
-                <a:solidFill>
-                  <a:srgbClr val="8A8984"/>
-                </a:solidFill>
-                <a:latin typeface="Calibri"/>
-              </a:defRPr>
-            </a:pPr>
-            <a:r>
-              <a:t>faster lookups with load-factor resizing than a fixed-capacity table at 100k products</a:t>
-            </a:r>
-          </a:p>
-        </p:txBody>
-      </p:sp>
-      <p:sp>
-        <p:nvSpPr>
-          <p:cNvPr id="12" name="TextBox 11"/>
-          <p:cNvSpPr txBox="1"/>
-          <p:nvPr/>
-        </p:nvSpPr>
-        <p:spPr>
-          <a:xfrm>
-            <a:off x="548640" y="3108960"/>
-            <a:ext cx="5577840" cy="3200400"/>
-          </a:xfrm>
-          <a:prstGeom prst="rect">
-            <a:avLst/>
-          </a:prstGeom>
-          <a:noFill/>
-        </p:spPr>
-        <p:txBody>
-          <a:bodyPr wrap="square">
+          <a:bodyPr wrap="square" anchor="ctr">
             <a:spAutoFit/>
           </a:bodyPr>
           <a:lstStyle/>
@@ -9432,7 +9167,57 @@
                 </a:solidFill>
                 <a:latin typeface="Calibri"/>
               </a:rPr>
-              <a:t>Resizing: ~2.2 µs per lookup — flat, 1k → 100k</a:t>
+              <a:t>Catalogs of 1k → 100k products, 20k-order streams</a:t>
+            </a:r>
+          </a:p>
+          <a:p>
+            <a:pPr algn="l" marL="530352" indent="-182880">
+              <a:lnSpc>
+                <a:spcPct val="104000"/>
+              </a:lnSpc>
+              <a:spcAft>
+                <a:spcPts val="800"/>
+              </a:spcAft>
+              <a:buClr>
+                <a:srgbClr val="8A8984"/>
+              </a:buClr>
+              <a:buSzPct val="82000"/>
+              <a:buFont typeface="Calibri"/>
+              <a:buChar char="–"/>
+            </a:pPr>
+            <a:r>
+              <a:rPr sz="1700">
+                <a:solidFill>
+                  <a:srgbClr val="3A3F4A"/>
+                </a:solidFill>
+                <a:latin typeface="Calibri"/>
+              </a:rPr>
+              <a:t>Realistic names (shared prefixes) — the trie earns nothing from random strings</a:t>
+            </a:r>
+          </a:p>
+          <a:p>
+            <a:pPr algn="l" marL="530352" indent="-182880">
+              <a:lnSpc>
+                <a:spcPct val="104000"/>
+              </a:lnSpc>
+              <a:spcAft>
+                <a:spcPts val="800"/>
+              </a:spcAft>
+              <a:buClr>
+                <a:srgbClr val="8A8984"/>
+              </a:buClr>
+              <a:buSzPct val="82000"/>
+              <a:buFont typeface="Calibri"/>
+              <a:buChar char="–"/>
+            </a:pPr>
+            <a:r>
+              <a:rPr sz="1700">
+                <a:solidFill>
+                  <a:srgbClr val="3A3F4A"/>
+                </a:solidFill>
+                <a:latin typeface="Calibri"/>
+              </a:rPr>
+              <a:t>Quadratic popularity skew — hub products emerge, like real stores</a:t>
             </a:r>
           </a:p>
           <a:p>
@@ -9457,7 +9242,32 @@
                 </a:solidFill>
                 <a:latin typeface="Calibri"/>
               </a:rPr>
-              <a:t>Fixed 1,024 buckets: degrades to 10.1 µs</a:t>
+              <a:t>Best-of-5 timings (perf_counter), peak memory (tracemalloc)</a:t>
+            </a:r>
+          </a:p>
+          <a:p>
+            <a:pPr algn="l" marL="256032" indent="-256032">
+              <a:lnSpc>
+                <a:spcPct val="104000"/>
+              </a:lnSpc>
+              <a:spcAft>
+                <a:spcPts val="1200"/>
+              </a:spcAft>
+              <a:buClr>
+                <a:srgbClr val="2C7BB6"/>
+              </a:buClr>
+              <a:buSzPct val="82000"/>
+              <a:buFont typeface="Arial"/>
+              <a:buChar char="▪"/>
+            </a:pPr>
+            <a:r>
+              <a:rPr sz="2000">
+                <a:solidFill>
+                  <a:srgbClr val="3A3F4A"/>
+                </a:solidFill>
+                <a:latin typeface="Calibri"/>
+              </a:rPr>
+              <a:t>Every structure measured against a naive baseline</a:t>
             </a:r>
           </a:p>
           <a:p>
@@ -9482,68 +9292,14 @@
                 </a:solidFill>
                 <a:latin typeface="Calibri"/>
               </a:rPr>
-              <a:t>max collision chain reaches 111 entries</a:t>
-            </a:r>
-          </a:p>
-          <a:p>
-            <a:pPr algn="l" marL="256032" indent="-256032">
-              <a:lnSpc>
-                <a:spcPct val="104000"/>
-              </a:lnSpc>
-              <a:spcAft>
-                <a:spcPts val="1200"/>
-              </a:spcAft>
-              <a:buClr>
-                <a:srgbClr val="2C7BB6"/>
-              </a:buClr>
-              <a:buSzPct val="82000"/>
-              <a:buFont typeface="Arial"/>
-              <a:buChar char="▪"/>
-            </a:pPr>
-            <a:r>
-              <a:rPr sz="2000">
-                <a:solidFill>
-                  <a:srgbClr val="3A3F4A"/>
-                </a:solidFill>
-                <a:latin typeface="Calibri"/>
-              </a:rPr>
-              <a:t>The O(n/m) arithmetic of chained hashing, made visible</a:t>
-            </a:r>
-          </a:p>
-        </p:txBody>
-      </p:sp>
-      <p:pic>
-        <p:nvPicPr>
-          <p:cNvPr id="13" name="Picture 12" descr="chart_catalog_lookup.png"/>
-          <p:cNvPicPr>
-            <a:picLocks noChangeAspect="1"/>
-          </p:cNvPicPr>
-          <p:nvPr/>
-        </p:nvPicPr>
-        <p:blipFill>
-          <a:blip r:embed="rId2"/>
-          <a:stretch>
-            <a:fillRect/>
-          </a:stretch>
-        </p:blipFill>
-        <p:spPr>
-          <a:xfrm>
-            <a:off x="6309360" y="2063931"/>
-            <a:ext cx="5669280" cy="3644537"/>
-          </a:xfrm>
-          <a:prstGeom prst="rect">
-            <a:avLst/>
-          </a:prstGeom>
-          <a:ln w="12700">
-            <a:solidFill>
-              <a:srgbClr val="DCE0E8"/>
-            </a:solidFill>
-          </a:ln>
-        </p:spPr>
-      </p:pic>
-      <p:sp>
-        <p:nvSpPr>
-          <p:cNvPr id="14" name="Rectangle 13"/>
+              <a:t>fixed-capacity hashing, linear scans, full sorts</a:t>
+            </a:r>
+          </a:p>
+        </p:txBody>
+      </p:sp>
+      <p:sp>
+        <p:nvSpPr>
+          <p:cNvPr id="12" name="Rectangle 11"/>
           <p:cNvSpPr/>
           <p:nvPr/>
         </p:nvSpPr>
@@ -9587,7 +9343,7 @@
       </p:sp>
       <p:sp>
         <p:nvSpPr>
-          <p:cNvPr id="15" name="TextBox 14"/>
+          <p:cNvPr id="13" name="TextBox 12"/>
           <p:cNvSpPr txBox="1"/>
           <p:nvPr/>
         </p:nvSpPr>
@@ -9623,7 +9379,7 @@
       </p:sp>
       <p:sp>
         <p:nvSpPr>
-          <p:cNvPr id="16" name="TextBox 15"/>
+          <p:cNvPr id="14" name="TextBox 13"/>
           <p:cNvSpPr txBox="1"/>
           <p:nvPr/>
         </p:nvSpPr>
@@ -9749,7 +9505,7 @@
               </a:defRPr>
             </a:pPr>
             <a:r>
-              <a:t>Result: The Trie Wins by 45×</a:t>
+              <a:t>Result: Resizing Keeps Lookups Flat</a:t>
             </a:r>
           </a:p>
         </p:txBody>
@@ -10093,7 +9849,7 @@
               </a:defRPr>
             </a:pPr>
             <a:r>
-              <a:t>45×</a:t>
+              <a:t>4.6×</a:t>
             </a:r>
           </a:p>
           <a:p>
@@ -10106,7 +9862,7 @@
               </a:defRPr>
             </a:pPr>
             <a:r>
-              <a:t>faster prefix search than a linear scan at 100k products</a:t>
+              <a:t>faster lookups with load-factor resizing than a fixed-capacity table at 100k products</a:t>
             </a:r>
           </a:p>
         </p:txBody>
@@ -10154,7 +9910,7 @@
                 </a:solidFill>
                 <a:latin typeface="Calibri"/>
               </a:rPr>
-              <a:t>Linear name scan: 82 ms per query at 100k products</a:t>
+              <a:t>Resizing: ~2.2 µs per lookup — flat, 1k → 100k</a:t>
             </a:r>
           </a:p>
           <a:p>
@@ -10179,7 +9935,7 @@
                 </a:solidFill>
                 <a:latin typeface="Calibri"/>
               </a:rPr>
-              <a:t>Trie prefix walk: 1.83 ms — 45× faster</a:t>
+              <a:t>Fixed 1,024 buckets: degrades to 10.1 µs</a:t>
             </a:r>
           </a:p>
           <a:p>
@@ -10204,7 +9960,7 @@
                 </a:solidFill>
                 <a:latin typeface="Calibri"/>
               </a:rPr>
-              <a:t>Cost depends on prefix + matches, not catalog size</a:t>
+              <a:t>max collision chain reaches 111 entries</a:t>
             </a:r>
           </a:p>
           <a:p>
@@ -10229,39 +9985,14 @@
                 </a:solidFill>
                 <a:latin typeface="Calibri"/>
               </a:rPr>
-              <a:t>Price-band query: pruned BST beats scan 5.7×</a:t>
-            </a:r>
-          </a:p>
-          <a:p>
-            <a:pPr algn="l" marL="256032" indent="-256032">
-              <a:lnSpc>
-                <a:spcPct val="104000"/>
-              </a:lnSpc>
-              <a:spcAft>
-                <a:spcPts val="1200"/>
-              </a:spcAft>
-              <a:buClr>
-                <a:srgbClr val="2C7BB6"/>
-              </a:buClr>
-              <a:buSzPct val="82000"/>
-              <a:buFont typeface="Arial"/>
-              <a:buChar char="▪"/>
-            </a:pPr>
-            <a:r>
-              <a:rPr sz="2000">
-                <a:solidFill>
-                  <a:srgbClr val="3A3F4A"/>
-                </a:solidFill>
-                <a:latin typeface="Calibri"/>
-              </a:rPr>
-              <a:t>Both gaps widen as the catalog grows</a:t>
+              <a:t>The O(n/m) arithmetic of chained hashing, made visible</a:t>
             </a:r>
           </a:p>
         </p:txBody>
       </p:sp>
       <p:pic>
         <p:nvPicPr>
-          <p:cNvPr id="13" name="Picture 12" descr="chart_search_prefix.png"/>
+          <p:cNvPr id="13" name="Picture 12" descr="chart_catalog_lookup.png"/>
           <p:cNvPicPr>
             <a:picLocks noChangeAspect="1"/>
           </p:cNvPicPr>
@@ -10496,7 +10227,7 @@
               </a:defRPr>
             </a:pPr>
             <a:r>
-              <a:t>The Honest Result: Asymptotics vs the Interpreter</a:t>
+              <a:t>Result: The Trie Wins by 45×</a:t>
             </a:r>
           </a:p>
         </p:txBody>
@@ -10817,8 +10548,8 @@
         </p:nvSpPr>
         <p:spPr>
           <a:xfrm>
-            <a:off x="548640" y="1463040"/>
-            <a:ext cx="5577840" cy="4846320"/>
+            <a:off x="548640" y="1572768"/>
+            <a:ext cx="5577840" cy="1463040"/>
           </a:xfrm>
           <a:prstGeom prst="rect">
             <a:avLst/>
@@ -10826,7 +10557,56 @@
           <a:noFill/>
         </p:spPr>
         <p:txBody>
-          <a:bodyPr wrap="square" anchor="ctr">
+          <a:bodyPr wrap="square">
+            <a:spAutoFit/>
+          </a:bodyPr>
+          <a:lstStyle/>
+          <a:p>
+            <a:pPr algn="l">
+              <a:defRPr sz="5200" b="1">
+                <a:solidFill>
+                  <a:srgbClr val="2C7BB6"/>
+                </a:solidFill>
+                <a:latin typeface="Calibri"/>
+              </a:defRPr>
+            </a:pPr>
+            <a:r>
+              <a:t>45×</a:t>
+            </a:r>
+          </a:p>
+          <a:p>
+            <a:pPr algn="l">
+              <a:defRPr sz="1400">
+                <a:solidFill>
+                  <a:srgbClr val="8A8984"/>
+                </a:solidFill>
+                <a:latin typeface="Calibri"/>
+              </a:defRPr>
+            </a:pPr>
+            <a:r>
+              <a:t>faster prefix search than a linear scan at 100k products</a:t>
+            </a:r>
+          </a:p>
+        </p:txBody>
+      </p:sp>
+      <p:sp>
+        <p:nvSpPr>
+          <p:cNvPr id="12" name="TextBox 11"/>
+          <p:cNvSpPr txBox="1"/>
+          <p:nvPr/>
+        </p:nvSpPr>
+        <p:spPr>
+          <a:xfrm>
+            <a:off x="548640" y="3108960"/>
+            <a:ext cx="5577840" cy="3200400"/>
+          </a:xfrm>
+          <a:prstGeom prst="rect">
+            <a:avLst/>
+          </a:prstGeom>
+          <a:noFill/>
+        </p:spPr>
+        <p:txBody>
+          <a:bodyPr wrap="square">
             <a:spAutoFit/>
           </a:bodyPr>
           <a:lstStyle/>
@@ -10852,7 +10632,7 @@
                 </a:solidFill>
                 <a:latin typeface="Calibri"/>
               </a:rPr>
-              <a:t>Heap top-10: O(n + k log n) — should beat O(n log n) sort</a:t>
+              <a:t>Linear name scan: 82 ms per query at 100k products</a:t>
             </a:r>
           </a:p>
           <a:p>
@@ -10877,7 +10657,7 @@
                 </a:solidFill>
                 <a:latin typeface="Calibri"/>
               </a:rPr>
-              <a:t>Measured: pure-Python heap ≈ ties C-implemented Timsort</a:t>
+              <a:t>Trie prefix walk: 1.83 ms — 45× faster</a:t>
             </a:r>
           </a:p>
           <a:p>
@@ -10902,7 +10682,7 @@
                 </a:solidFill>
                 <a:latin typeface="Calibri"/>
               </a:rPr>
-              <a:t>every sift-down comparison runs in the interpreter</a:t>
+              <a:t>Cost depends on prefix + matches, not catalog size</a:t>
             </a:r>
           </a:p>
           <a:p>
@@ -10927,7 +10707,7 @@
                 </a:solidFill>
                 <a:latin typeface="Calibri"/>
               </a:rPr>
-              <a:t>Constant factors consumed the asymptotic advantage</a:t>
+              <a:t>Price-band query: pruned BST beats scan 5.7×</a:t>
             </a:r>
           </a:p>
           <a:p>
@@ -10952,39 +10732,14 @@
                 </a:solidFill>
                 <a:latin typeface="Calibri"/>
               </a:rPr>
-              <a:t>Heap kept for incremental updates, not cold rankings</a:t>
-            </a:r>
-          </a:p>
-          <a:p>
-            <a:pPr algn="l" marL="256032" indent="-256032">
-              <a:lnSpc>
-                <a:spcPct val="104000"/>
-              </a:lnSpc>
-              <a:spcAft>
-                <a:spcPts val="1200"/>
-              </a:spcAft>
-              <a:buClr>
-                <a:srgbClr val="2C7BB6"/>
-              </a:buClr>
-              <a:buSzPct val="82000"/>
-              <a:buFont typeface="Arial"/>
-              <a:buChar char="▪"/>
-            </a:pPr>
-            <a:r>
-              <a:rPr sz="2000">
-                <a:solidFill>
-                  <a:srgbClr val="3A3F4A"/>
-                </a:solidFill>
-                <a:latin typeface="Calibri"/>
-              </a:rPr>
-              <a:t>Lesson: measure optimizations in their environment</a:t>
+              <a:t>Both gaps widen as the catalog grows</a:t>
             </a:r>
           </a:p>
         </p:txBody>
       </p:sp>
       <p:pic>
         <p:nvPicPr>
-          <p:cNvPr id="12" name="Picture 11" descr="chart_top_k.png"/>
+          <p:cNvPr id="13" name="Picture 12" descr="chart_search_prefix.png"/>
           <p:cNvPicPr>
             <a:picLocks noChangeAspect="1"/>
           </p:cNvPicPr>
@@ -11013,7 +10768,7 @@
       </p:pic>
       <p:sp>
         <p:nvSpPr>
-          <p:cNvPr id="13" name="Rectangle 12"/>
+          <p:cNvPr id="14" name="Rectangle 13"/>
           <p:cNvSpPr/>
           <p:nvPr/>
         </p:nvSpPr>
@@ -11057,7 +10812,7 @@
       </p:sp>
       <p:sp>
         <p:nvSpPr>
-          <p:cNvPr id="14" name="TextBox 13"/>
+          <p:cNvPr id="15" name="TextBox 14"/>
           <p:cNvSpPr txBox="1"/>
           <p:nvPr/>
         </p:nvSpPr>
@@ -11093,7 +10848,7 @@
       </p:sp>
       <p:sp>
         <p:nvSpPr>
-          <p:cNvPr id="15" name="TextBox 14"/>
+          <p:cNvPr id="16" name="TextBox 15"/>
           <p:cNvSpPr txBox="1"/>
           <p:nvPr/>
         </p:nvSpPr>
@@ -11219,7 +10974,7 @@
               </a:defRPr>
             </a:pPr>
             <a:r>
-              <a:t>Stress Tests: Predicted Failures, Observed on Cue</a:t>
+              <a:t>The Honest Result: Asymptotics vs the Interpreter</a:t>
             </a:r>
           </a:p>
         </p:txBody>
@@ -11575,7 +11330,32 @@
                 </a:solidFill>
                 <a:latin typeface="Calibri"/>
               </a:rPr>
-              <a:t>Monotone price load: BST height 4,000 vs 25 (random)</a:t>
+              <a:t>Heap top-10: O(n + k log n) — should beat O(n log n) sort</a:t>
+            </a:r>
+          </a:p>
+          <a:p>
+            <a:pPr algn="l" marL="256032" indent="-256032">
+              <a:lnSpc>
+                <a:spcPct val="104000"/>
+              </a:lnSpc>
+              <a:spcAft>
+                <a:spcPts val="1200"/>
+              </a:spcAft>
+              <a:buClr>
+                <a:srgbClr val="2C7BB6"/>
+              </a:buClr>
+              <a:buSzPct val="82000"/>
+              <a:buFont typeface="Arial"/>
+              <a:buChar char="▪"/>
+            </a:pPr>
+            <a:r>
+              <a:rPr sz="2000">
+                <a:solidFill>
+                  <a:srgbClr val="3A3F4A"/>
+                </a:solidFill>
+                <a:latin typeface="Calibri"/>
+              </a:rPr>
+              <a:t>Measured: pure-Python heap ≈ ties C-implemented Timsort</a:t>
             </a:r>
           </a:p>
           <a:p>
@@ -11600,32 +11380,7 @@
                 </a:solidFill>
                 <a:latin typeface="Calibri"/>
               </a:rPr>
-              <a:t>the documented worst case, built deliberately</a:t>
-            </a:r>
-          </a:p>
-          <a:p>
-            <a:pPr algn="l" marL="530352" indent="-182880">
-              <a:lnSpc>
-                <a:spcPct val="104000"/>
-              </a:lnSpc>
-              <a:spcAft>
-                <a:spcPts val="800"/>
-              </a:spcAft>
-              <a:buClr>
-                <a:srgbClr val="8A8984"/>
-              </a:buClr>
-              <a:buSzPct val="82000"/>
-              <a:buFont typeface="Calibri"/>
-              <a:buChar char="–"/>
-            </a:pPr>
-            <a:r>
-              <a:rPr sz="1700">
-                <a:solidFill>
-                  <a:srgbClr val="3A3F4A"/>
-                </a:solidFill>
-                <a:latin typeface="Calibri"/>
-              </a:rPr>
-              <a:t>iterative traversal survives where recursion would overflow</a:t>
+              <a:t>every sift-down comparison runs in the interpreter</a:t>
             </a:r>
           </a:p>
           <a:p>
@@ -11650,32 +11405,7 @@
                 </a:solidFill>
                 <a:latin typeface="Calibri"/>
               </a:rPr>
-              <a:t>Flash-sale load: 20k orders vs 1k-product catalog</a:t>
-            </a:r>
-          </a:p>
-          <a:p>
-            <a:pPr algn="l" marL="530352" indent="-182880">
-              <a:lnSpc>
-                <a:spcPct val="104000"/>
-              </a:lnSpc>
-              <a:spcAft>
-                <a:spcPts val="800"/>
-              </a:spcAft>
-              <a:buClr>
-                <a:srgbClr val="8A8984"/>
-              </a:buClr>
-              <a:buSzPct val="82000"/>
-              <a:buFont typeface="Calibri"/>
-              <a:buChar char="–"/>
-            </a:pPr>
-            <a:r>
-              <a:rPr sz="1700">
-                <a:solidFill>
-                  <a:srgbClr val="3A3F4A"/>
-                </a:solidFill>
-                <a:latin typeface="Calibri"/>
-              </a:rPr>
-              <a:t>9,413 atomic rejections, zero corrupted line items</a:t>
+              <a:t>Constant factors consumed the asymptotic advantage</a:t>
             </a:r>
           </a:p>
           <a:p>
@@ -11700,14 +11430,39 @@
                 </a:solidFill>
                 <a:latin typeface="Calibri"/>
               </a:rPr>
-              <a:t>End to end: ~44k orders/s, ~65 MB at 100k products</a:t>
+              <a:t>Heap kept for incremental updates, not cold rankings</a:t>
+            </a:r>
+          </a:p>
+          <a:p>
+            <a:pPr algn="l" marL="256032" indent="-256032">
+              <a:lnSpc>
+                <a:spcPct val="104000"/>
+              </a:lnSpc>
+              <a:spcAft>
+                <a:spcPts val="1200"/>
+              </a:spcAft>
+              <a:buClr>
+                <a:srgbClr val="2C7BB6"/>
+              </a:buClr>
+              <a:buSzPct val="82000"/>
+              <a:buFont typeface="Arial"/>
+              <a:buChar char="▪"/>
+            </a:pPr>
+            <a:r>
+              <a:rPr sz="2000">
+                <a:solidFill>
+                  <a:srgbClr val="3A3F4A"/>
+                </a:solidFill>
+                <a:latin typeface="Calibri"/>
+              </a:rPr>
+              <a:t>Lesson: measure optimizations in their environment</a:t>
             </a:r>
           </a:p>
         </p:txBody>
       </p:sp>
       <p:pic>
         <p:nvPicPr>
-          <p:cNvPr id="12" name="Picture 11" descr="chart_bst_height.png"/>
+          <p:cNvPr id="12" name="Picture 11" descr="chart_top_k.png"/>
           <p:cNvPicPr>
             <a:picLocks noChangeAspect="1"/>
           </p:cNvPicPr>
@@ -11906,7 +11661,7 @@
                 </a:solidFill>
                 <a:latin typeface="Calibri"/>
               </a:rPr>
-              <a:t>07 · CONCLUSIONS</a:t>
+              <a:t>06 · BENCHMARKS</a:t>
             </a:r>
           </a:p>
         </p:txBody>
@@ -11942,7 +11697,7 @@
               </a:defRPr>
             </a:pPr>
             <a:r>
-              <a:t>Conclusions</a:t>
+              <a:t>Stress Tests: Predicted Failures, Observed on Cue</a:t>
             </a:r>
           </a:p>
         </p:txBody>
@@ -12264,7 +12019,7 @@
         <p:spPr>
           <a:xfrm>
             <a:off x="548640" y="1463040"/>
-            <a:ext cx="11064240" cy="4846320"/>
+            <a:ext cx="5577840" cy="4846320"/>
           </a:xfrm>
           <a:prstGeom prst="rect">
             <a:avLst/>
@@ -12298,7 +12053,57 @@
                 </a:solidFill>
                 <a:latin typeface="Calibri"/>
               </a:rPr>
-              <a:t>Composition beats generality — six specialists, one O(1) source of truth</a:t>
+              <a:t>Monotone price load: BST height 4,000 vs 25 (random)</a:t>
+            </a:r>
+          </a:p>
+          <a:p>
+            <a:pPr algn="l" marL="530352" indent="-182880">
+              <a:lnSpc>
+                <a:spcPct val="104000"/>
+              </a:lnSpc>
+              <a:spcAft>
+                <a:spcPts val="800"/>
+              </a:spcAft>
+              <a:buClr>
+                <a:srgbClr val="8A8984"/>
+              </a:buClr>
+              <a:buSzPct val="82000"/>
+              <a:buFont typeface="Calibri"/>
+              <a:buChar char="–"/>
+            </a:pPr>
+            <a:r>
+              <a:rPr sz="1700">
+                <a:solidFill>
+                  <a:srgbClr val="3A3F4A"/>
+                </a:solidFill>
+                <a:latin typeface="Calibri"/>
+              </a:rPr>
+              <a:t>the documented worst case, built deliberately</a:t>
+            </a:r>
+          </a:p>
+          <a:p>
+            <a:pPr algn="l" marL="530352" indent="-182880">
+              <a:lnSpc>
+                <a:spcPct val="104000"/>
+              </a:lnSpc>
+              <a:spcAft>
+                <a:spcPts val="800"/>
+              </a:spcAft>
+              <a:buClr>
+                <a:srgbClr val="8A8984"/>
+              </a:buClr>
+              <a:buSzPct val="82000"/>
+              <a:buFont typeface="Calibri"/>
+              <a:buChar char="–"/>
+            </a:pPr>
+            <a:r>
+              <a:rPr sz="1700">
+                <a:solidFill>
+                  <a:srgbClr val="3A3F4A"/>
+                </a:solidFill>
+                <a:latin typeface="Calibri"/>
+              </a:rPr>
+              <a:t>iterative traversal survives where recursion would overflow</a:t>
             </a:r>
           </a:p>
           <a:p>
@@ -12323,7 +12128,32 @@
                 </a:solidFill>
                 <a:latin typeface="Calibri"/>
               </a:rPr>
-              <a:t>Optimizations must be measured: resizing repaid 5×, the heap's textbook win didn't survive C vs interpreter</a:t>
+              <a:t>Flash-sale load: 20k orders vs 1k-product catalog</a:t>
+            </a:r>
+          </a:p>
+          <a:p>
+            <a:pPr algn="l" marL="530352" indent="-182880">
+              <a:lnSpc>
+                <a:spcPct val="104000"/>
+              </a:lnSpc>
+              <a:spcAft>
+                <a:spcPts val="800"/>
+              </a:spcAft>
+              <a:buClr>
+                <a:srgbClr val="8A8984"/>
+              </a:buClr>
+              <a:buSzPct val="82000"/>
+              <a:buFont typeface="Calibri"/>
+              <a:buChar char="–"/>
+            </a:pPr>
+            <a:r>
+              <a:rPr sz="1700">
+                <a:solidFill>
+                  <a:srgbClr val="3A3F4A"/>
+                </a:solidFill>
+                <a:latin typeface="Calibri"/>
+              </a:rPr>
+              <a:t>9,413 atomic rejections, zero corrupted line items</a:t>
             </a:r>
           </a:p>
           <a:p>
@@ -12348,89 +12178,43 @@
                 </a:solidFill>
                 <a:latin typeface="Calibri"/>
               </a:rPr>
-              <a:t>Worst cases written down at design time became cheap tests</a:t>
-            </a:r>
-          </a:p>
-          <a:p>
-            <a:pPr algn="l" marL="256032" indent="-256032">
-              <a:lnSpc>
-                <a:spcPct val="104000"/>
-              </a:lnSpc>
-              <a:spcAft>
-                <a:spcPts val="1200"/>
-              </a:spcAft>
-              <a:buClr>
-                <a:srgbClr val="2C7BB6"/>
-              </a:buClr>
-              <a:buSzPct val="82000"/>
-              <a:buFont typeface="Arial"/>
-              <a:buChar char="▪"/>
-            </a:pPr>
-            <a:r>
-              <a:rPr sz="2000">
-                <a:solidFill>
-                  <a:srgbClr val="3A3F4A"/>
-                </a:solidFill>
-                <a:latin typeface="Calibri"/>
-              </a:rPr>
-              <a:t>Future: self-balancing price tree, edge decay in the graph, radix-compressed trie</a:t>
-            </a:r>
-          </a:p>
-          <a:p>
-            <a:pPr algn="l" marL="256032" indent="-256032">
-              <a:lnSpc>
-                <a:spcPct val="104000"/>
-              </a:lnSpc>
-              <a:spcAft>
-                <a:spcPts val="1200"/>
-              </a:spcAft>
-              <a:buClr>
-                <a:srgbClr val="2C7BB6"/>
-              </a:buClr>
-              <a:buSzPct val="82000"/>
-              <a:buFont typeface="Arial"/>
-              <a:buChar char="▪"/>
-            </a:pPr>
-            <a:r>
-              <a:rPr sz="2000">
-                <a:solidFill>
-                  <a:srgbClr val="3A3F4A"/>
-                </a:solidFill>
-                <a:latin typeface="Calibri"/>
-              </a:rPr>
-              <a:t>Code, tests, benchmarks, data: github.com/xhon-pelushi/2026-Summer-Algorithms-and-Data-Structures-MSCS-532-M20</a:t>
-            </a:r>
-          </a:p>
-          <a:p>
-            <a:pPr algn="l" marL="256032" indent="-256032">
-              <a:lnSpc>
-                <a:spcPct val="104000"/>
-              </a:lnSpc>
-              <a:spcAft>
-                <a:spcPts val="1200"/>
-              </a:spcAft>
-              <a:buClr>
-                <a:srgbClr val="2C7BB6"/>
-              </a:buClr>
-              <a:buSzPct val="82000"/>
-              <a:buFont typeface="Arial"/>
-              <a:buChar char="▪"/>
-            </a:pPr>
-            <a:r>
-              <a:rPr sz="2000" b="1">
-                <a:solidFill>
-                  <a:srgbClr val="2C7BB6"/>
-                </a:solidFill>
-                <a:latin typeface="Calibri"/>
-              </a:rPr>
-              <a:t>Thank you — questions?</a:t>
-            </a:r>
-          </a:p>
-        </p:txBody>
-      </p:sp>
-      <p:sp>
-        <p:nvSpPr>
-          <p:cNvPr id="12" name="Rectangle 11"/>
+              <a:t>End to end: ~44k orders/s, ~65 MB at 100k products</a:t>
+            </a:r>
+          </a:p>
+        </p:txBody>
+      </p:sp>
+      <p:pic>
+        <p:nvPicPr>
+          <p:cNvPr id="12" name="Picture 11" descr="chart_bst_height.png"/>
+          <p:cNvPicPr>
+            <a:picLocks noChangeAspect="1"/>
+          </p:cNvPicPr>
+          <p:nvPr/>
+        </p:nvPicPr>
+        <p:blipFill>
+          <a:blip r:embed="rId2"/>
+          <a:stretch>
+            <a:fillRect/>
+          </a:stretch>
+        </p:blipFill>
+        <p:spPr>
+          <a:xfrm>
+            <a:off x="6309360" y="2063931"/>
+            <a:ext cx="5669280" cy="3644537"/>
+          </a:xfrm>
+          <a:prstGeom prst="rect">
+            <a:avLst/>
+          </a:prstGeom>
+          <a:ln w="12700">
+            <a:solidFill>
+              <a:srgbClr val="DCE0E8"/>
+            </a:solidFill>
+          </a:ln>
+        </p:spPr>
+      </p:pic>
+      <p:sp>
+        <p:nvSpPr>
+          <p:cNvPr id="13" name="Rectangle 12"/>
           <p:cNvSpPr/>
           <p:nvPr/>
         </p:nvSpPr>
@@ -12474,7 +12258,7 @@
       </p:sp>
       <p:sp>
         <p:nvSpPr>
-          <p:cNvPr id="13" name="TextBox 12"/>
+          <p:cNvPr id="14" name="TextBox 13"/>
           <p:cNvSpPr txBox="1"/>
           <p:nvPr/>
         </p:nvSpPr>
@@ -12510,7 +12294,7 @@
       </p:sp>
       <p:sp>
         <p:nvSpPr>
-          <p:cNvPr id="14" name="TextBox 13"/>
+          <p:cNvPr id="15" name="TextBox 14"/>
           <p:cNvSpPr txBox="1"/>
           <p:nvPr/>
         </p:nvSpPr>
@@ -13017,7 +12801,7 @@
                 </a:solidFill>
                 <a:latin typeface="Calibri"/>
               </a:rPr>
-              <a:t>types "wir…"  →  prefix match at keystroke speed</a:t>
+              <a:t>typing → prefix search</a:t>
             </a:r>
           </a:p>
           <a:p>
@@ -13042,7 +12826,7 @@
                 </a:solidFill>
                 <a:latin typeface="Calibri"/>
               </a:rPr>
-              <a:t>filters $20–$50  →  ordered range query</a:t>
+              <a:t>filtering → range query</a:t>
             </a:r>
           </a:p>
           <a:p>
@@ -13067,7 +12851,7 @@
                 </a:solidFill>
                 <a:latin typeface="Calibri"/>
               </a:rPr>
-              <a:t>"customers also bought"  →  weighted graph neighborhood</a:t>
+              <a:t>recommendations → graph traversal</a:t>
             </a:r>
           </a:p>
           <a:p>
@@ -13092,7 +12876,7 @@
                 </a:solidFill>
                 <a:latin typeface="Calibri"/>
               </a:rPr>
-              <a:t>checks out  →  exact-key lookups + FIFO fulfilment</a:t>
+              <a:t>checkout → exact lookup + FIFO</a:t>
             </a:r>
           </a:p>
           <a:p>
@@ -13117,7 +12901,7 @@
                 </a:solidFill>
                 <a:latin typeface="Calibri"/>
               </a:rPr>
-              <a:t>dashboards  →  top-k selection</a:t>
+              <a:t>dashboards → top-k/priority selection</a:t>
             </a:r>
           </a:p>
           <a:p>
@@ -13302,7 +13086,7 @@
     <p:bg>
       <p:bgPr>
         <a:solidFill>
-          <a:srgbClr val="1F2A44"/>
+          <a:srgbClr val="FCFCFB"/>
         </a:solidFill>
         <a:effectLst/>
       </p:bgPr>
@@ -13322,8 +13106,8 @@
         </p:nvSpPr>
         <p:spPr>
           <a:xfrm>
-            <a:off x="914400" y="2331720"/>
-            <a:ext cx="10360152" cy="1280160"/>
+            <a:off x="566928" y="310896"/>
+            <a:ext cx="8046720" cy="274320"/>
           </a:xfrm>
           <a:prstGeom prst="rect">
             <a:avLst/>
@@ -13336,30 +13120,109 @@
           </a:bodyPr>
           <a:lstStyle/>
           <a:p>
-            <a:pPr algn="ctr">
-              <a:defRPr sz="6600" b="1">
-                <a:solidFill>
-                  <a:srgbClr val="FFFFFF"/>
+            <a:pPr algn="l"/>
+            <a:r>
+              <a:rPr sz="1150" b="1" spc="160">
+                <a:solidFill>
+                  <a:srgbClr val="6B7A99"/>
+                </a:solidFill>
+                <a:latin typeface="Calibri"/>
+              </a:rPr>
+              <a:t>07 · CONCLUSIONS</a:t>
+            </a:r>
+          </a:p>
+        </p:txBody>
+      </p:sp>
+      <p:sp>
+        <p:nvSpPr>
+          <p:cNvPr id="3" name="TextBox 2"/>
+          <p:cNvSpPr txBox="1"/>
+          <p:nvPr/>
+        </p:nvSpPr>
+        <p:spPr>
+          <a:xfrm>
+            <a:off x="548640" y="530352"/>
+            <a:ext cx="11064240" cy="685800"/>
+          </a:xfrm>
+          <a:prstGeom prst="rect">
+            <a:avLst/>
+          </a:prstGeom>
+          <a:noFill/>
+        </p:spPr>
+        <p:txBody>
+          <a:bodyPr wrap="square">
+            <a:spAutoFit/>
+          </a:bodyPr>
+          <a:lstStyle/>
+          <a:p>
+            <a:pPr algn="l">
+              <a:defRPr sz="2900" b="1">
+                <a:solidFill>
+                  <a:srgbClr val="1F2A44"/>
                 </a:solidFill>
                 <a:latin typeface="Calibri"/>
               </a:defRPr>
             </a:pPr>
             <a:r>
-              <a:t>Demo time!</a:t>
-            </a:r>
-          </a:p>
-        </p:txBody>
-      </p:sp>
-      <p:sp>
-        <p:nvSpPr>
-          <p:cNvPr id="3" name="Rectangle 2"/>
+              <a:t>Conclusions</a:t>
+            </a:r>
+          </a:p>
+        </p:txBody>
+      </p:sp>
+      <p:sp>
+        <p:nvSpPr>
+          <p:cNvPr id="4" name="Rectangle 3"/>
           <p:cNvSpPr/>
           <p:nvPr/>
         </p:nvSpPr>
         <p:spPr>
           <a:xfrm>
-            <a:off x="4724247" y="3794760"/>
-            <a:ext cx="457200" cy="64008"/>
+            <a:off x="548640" y="1243584"/>
+            <a:ext cx="11064240" cy="12801"/>
+          </a:xfrm>
+          <a:prstGeom prst="rect">
+            <a:avLst/>
+          </a:prstGeom>
+          <a:solidFill>
+            <a:srgbClr val="DCE0E8"/>
+          </a:solidFill>
+          <a:ln>
+            <a:noFill/>
+          </a:ln>
+          <a:effectLst/>
+        </p:spPr>
+        <p:style>
+          <a:lnRef idx="1">
+            <a:schemeClr val="accent1"/>
+          </a:lnRef>
+          <a:fillRef idx="3">
+            <a:schemeClr val="accent1"/>
+          </a:fillRef>
+          <a:effectRef idx="2">
+            <a:schemeClr val="accent1"/>
+          </a:effectRef>
+          <a:fontRef idx="minor">
+            <a:schemeClr val="lt1"/>
+          </a:fontRef>
+        </p:style>
+        <p:txBody>
+          <a:bodyPr rtlCol="0" anchor="ctr"/>
+          <a:lstStyle/>
+          <a:p>
+            <a:pPr algn="ctr"/>
+          </a:p>
+        </p:txBody>
+      </p:sp>
+      <p:sp>
+        <p:nvSpPr>
+          <p:cNvPr id="5" name="Rectangle 4"/>
+          <p:cNvSpPr/>
+          <p:nvPr/>
+        </p:nvSpPr>
+        <p:spPr>
+          <a:xfrm>
+            <a:off x="548640" y="1216152"/>
+            <a:ext cx="329184" cy="50292"/>
           </a:xfrm>
           <a:prstGeom prst="rect">
             <a:avLst/>
@@ -13396,14 +13259,14 @@
       </p:sp>
       <p:sp>
         <p:nvSpPr>
-          <p:cNvPr id="4" name="Rectangle 3"/>
+          <p:cNvPr id="6" name="Rectangle 5"/>
           <p:cNvSpPr/>
           <p:nvPr/>
         </p:nvSpPr>
         <p:spPr>
           <a:xfrm>
-            <a:off x="5181447" y="3794760"/>
-            <a:ext cx="457200" cy="64008"/>
+            <a:off x="877824" y="1216152"/>
+            <a:ext cx="329184" cy="50292"/>
           </a:xfrm>
           <a:prstGeom prst="rect">
             <a:avLst/>
@@ -13440,14 +13303,14 @@
       </p:sp>
       <p:sp>
         <p:nvSpPr>
-          <p:cNvPr id="5" name="Rectangle 4"/>
+          <p:cNvPr id="7" name="Rectangle 6"/>
           <p:cNvSpPr/>
           <p:nvPr/>
         </p:nvSpPr>
         <p:spPr>
           <a:xfrm>
-            <a:off x="5638647" y="3794760"/>
-            <a:ext cx="457200" cy="64008"/>
+            <a:off x="1207008" y="1216152"/>
+            <a:ext cx="329184" cy="50292"/>
           </a:xfrm>
           <a:prstGeom prst="rect">
             <a:avLst/>
@@ -13484,14 +13347,14 @@
       </p:sp>
       <p:sp>
         <p:nvSpPr>
-          <p:cNvPr id="6" name="Rectangle 5"/>
+          <p:cNvPr id="8" name="Rectangle 7"/>
           <p:cNvSpPr/>
           <p:nvPr/>
         </p:nvSpPr>
         <p:spPr>
           <a:xfrm>
-            <a:off x="6095847" y="3794760"/>
-            <a:ext cx="457200" cy="64008"/>
+            <a:off x="1536192" y="1216152"/>
+            <a:ext cx="329184" cy="50292"/>
           </a:xfrm>
           <a:prstGeom prst="rect">
             <a:avLst/>
@@ -13528,14 +13391,14 @@
       </p:sp>
       <p:sp>
         <p:nvSpPr>
-          <p:cNvPr id="7" name="Rectangle 6"/>
+          <p:cNvPr id="9" name="Rectangle 8"/>
           <p:cNvSpPr/>
           <p:nvPr/>
         </p:nvSpPr>
         <p:spPr>
           <a:xfrm>
-            <a:off x="6553047" y="3794760"/>
-            <a:ext cx="457200" cy="64008"/>
+            <a:off x="1865376" y="1216152"/>
+            <a:ext cx="329184" cy="50292"/>
           </a:xfrm>
           <a:prstGeom prst="rect">
             <a:avLst/>
@@ -13572,14 +13435,14 @@
       </p:sp>
       <p:sp>
         <p:nvSpPr>
-          <p:cNvPr id="8" name="Rectangle 7"/>
+          <p:cNvPr id="10" name="Rectangle 9"/>
           <p:cNvSpPr/>
           <p:nvPr/>
         </p:nvSpPr>
         <p:spPr>
           <a:xfrm>
-            <a:off x="7010247" y="3794760"/>
-            <a:ext cx="457200" cy="64008"/>
+            <a:off x="2194560" y="1216152"/>
+            <a:ext cx="329184" cy="50292"/>
           </a:xfrm>
           <a:prstGeom prst="rect">
             <a:avLst/>
@@ -13616,14 +13479,14 @@
       </p:sp>
       <p:sp>
         <p:nvSpPr>
-          <p:cNvPr id="9" name="TextBox 8"/>
+          <p:cNvPr id="11" name="TextBox 10"/>
           <p:cNvSpPr txBox="1"/>
           <p:nvPr/>
         </p:nvSpPr>
         <p:spPr>
           <a:xfrm>
-            <a:off x="914400" y="4069080"/>
-            <a:ext cx="10360152" cy="457200"/>
+            <a:off x="548640" y="1463040"/>
+            <a:ext cx="11064240" cy="4846320"/>
           </a:xfrm>
           <a:prstGeom prst="rect">
             <a:avLst/>
@@ -13631,28 +13494,165 @@
           <a:noFill/>
         </p:spPr>
         <p:txBody>
-          <a:bodyPr wrap="square">
+          <a:bodyPr wrap="square" anchor="ctr">
             <a:spAutoFit/>
           </a:bodyPr>
           <a:lstStyle/>
           <a:p>
-            <a:pPr algn="ctr">
-              <a:defRPr sz="1800">
-                <a:solidFill>
-                  <a:srgbClr val="9FB3D1"/>
+            <a:pPr algn="l" marL="256032" indent="-256032">
+              <a:lnSpc>
+                <a:spcPct val="104000"/>
+              </a:lnSpc>
+              <a:spcAft>
+                <a:spcPts val="1200"/>
+              </a:spcAft>
+              <a:buClr>
+                <a:srgbClr val="2C7BB6"/>
+              </a:buClr>
+              <a:buSzPct val="82000"/>
+              <a:buFont typeface="Arial"/>
+              <a:buChar char="▪"/>
+            </a:pPr>
+            <a:r>
+              <a:rPr sz="2000">
+                <a:solidFill>
+                  <a:srgbClr val="3A3F4A"/>
                 </a:solidFill>
                 <a:latin typeface="Calibri"/>
-              </a:defRPr>
+              </a:rPr>
+              <a:t>Composition beats generality — six specialists, one O(1) source of truth</a:t>
+            </a:r>
+          </a:p>
+          <a:p>
+            <a:pPr algn="l" marL="256032" indent="-256032">
+              <a:lnSpc>
+                <a:spcPct val="104000"/>
+              </a:lnSpc>
+              <a:spcAft>
+                <a:spcPts val="1200"/>
+              </a:spcAft>
+              <a:buClr>
+                <a:srgbClr val="2C7BB6"/>
+              </a:buClr>
+              <a:buSzPct val="82000"/>
+              <a:buFont typeface="Arial"/>
+              <a:buChar char="▪"/>
             </a:pPr>
             <a:r>
-              <a:t>the portal, live — http://localhost:8000</a:t>
-            </a:r>
-          </a:p>
-        </p:txBody>
-      </p:sp>
-      <p:sp>
-        <p:nvSpPr>
-          <p:cNvPr id="10" name="Rectangle 9"/>
+              <a:rPr sz="2000">
+                <a:solidFill>
+                  <a:srgbClr val="3A3F4A"/>
+                </a:solidFill>
+                <a:latin typeface="Calibri"/>
+              </a:rPr>
+              <a:t>Optimizations must be measured: resizing repaid 5×, the heap's textbook win didn't survive C vs interpreter</a:t>
+            </a:r>
+          </a:p>
+          <a:p>
+            <a:pPr algn="l" marL="256032" indent="-256032">
+              <a:lnSpc>
+                <a:spcPct val="104000"/>
+              </a:lnSpc>
+              <a:spcAft>
+                <a:spcPts val="1200"/>
+              </a:spcAft>
+              <a:buClr>
+                <a:srgbClr val="2C7BB6"/>
+              </a:buClr>
+              <a:buSzPct val="82000"/>
+              <a:buFont typeface="Arial"/>
+              <a:buChar char="▪"/>
+            </a:pPr>
+            <a:r>
+              <a:rPr sz="2000">
+                <a:solidFill>
+                  <a:srgbClr val="3A3F4A"/>
+                </a:solidFill>
+                <a:latin typeface="Calibri"/>
+              </a:rPr>
+              <a:t>Worst cases written down at design time became cheap tests</a:t>
+            </a:r>
+          </a:p>
+          <a:p>
+            <a:pPr algn="l" marL="256032" indent="-256032">
+              <a:lnSpc>
+                <a:spcPct val="104000"/>
+              </a:lnSpc>
+              <a:spcAft>
+                <a:spcPts val="1200"/>
+              </a:spcAft>
+              <a:buClr>
+                <a:srgbClr val="2C7BB6"/>
+              </a:buClr>
+              <a:buSzPct val="82000"/>
+              <a:buFont typeface="Arial"/>
+              <a:buChar char="▪"/>
+            </a:pPr>
+            <a:r>
+              <a:rPr sz="2000">
+                <a:solidFill>
+                  <a:srgbClr val="3A3F4A"/>
+                </a:solidFill>
+                <a:latin typeface="Calibri"/>
+              </a:rPr>
+              <a:t>Future: self-balancing price tree, edge decay in the graph, radix-compressed trie</a:t>
+            </a:r>
+          </a:p>
+          <a:p>
+            <a:pPr algn="l" marL="256032" indent="-256032">
+              <a:lnSpc>
+                <a:spcPct val="104000"/>
+              </a:lnSpc>
+              <a:spcAft>
+                <a:spcPts val="1200"/>
+              </a:spcAft>
+              <a:buClr>
+                <a:srgbClr val="2C7BB6"/>
+              </a:buClr>
+              <a:buSzPct val="82000"/>
+              <a:buFont typeface="Arial"/>
+              <a:buChar char="▪"/>
+            </a:pPr>
+            <a:r>
+              <a:rPr sz="2000">
+                <a:solidFill>
+                  <a:srgbClr val="3A3F4A"/>
+                </a:solidFill>
+                <a:latin typeface="Calibri"/>
+              </a:rPr>
+              <a:t>Code, tests, benchmarks, data: github.com/xhon-pelushi/2026-Summer-Algorithms-and-Data-Structures-MSCS-532-M20</a:t>
+            </a:r>
+          </a:p>
+          <a:p>
+            <a:pPr algn="l" marL="256032" indent="-256032">
+              <a:lnSpc>
+                <a:spcPct val="104000"/>
+              </a:lnSpc>
+              <a:spcAft>
+                <a:spcPts val="1200"/>
+              </a:spcAft>
+              <a:buClr>
+                <a:srgbClr val="2C7BB6"/>
+              </a:buClr>
+              <a:buSzPct val="82000"/>
+              <a:buFont typeface="Arial"/>
+              <a:buChar char="▪"/>
+            </a:pPr>
+            <a:r>
+              <a:rPr sz="2000" b="1">
+                <a:solidFill>
+                  <a:srgbClr val="2C7BB6"/>
+                </a:solidFill>
+                <a:latin typeface="Calibri"/>
+              </a:rPr>
+              <a:t>Thank you — questions?</a:t>
+            </a:r>
+          </a:p>
+        </p:txBody>
+      </p:sp>
+      <p:sp>
+        <p:nvSpPr>
+          <p:cNvPr id="12" name="Rectangle 11"/>
           <p:cNvSpPr/>
           <p:nvPr/>
         </p:nvSpPr>
@@ -13665,7 +13665,7 @@
             <a:avLst/>
           </a:prstGeom>
           <a:solidFill>
-            <a:srgbClr val="3A4A6E"/>
+            <a:srgbClr val="DCE0E8"/>
           </a:solidFill>
           <a:ln>
             <a:noFill/>
@@ -13696,7 +13696,7 @@
       </p:sp>
       <p:sp>
         <p:nvSpPr>
-          <p:cNvPr id="11" name="TextBox 10"/>
+          <p:cNvPr id="13" name="TextBox 12"/>
           <p:cNvSpPr txBox="1"/>
           <p:nvPr/>
         </p:nvSpPr>
@@ -13719,7 +13719,7 @@
             <a:pPr algn="l">
               <a:defRPr sz="950">
                 <a:solidFill>
-                  <a:srgbClr val="9FB3D1"/>
+                  <a:srgbClr val="8A8984"/>
                 </a:solidFill>
                 <a:latin typeface="Calibri"/>
               </a:defRPr>
@@ -13732,7 +13732,7 @@
       </p:sp>
       <p:sp>
         <p:nvSpPr>
-          <p:cNvPr id="12" name="TextBox 11"/>
+          <p:cNvPr id="14" name="TextBox 13"/>
           <p:cNvSpPr txBox="1"/>
           <p:nvPr/>
         </p:nvSpPr>
@@ -13755,7 +13755,7 @@
             <a:pPr algn="r">
               <a:defRPr sz="950">
                 <a:solidFill>
-                  <a:srgbClr val="9FB3D1"/>
+                  <a:srgbClr val="8A8984"/>
                 </a:solidFill>
                 <a:latin typeface="Calibri"/>
               </a:defRPr>

</xml_diff>